<commit_message>
docs(deck): add 954-vs-76.5k code contrast + jjforge complexity note
Meta-story slide now shows a proportion bar: 954 lines of first-party
orchestrator (1.2%) against the ~76,500 lines of @ai-hero/sandcastle it
builds on — none of the library is counted. Proof slide notes jjforge's
real complexity (two forks + a Rust sidecar + a client, wrapping a VCS
that can't lose your work) to frame why a real test gate matters.

Co-Authored-By: Claude Opus 4.8 (1M context) <noreply@anthropic.com>
</commit_message>
<xml_diff>
--- a/sandcastle-tdd-deck.pptx
+++ b/sandcastle-tdd-deck.pptx
@@ -5675,8 +5675,8 @@
         </p:nvSpPr>
         <p:spPr>
           <a:xfrm>
-            <a:off x="822960" y="4160520"/>
-            <a:ext cx="10515600" cy="914400"/>
+            <a:off x="822960" y="4023360"/>
+            <a:ext cx="10515600" cy="457200"/>
           </a:xfrm>
           <a:prstGeom prst="rect">
             <a:avLst/>
@@ -5701,7 +5701,7 @@
               </a:spcAft>
             </a:pPr>
             <a:r>
-              <a:rPr sz="1800" b="1" i="0">
+              <a:rPr sz="1700" b="1" i="0">
                 <a:solidFill>
                   <a:srgbClr val="F8FAFC"/>
                 </a:solidFill>
@@ -5714,14 +5714,158 @@
       </p:sp>
       <p:sp>
         <p:nvSpPr>
-          <p:cNvPr id="20" name="TextBox 19"/>
+          <p:cNvPr id="20" name="Rounded Rectangle 19"/>
+          <p:cNvSpPr/>
+          <p:nvPr/>
+        </p:nvSpPr>
+        <p:spPr>
+          <a:xfrm>
+            <a:off x="822960" y="4846320"/>
+            <a:ext cx="10561320" cy="566928"/>
+          </a:xfrm>
+          <a:prstGeom prst="roundRect">
+            <a:avLst>
+              <a:gd name="adj" fmla="val 3000"/>
+            </a:avLst>
+          </a:prstGeom>
+          <a:solidFill>
+            <a:srgbClr val="1E293B"/>
+          </a:solidFill>
+          <a:ln>
+            <a:noFill/>
+          </a:ln>
+          <a:effectLst/>
+        </p:spPr>
+        <p:style>
+          <a:lnRef idx="1">
+            <a:schemeClr val="accent1"/>
+          </a:lnRef>
+          <a:fillRef idx="3">
+            <a:schemeClr val="accent1"/>
+          </a:fillRef>
+          <a:effectRef idx="2">
+            <a:schemeClr val="accent1"/>
+          </a:effectRef>
+          <a:fontRef idx="minor">
+            <a:schemeClr val="lt1"/>
+          </a:fontRef>
+        </p:style>
+        <p:txBody>
+          <a:bodyPr rtlCol="0" anchor="ctr"/>
+          <a:lstStyle/>
+          <a:p>
+            <a:pPr algn="ctr"/>
+          </a:p>
+        </p:txBody>
+      </p:sp>
+      <p:sp>
+        <p:nvSpPr>
+          <p:cNvPr id="21" name="Rectangle 20"/>
+          <p:cNvSpPr/>
+          <p:nvPr/>
+        </p:nvSpPr>
+        <p:spPr>
+          <a:xfrm>
+            <a:off x="822960" y="4846320"/>
+            <a:ext cx="130083" cy="566928"/>
+          </a:xfrm>
+          <a:prstGeom prst="rect">
+            <a:avLst/>
+          </a:prstGeom>
+          <a:solidFill>
+            <a:srgbClr val="F59E0B"/>
+          </a:solidFill>
+          <a:ln>
+            <a:noFill/>
+          </a:ln>
+          <a:effectLst/>
+        </p:spPr>
+        <p:style>
+          <a:lnRef idx="1">
+            <a:schemeClr val="accent1"/>
+          </a:lnRef>
+          <a:fillRef idx="3">
+            <a:schemeClr val="accent1"/>
+          </a:fillRef>
+          <a:effectRef idx="2">
+            <a:schemeClr val="accent1"/>
+          </a:effectRef>
+          <a:fontRef idx="minor">
+            <a:schemeClr val="lt1"/>
+          </a:fontRef>
+        </p:style>
+        <p:txBody>
+          <a:bodyPr rtlCol="0" anchor="ctr"/>
+          <a:lstStyle/>
+          <a:p>
+            <a:pPr algn="ctr"/>
+          </a:p>
+        </p:txBody>
+      </p:sp>
+      <p:sp>
+        <p:nvSpPr>
+          <p:cNvPr id="22" name="TextBox 21"/>
           <p:cNvSpPr txBox="1"/>
           <p:nvPr/>
         </p:nvSpPr>
         <p:spPr>
           <a:xfrm>
-            <a:off x="822960" y="4617720"/>
-            <a:ext cx="10515600" cy="1463040"/>
+            <a:off x="1227363" y="4846320"/>
+            <a:ext cx="9974036" cy="566928"/>
+          </a:xfrm>
+          <a:prstGeom prst="rect">
+            <a:avLst/>
+          </a:prstGeom>
+          <a:noFill/>
+        </p:spPr>
+        <p:txBody>
+          <a:bodyPr wrap="square" anchor="ctr" lIns="0" rIns="0" tIns="0" bIns="0">
+            <a:spAutoFit/>
+          </a:bodyPr>
+          <a:lstStyle/>
+          <a:p>
+            <a:pPr algn="l">
+              <a:lnSpc>
+                <a:spcPct val="105000"/>
+              </a:lnSpc>
+              <a:spcBef>
+                <a:spcPts val="0"/>
+              </a:spcBef>
+              <a:spcAft>
+                <a:spcPts val="0"/>
+              </a:spcAft>
+            </a:pPr>
+            <a:r>
+              <a:rPr sz="1300" b="1" i="0">
+                <a:solidFill>
+                  <a:srgbClr val="E2E8F0"/>
+                </a:solidFill>
+                <a:latin typeface="Arial"/>
+              </a:rPr>
+              <a:t>~76,500 lines you didn't write</a:t>
+            </a:r>
+            <a:r>
+              <a:rPr sz="1200" b="0" i="0">
+                <a:solidFill>
+                  <a:srgbClr val="94A3B8"/>
+                </a:solidFill>
+                <a:latin typeface="Arial"/>
+              </a:rPr>
+              <a:t>   ·  @ai-hero/sandcastle: Docker sandboxing, the agent, session capture</a:t>
+            </a:r>
+          </a:p>
+        </p:txBody>
+      </p:sp>
+      <p:sp>
+        <p:nvSpPr>
+          <p:cNvPr id="23" name="TextBox 22"/>
+          <p:cNvSpPr txBox="1"/>
+          <p:nvPr/>
+        </p:nvSpPr>
+        <p:spPr>
+          <a:xfrm>
+            <a:off x="685800" y="4462272"/>
+            <a:ext cx="2926080" cy="320040"/>
           </a:xfrm>
           <a:prstGeom prst="rect">
             <a:avLst/>
@@ -5736,55 +5880,37 @@
           <a:p>
             <a:pPr algn="l">
               <a:lnSpc>
-                <a:spcPct val="125000"/>
-              </a:lnSpc>
-              <a:spcBef>
-                <a:spcPts val="0"/>
-              </a:spcBef>
-              <a:spcAft>
-                <a:spcPts val="0"/>
-              </a:spcAft>
-            </a:pPr>
-            <a:r>
-              <a:rPr sz="1450" b="0" i="0">
-                <a:solidFill>
-                  <a:srgbClr val="E2E8F0"/>
-                </a:solidFill>
-                <a:latin typeface="Arial"/>
-              </a:rPr>
-              <a:t>The hard parts — the sandbox, the agent, the skills, git — already exist. The work was </a:t>
-            </a:r>
-            <a:r>
-              <a:rPr sz="1450" b="1" i="0">
+                <a:spcPct val="105000"/>
+              </a:lnSpc>
+              <a:spcBef>
+                <a:spcPts val="0"/>
+              </a:spcBef>
+              <a:spcAft>
+                <a:spcPts val="0"/>
+              </a:spcAft>
+            </a:pPr>
+            <a:r>
+              <a:rPr sz="1250" b="1" i="0">
                 <a:solidFill>
                   <a:srgbClr val="F59E0B"/>
                 </a:solidFill>
                 <a:latin typeface="Arial"/>
               </a:rPr>
-              <a:t>wiring them together with the right guarantees</a:t>
-            </a:r>
-            <a:r>
-              <a:rPr sz="1450" b="0" i="0">
-                <a:solidFill>
-                  <a:srgbClr val="E2E8F0"/>
-                </a:solidFill>
-                <a:latin typeface="Arial"/>
-              </a:rPr>
-              <a:t>: who owns "done," what happens on ambiguity, how state stays isolated. That's a weekend now, and the result is a tool sharp enough to run a real backlog.</a:t>
-            </a:r>
-          </a:p>
-        </p:txBody>
-      </p:sp>
-      <p:sp>
-        <p:nvSpPr>
-          <p:cNvPr id="21" name="TextBox 20"/>
+              <a:t>954 lines — yours  ↓</a:t>
+            </a:r>
+          </a:p>
+        </p:txBody>
+      </p:sp>
+      <p:sp>
+        <p:nvSpPr>
+          <p:cNvPr id="24" name="TextBox 23"/>
           <p:cNvSpPr txBox="1"/>
           <p:nvPr/>
         </p:nvSpPr>
         <p:spPr>
           <a:xfrm>
-            <a:off x="640080" y="6419088"/>
-            <a:ext cx="7315200" cy="274320"/>
+            <a:off x="822960" y="5623560"/>
+            <a:ext cx="10515600" cy="640080"/>
           </a:xfrm>
           <a:prstGeom prst="rect">
             <a:avLst/>
@@ -5799,6 +5925,69 @@
           <a:p>
             <a:pPr algn="l">
               <a:lnSpc>
+                <a:spcPct val="115000"/>
+              </a:lnSpc>
+              <a:spcBef>
+                <a:spcPts val="0"/>
+              </a:spcBef>
+              <a:spcAft>
+                <a:spcPts val="0"/>
+              </a:spcAft>
+            </a:pPr>
+            <a:r>
+              <a:rPr sz="1500" b="0" i="0">
+                <a:solidFill>
+                  <a:srgbClr val="E2E8F0"/>
+                </a:solidFill>
+                <a:latin typeface="Arial"/>
+              </a:rPr>
+              <a:t>Your own code is </a:t>
+            </a:r>
+            <a:r>
+              <a:rPr sz="1900" b="1" i="0">
+                <a:solidFill>
+                  <a:srgbClr val="F59E0B"/>
+                </a:solidFill>
+                <a:latin typeface="Arial"/>
+              </a:rPr>
+              <a:t>1.2%</a:t>
+            </a:r>
+            <a:r>
+              <a:rPr sz="1500" b="0" i="0">
+                <a:solidFill>
+                  <a:srgbClr val="E2E8F0"/>
+                </a:solidFill>
+                <a:latin typeface="Arial"/>
+              </a:rPr>
+              <a:t> of what runs — and that 1.2% is where the entire "agents can't grade themselves" guarantee lives.</a:t>
+            </a:r>
+          </a:p>
+        </p:txBody>
+      </p:sp>
+      <p:sp>
+        <p:nvSpPr>
+          <p:cNvPr id="25" name="TextBox 24"/>
+          <p:cNvSpPr txBox="1"/>
+          <p:nvPr/>
+        </p:nvSpPr>
+        <p:spPr>
+          <a:xfrm>
+            <a:off x="640080" y="6419088"/>
+            <a:ext cx="7315200" cy="274320"/>
+          </a:xfrm>
+          <a:prstGeom prst="rect">
+            <a:avLst/>
+          </a:prstGeom>
+          <a:noFill/>
+        </p:spPr>
+        <p:txBody>
+          <a:bodyPr wrap="square" anchor="t" lIns="0" rIns="0" tIns="0" bIns="0">
+            <a:spAutoFit/>
+          </a:bodyPr>
+          <a:lstStyle/>
+          <a:p>
+            <a:pPr algn="l">
+              <a:lnSpc>
                 <a:spcPct val="105000"/>
               </a:lnSpc>
               <a:spcBef>
@@ -5822,7 +6011,7 @@
       </p:sp>
       <p:sp>
         <p:nvSpPr>
-          <p:cNvPr id="22" name="TextBox 21"/>
+          <p:cNvPr id="26" name="TextBox 25"/>
           <p:cNvSpPr txBox="1"/>
           <p:nvPr/>
         </p:nvSpPr>
@@ -6069,8 +6258,8 @@
         </p:nvSpPr>
         <p:spPr>
           <a:xfrm>
-            <a:off x="640080" y="1737360"/>
-            <a:ext cx="10881360" cy="548640"/>
+            <a:off x="640080" y="1664208"/>
+            <a:ext cx="10881360" cy="365760"/>
           </a:xfrm>
           <a:prstGeom prst="rect">
             <a:avLst/>
@@ -6085,17 +6274,17 @@
           <a:p>
             <a:pPr algn="l">
               <a:lnSpc>
-                <a:spcPct val="115000"/>
-              </a:lnSpc>
-              <a:spcBef>
-                <a:spcPts val="0"/>
-              </a:spcBef>
-              <a:spcAft>
-                <a:spcPts val="0"/>
-              </a:spcAft>
-            </a:pPr>
-            <a:r>
-              <a:rPr sz="1450" b="0" i="0">
+                <a:spcPct val="110000"/>
+              </a:lnSpc>
+              <a:spcBef>
+                <a:spcPts val="0"/>
+              </a:spcBef>
+              <a:spcAft>
+                <a:spcPts val="0"/>
+              </a:spcAft>
+            </a:pPr>
+            <a:r>
+              <a:rPr sz="1400" b="0" i="0">
                 <a:solidFill>
                   <a:srgbClr val="E2E8F0"/>
                 </a:solidFill>
@@ -6104,7 +6293,7 @@
               <a:t>Every </a:t>
             </a:r>
             <a:r>
-              <a:rPr sz="1350" b="0" i="0">
+              <a:rPr sz="1300" b="0" i="0">
                 <a:solidFill>
                   <a:srgbClr val="F59E0B"/>
                 </a:solidFill>
@@ -6113,16 +6302,16 @@
               <a:t>agent/&lt;task&gt;</a:t>
             </a:r>
             <a:r>
-              <a:rPr sz="1450" b="0" i="0">
+              <a:rPr sz="1400" b="0" i="0">
                 <a:solidFill>
                   <a:srgbClr val="E2E8F0"/>
                 </a:solidFill>
                 <a:latin typeface="Arial"/>
               </a:rPr>
-              <a:t> merge on jjforge's </a:t>
-            </a:r>
-            <a:r>
-              <a:rPr sz="1350" b="0" i="0">
+              <a:t> merge on </a:t>
+            </a:r>
+            <a:r>
+              <a:rPr sz="1300" b="0" i="0">
                 <a:solidFill>
                   <a:srgbClr val="38BDF8"/>
                 </a:solidFill>
@@ -6131,7 +6320,7 @@
               <a:t>develop</a:t>
             </a:r>
             <a:r>
-              <a:rPr sz="1450" b="0" i="0">
+              <a:rPr sz="1400" b="0" i="0">
                 <a:solidFill>
                   <a:srgbClr val="E2E8F0"/>
                 </a:solidFill>
@@ -6140,13 +6329,13 @@
               <a:t> landed in one 3-day burst — </a:t>
             </a:r>
             <a:r>
-              <a:rPr sz="1450" b="1" i="0">
+              <a:rPr sz="1400" b="1" i="0">
                 <a:solidFill>
                   <a:srgbClr val="F8FAFC"/>
                 </a:solidFill>
                 <a:latin typeface="Arial"/>
               </a:rPr>
-              <a:t>that starts the day sandcastle-tdd's first commit was written.</a:t>
+              <a:t>starting the day sandcastle-tdd was first committed.</a:t>
             </a:r>
           </a:p>
         </p:txBody>
@@ -6159,8 +6348,170 @@
         </p:nvSpPr>
         <p:spPr>
           <a:xfrm>
-            <a:off x="640080" y="2514600"/>
-            <a:ext cx="2606040" cy="1783080"/>
+            <a:off x="640080" y="2121408"/>
+            <a:ext cx="10881360" cy="566928"/>
+          </a:xfrm>
+          <a:prstGeom prst="roundRect">
+            <a:avLst>
+              <a:gd name="adj" fmla="val 5000"/>
+            </a:avLst>
+          </a:prstGeom>
+          <a:solidFill>
+            <a:srgbClr val="162133"/>
+          </a:solidFill>
+          <a:ln>
+            <a:noFill/>
+          </a:ln>
+          <a:effectLst/>
+        </p:spPr>
+        <p:style>
+          <a:lnRef idx="1">
+            <a:schemeClr val="accent1"/>
+          </a:lnRef>
+          <a:fillRef idx="3">
+            <a:schemeClr val="accent1"/>
+          </a:fillRef>
+          <a:effectRef idx="2">
+            <a:schemeClr val="accent1"/>
+          </a:effectRef>
+          <a:fontRef idx="minor">
+            <a:schemeClr val="lt1"/>
+          </a:fontRef>
+        </p:style>
+        <p:txBody>
+          <a:bodyPr rtlCol="0" anchor="ctr"/>
+          <a:lstStyle/>
+          <a:p>
+            <a:pPr algn="ctr"/>
+          </a:p>
+        </p:txBody>
+      </p:sp>
+      <p:sp>
+        <p:nvSpPr>
+          <p:cNvPr id="8" name="Rectangle 7"/>
+          <p:cNvSpPr/>
+          <p:nvPr/>
+        </p:nvSpPr>
+        <p:spPr>
+          <a:xfrm>
+            <a:off x="640080" y="2121408"/>
+            <a:ext cx="91440" cy="566928"/>
+          </a:xfrm>
+          <a:prstGeom prst="rect">
+            <a:avLst/>
+          </a:prstGeom>
+          <a:solidFill>
+            <a:srgbClr val="F59E0B"/>
+          </a:solidFill>
+          <a:ln>
+            <a:noFill/>
+          </a:ln>
+          <a:effectLst/>
+        </p:spPr>
+        <p:style>
+          <a:lnRef idx="1">
+            <a:schemeClr val="accent1"/>
+          </a:lnRef>
+          <a:fillRef idx="3">
+            <a:schemeClr val="accent1"/>
+          </a:fillRef>
+          <a:effectRef idx="2">
+            <a:schemeClr val="accent1"/>
+          </a:effectRef>
+          <a:fontRef idx="minor">
+            <a:schemeClr val="lt1"/>
+          </a:fontRef>
+        </p:style>
+        <p:txBody>
+          <a:bodyPr rtlCol="0" anchor="ctr"/>
+          <a:lstStyle/>
+          <a:p>
+            <a:pPr algn="ctr"/>
+          </a:p>
+        </p:txBody>
+      </p:sp>
+      <p:sp>
+        <p:nvSpPr>
+          <p:cNvPr id="9" name="TextBox 8"/>
+          <p:cNvSpPr txBox="1"/>
+          <p:nvPr/>
+        </p:nvSpPr>
+        <p:spPr>
+          <a:xfrm>
+            <a:off x="914400" y="2121408"/>
+            <a:ext cx="10424160" cy="566928"/>
+          </a:xfrm>
+          <a:prstGeom prst="rect">
+            <a:avLst/>
+          </a:prstGeom>
+          <a:noFill/>
+        </p:spPr>
+        <p:txBody>
+          <a:bodyPr wrap="square" anchor="ctr" lIns="0" rIns="0" tIns="0" bIns="0">
+            <a:spAutoFit/>
+          </a:bodyPr>
+          <a:lstStyle/>
+          <a:p>
+            <a:pPr algn="l">
+              <a:lnSpc>
+                <a:spcPct val="108000"/>
+              </a:lnSpc>
+              <a:spcBef>
+                <a:spcPts val="0"/>
+              </a:spcBef>
+              <a:spcAft>
+                <a:spcPts val="0"/>
+              </a:spcAft>
+            </a:pPr>
+            <a:r>
+              <a:rPr sz="1250" b="1" i="0">
+                <a:solidFill>
+                  <a:srgbClr val="F59E0B"/>
+                </a:solidFill>
+                <a:latin typeface="Arial"/>
+              </a:rPr>
+              <a:t>And it's not a toy target: </a:t>
+            </a:r>
+            <a:r>
+              <a:rPr sz="1250" b="0" i="0">
+                <a:solidFill>
+                  <a:srgbClr val="E2E8F0"/>
+                </a:solidFill>
+                <a:latin typeface="Arial"/>
+              </a:rPr>
+              <a:t>two forks + a Rust sidecar + a client, wrapping Jujutsu — a version-control system whose whole promise is it </a:t>
+            </a:r>
+            <a:r>
+              <a:rPr sz="1250" b="1" i="0">
+                <a:solidFill>
+                  <a:srgbClr val="F8FAFC"/>
+                </a:solidFill>
+                <a:latin typeface="Arial"/>
+              </a:rPr>
+              <a:t>can't lose your work</a:t>
+            </a:r>
+            <a:r>
+              <a:rPr sz="1250" b="0" i="0">
+                <a:solidFill>
+                  <a:srgbClr val="E2E8F0"/>
+                </a:solidFill>
+                <a:latin typeface="Arial"/>
+              </a:rPr>
+              <a:t>. Exactly where a real test gate earns its keep.</a:t>
+            </a:r>
+          </a:p>
+        </p:txBody>
+      </p:sp>
+      <p:sp>
+        <p:nvSpPr>
+          <p:cNvPr id="10" name="Rounded Rectangle 9"/>
+          <p:cNvSpPr/>
+          <p:nvPr/>
+        </p:nvSpPr>
+        <p:spPr>
+          <a:xfrm>
+            <a:off x="640080" y="2852928"/>
+            <a:ext cx="2606040" cy="1572768"/>
           </a:xfrm>
           <a:prstGeom prst="roundRect">
             <a:avLst>
@@ -6199,13 +6550,13 @@
       </p:sp>
       <p:sp>
         <p:nvSpPr>
-          <p:cNvPr id="8" name="Rectangle 7"/>
+          <p:cNvPr id="11" name="Rectangle 10"/>
           <p:cNvSpPr/>
           <p:nvPr/>
         </p:nvSpPr>
         <p:spPr>
           <a:xfrm>
-            <a:off x="640080" y="2514600"/>
+            <a:off x="640080" y="2852928"/>
             <a:ext cx="2606040" cy="109728"/>
           </a:xfrm>
           <a:prstGeom prst="rect">
@@ -6243,14 +6594,14 @@
       </p:sp>
       <p:sp>
         <p:nvSpPr>
-          <p:cNvPr id="9" name="TextBox 8"/>
+          <p:cNvPr id="12" name="TextBox 11"/>
           <p:cNvSpPr txBox="1"/>
           <p:nvPr/>
         </p:nvSpPr>
         <p:spPr>
           <a:xfrm>
-            <a:off x="640080" y="2724912"/>
-            <a:ext cx="2606040" cy="822960"/>
+            <a:off x="640080" y="3035808"/>
+            <a:ext cx="2606040" cy="777240"/>
           </a:xfrm>
           <a:prstGeom prst="rect">
             <a:avLst/>
@@ -6275,7 +6626,7 @@
               </a:spcAft>
             </a:pPr>
             <a:r>
-              <a:rPr sz="4000" b="1" i="0">
+              <a:rPr sz="3800" b="1" i="0">
                 <a:solidFill>
                   <a:srgbClr val="F59E0B"/>
                 </a:solidFill>
@@ -6288,14 +6639,14 @@
       </p:sp>
       <p:sp>
         <p:nvSpPr>
-          <p:cNvPr id="10" name="TextBox 9"/>
+          <p:cNvPr id="13" name="TextBox 12"/>
           <p:cNvSpPr txBox="1"/>
           <p:nvPr/>
         </p:nvSpPr>
         <p:spPr>
           <a:xfrm>
-            <a:off x="640080" y="3611880"/>
-            <a:ext cx="2606040" cy="640080"/>
+            <a:off x="640080" y="3840480"/>
+            <a:ext cx="2606040" cy="548640"/>
           </a:xfrm>
           <a:prstGeom prst="rect">
             <a:avLst/>
@@ -6320,7 +6671,7 @@
               </a:spcAft>
             </a:pPr>
             <a:r>
-              <a:rPr sz="1250" b="0" i="0">
+              <a:rPr sz="1200" b="0" i="0">
                 <a:solidFill>
                   <a:srgbClr val="94A3B8"/>
                 </a:solidFill>
@@ -6333,14 +6684,14 @@
       </p:sp>
       <p:sp>
         <p:nvSpPr>
-          <p:cNvPr id="11" name="Rounded Rectangle 10"/>
+          <p:cNvPr id="14" name="Rounded Rectangle 13"/>
           <p:cNvSpPr/>
           <p:nvPr/>
         </p:nvSpPr>
         <p:spPr>
           <a:xfrm>
-            <a:off x="3410711" y="2514600"/>
-            <a:ext cx="2606040" cy="1783080"/>
+            <a:off x="3410711" y="2852928"/>
+            <a:ext cx="2606040" cy="1572768"/>
           </a:xfrm>
           <a:prstGeom prst="roundRect">
             <a:avLst>
@@ -6379,13 +6730,13 @@
       </p:sp>
       <p:sp>
         <p:nvSpPr>
-          <p:cNvPr id="12" name="Rectangle 11"/>
+          <p:cNvPr id="15" name="Rectangle 14"/>
           <p:cNvSpPr/>
           <p:nvPr/>
         </p:nvSpPr>
         <p:spPr>
           <a:xfrm>
-            <a:off x="3410711" y="2514600"/>
+            <a:off x="3410711" y="2852928"/>
             <a:ext cx="2606040" cy="109728"/>
           </a:xfrm>
           <a:prstGeom prst="rect">
@@ -6423,14 +6774,14 @@
       </p:sp>
       <p:sp>
         <p:nvSpPr>
-          <p:cNvPr id="13" name="TextBox 12"/>
+          <p:cNvPr id="16" name="TextBox 15"/>
           <p:cNvSpPr txBox="1"/>
           <p:nvPr/>
         </p:nvSpPr>
         <p:spPr>
           <a:xfrm>
-            <a:off x="3410711" y="2724912"/>
-            <a:ext cx="2606040" cy="822960"/>
+            <a:off x="3410711" y="3035808"/>
+            <a:ext cx="2606040" cy="777240"/>
           </a:xfrm>
           <a:prstGeom prst="rect">
             <a:avLst/>
@@ -6455,7 +6806,7 @@
               </a:spcAft>
             </a:pPr>
             <a:r>
-              <a:rPr sz="4000" b="1" i="0">
+              <a:rPr sz="3800" b="1" i="0">
                 <a:solidFill>
                   <a:srgbClr val="38BDF8"/>
                 </a:solidFill>
@@ -6468,14 +6819,14 @@
       </p:sp>
       <p:sp>
         <p:nvSpPr>
-          <p:cNvPr id="14" name="TextBox 13"/>
+          <p:cNvPr id="17" name="TextBox 16"/>
           <p:cNvSpPr txBox="1"/>
           <p:nvPr/>
         </p:nvSpPr>
         <p:spPr>
           <a:xfrm>
-            <a:off x="3410711" y="3611880"/>
-            <a:ext cx="2606040" cy="640080"/>
+            <a:off x="3410711" y="3840480"/>
+            <a:ext cx="2606040" cy="548640"/>
           </a:xfrm>
           <a:prstGeom prst="rect">
             <a:avLst/>
@@ -6500,7 +6851,7 @@
               </a:spcAft>
             </a:pPr>
             <a:r>
-              <a:rPr sz="1250" b="0" i="0">
+              <a:rPr sz="1200" b="0" i="0">
                 <a:solidFill>
                   <a:srgbClr val="94A3B8"/>
                 </a:solidFill>
@@ -6513,14 +6864,14 @@
       </p:sp>
       <p:sp>
         <p:nvSpPr>
-          <p:cNvPr id="15" name="Rounded Rectangle 14"/>
+          <p:cNvPr id="18" name="Rounded Rectangle 17"/>
           <p:cNvSpPr/>
           <p:nvPr/>
         </p:nvSpPr>
         <p:spPr>
           <a:xfrm>
-            <a:off x="6181344" y="2514600"/>
-            <a:ext cx="2606040" cy="1783080"/>
+            <a:off x="6181344" y="2852928"/>
+            <a:ext cx="2606040" cy="1572768"/>
           </a:xfrm>
           <a:prstGeom prst="roundRect">
             <a:avLst>
@@ -6559,13 +6910,13 @@
       </p:sp>
       <p:sp>
         <p:nvSpPr>
-          <p:cNvPr id="16" name="Rectangle 15"/>
+          <p:cNvPr id="19" name="Rectangle 18"/>
           <p:cNvSpPr/>
           <p:nvPr/>
         </p:nvSpPr>
         <p:spPr>
           <a:xfrm>
-            <a:off x="6181344" y="2514600"/>
+            <a:off x="6181344" y="2852928"/>
             <a:ext cx="2606040" cy="109728"/>
           </a:xfrm>
           <a:prstGeom prst="rect">
@@ -6603,14 +6954,14 @@
       </p:sp>
       <p:sp>
         <p:nvSpPr>
-          <p:cNvPr id="17" name="TextBox 16"/>
+          <p:cNvPr id="20" name="TextBox 19"/>
           <p:cNvSpPr txBox="1"/>
           <p:nvPr/>
         </p:nvSpPr>
         <p:spPr>
           <a:xfrm>
-            <a:off x="6181344" y="2724912"/>
-            <a:ext cx="2606040" cy="822960"/>
+            <a:off x="6181344" y="3035808"/>
+            <a:ext cx="2606040" cy="777240"/>
           </a:xfrm>
           <a:prstGeom prst="rect">
             <a:avLst/>
@@ -6635,7 +6986,7 @@
               </a:spcAft>
             </a:pPr>
             <a:r>
-              <a:rPr sz="4000" b="1" i="0">
+              <a:rPr sz="3800" b="1" i="0">
                 <a:solidFill>
                   <a:srgbClr val="34D399"/>
                 </a:solidFill>
@@ -6648,14 +6999,14 @@
       </p:sp>
       <p:sp>
         <p:nvSpPr>
-          <p:cNvPr id="18" name="TextBox 17"/>
+          <p:cNvPr id="21" name="TextBox 20"/>
           <p:cNvSpPr txBox="1"/>
           <p:nvPr/>
         </p:nvSpPr>
         <p:spPr>
           <a:xfrm>
-            <a:off x="6181344" y="3611880"/>
-            <a:ext cx="2606040" cy="640080"/>
+            <a:off x="6181344" y="3840480"/>
+            <a:ext cx="2606040" cy="548640"/>
           </a:xfrm>
           <a:prstGeom prst="rect">
             <a:avLst/>
@@ -6680,7 +7031,7 @@
               </a:spcAft>
             </a:pPr>
             <a:r>
-              <a:rPr sz="1250" b="0" i="0">
+              <a:rPr sz="1200" b="0" i="0">
                 <a:solidFill>
                   <a:srgbClr val="94A3B8"/>
                 </a:solidFill>
@@ -6693,14 +7044,14 @@
       </p:sp>
       <p:sp>
         <p:nvSpPr>
-          <p:cNvPr id="19" name="Rounded Rectangle 18"/>
+          <p:cNvPr id="22" name="Rounded Rectangle 21"/>
           <p:cNvSpPr/>
           <p:nvPr/>
         </p:nvSpPr>
         <p:spPr>
           <a:xfrm>
-            <a:off x="8951976" y="2514600"/>
-            <a:ext cx="2606040" cy="1783080"/>
+            <a:off x="8951976" y="2852928"/>
+            <a:ext cx="2606040" cy="1572768"/>
           </a:xfrm>
           <a:prstGeom prst="roundRect">
             <a:avLst>
@@ -6739,13 +7090,13 @@
       </p:sp>
       <p:sp>
         <p:nvSpPr>
-          <p:cNvPr id="20" name="Rectangle 19"/>
+          <p:cNvPr id="23" name="Rectangle 22"/>
           <p:cNvSpPr/>
           <p:nvPr/>
         </p:nvSpPr>
         <p:spPr>
           <a:xfrm>
-            <a:off x="8951976" y="2514600"/>
+            <a:off x="8951976" y="2852928"/>
             <a:ext cx="2606040" cy="109728"/>
           </a:xfrm>
           <a:prstGeom prst="rect">
@@ -6783,14 +7134,14 @@
       </p:sp>
       <p:sp>
         <p:nvSpPr>
-          <p:cNvPr id="21" name="TextBox 20"/>
+          <p:cNvPr id="24" name="TextBox 23"/>
           <p:cNvSpPr txBox="1"/>
           <p:nvPr/>
         </p:nvSpPr>
         <p:spPr>
           <a:xfrm>
-            <a:off x="8951976" y="2724912"/>
-            <a:ext cx="2606040" cy="822960"/>
+            <a:off x="8951976" y="3035808"/>
+            <a:ext cx="2606040" cy="777240"/>
           </a:xfrm>
           <a:prstGeom prst="rect">
             <a:avLst/>
@@ -6815,7 +7166,7 @@
               </a:spcAft>
             </a:pPr>
             <a:r>
-              <a:rPr sz="4000" b="1" i="0">
+              <a:rPr sz="3800" b="1" i="0">
                 <a:solidFill>
                   <a:srgbClr val="C084FC"/>
                 </a:solidFill>
@@ -6828,14 +7179,14 @@
       </p:sp>
       <p:sp>
         <p:nvSpPr>
-          <p:cNvPr id="22" name="TextBox 21"/>
+          <p:cNvPr id="25" name="TextBox 24"/>
           <p:cNvSpPr txBox="1"/>
           <p:nvPr/>
         </p:nvSpPr>
         <p:spPr>
           <a:xfrm>
-            <a:off x="8951976" y="3611880"/>
-            <a:ext cx="2606040" cy="640080"/>
+            <a:off x="8951976" y="3840480"/>
+            <a:ext cx="2606040" cy="548640"/>
           </a:xfrm>
           <a:prstGeom prst="rect">
             <a:avLst/>
@@ -6860,7 +7211,7 @@
               </a:spcAft>
             </a:pPr>
             <a:r>
-              <a:rPr sz="1250" b="0" i="0">
+              <a:rPr sz="1200" b="0" i="0">
                 <a:solidFill>
                   <a:srgbClr val="94A3B8"/>
                 </a:solidFill>
@@ -6873,7 +7224,7 @@
       </p:sp>
       <p:sp>
         <p:nvSpPr>
-          <p:cNvPr id="23" name="Rounded Rectangle 22"/>
+          <p:cNvPr id="26" name="Rounded Rectangle 25"/>
           <p:cNvSpPr/>
           <p:nvPr/>
         </p:nvSpPr>
@@ -6919,7 +7270,7 @@
       </p:sp>
       <p:sp>
         <p:nvSpPr>
-          <p:cNvPr id="24" name="Rectangle 23"/>
+          <p:cNvPr id="27" name="Rectangle 26"/>
           <p:cNvSpPr/>
           <p:nvPr/>
         </p:nvSpPr>
@@ -6963,7 +7314,7 @@
       </p:sp>
       <p:sp>
         <p:nvSpPr>
-          <p:cNvPr id="25" name="TextBox 24"/>
+          <p:cNvPr id="28" name="TextBox 27"/>
           <p:cNvSpPr txBox="1"/>
           <p:nvPr/>
         </p:nvSpPr>
@@ -7030,7 +7381,7 @@
       </p:sp>
       <p:sp>
         <p:nvSpPr>
-          <p:cNvPr id="26" name="Rounded Rectangle 25"/>
+          <p:cNvPr id="29" name="Rounded Rectangle 28"/>
           <p:cNvSpPr/>
           <p:nvPr/>
         </p:nvSpPr>
@@ -7076,7 +7427,7 @@
       </p:sp>
       <p:sp>
         <p:nvSpPr>
-          <p:cNvPr id="27" name="Rectangle 26"/>
+          <p:cNvPr id="30" name="Rectangle 29"/>
           <p:cNvSpPr/>
           <p:nvPr/>
         </p:nvSpPr>
@@ -7120,7 +7471,7 @@
       </p:sp>
       <p:sp>
         <p:nvSpPr>
-          <p:cNvPr id="28" name="TextBox 27"/>
+          <p:cNvPr id="31" name="TextBox 30"/>
           <p:cNvSpPr txBox="1"/>
           <p:nvPr/>
         </p:nvSpPr>
@@ -7187,7 +7538,7 @@
       </p:sp>
       <p:sp>
         <p:nvSpPr>
-          <p:cNvPr id="29" name="TextBox 28"/>
+          <p:cNvPr id="32" name="TextBox 31"/>
           <p:cNvSpPr txBox="1"/>
           <p:nvPr/>
         </p:nvSpPr>
@@ -7232,7 +7583,7 @@
       </p:sp>
       <p:sp>
         <p:nvSpPr>
-          <p:cNvPr id="30" name="TextBox 29"/>
+          <p:cNvPr id="33" name="TextBox 32"/>
           <p:cNvSpPr txBox="1"/>
           <p:nvPr/>
         </p:nvSpPr>
@@ -7277,7 +7628,7 @@
       </p:sp>
       <p:sp>
         <p:nvSpPr>
-          <p:cNvPr id="31" name="TextBox 30"/>
+          <p:cNvPr id="34" name="TextBox 33"/>
           <p:cNvSpPr txBox="1"/>
           <p:nvPr/>
         </p:nvSpPr>

</xml_diff>

<commit_message>
docs(deck): speaker notes on every slide + component-chip complexity view
Add presenter notes to all 17 slides. Replace the jjforge prose strip
with a component-chip row showing the four real parts of the monorepo
(Forgejo fork/Go, jj fork/Rust, sidecar/Rust, jjf CLI) plus a stakes
badge — a VCS whose job is to never lose your work — so the target's
complexity is shown, not asserted.

Co-Authored-By: Claude Opus 4.8 (1M context) <noreply@anthropic.com>
</commit_message>
<xml_diff>
--- a/sandcastle-tdd-deck.pptx
+++ b/sandcastle-tdd-deck.pptx
@@ -121,6 +121,1631 @@
     </a:lvl9pPr>
   </p:defaultTextStyle>
 </p:presentation>
+</file>
+
+<file path=ppt/notesMasters/notesMaster1.xml><?xml version="1.0" encoding="utf-8"?>
+<p:notesMaster xmlns:a="http://schemas.openxmlformats.org/drawingml/2006/main" xmlns:p="http://schemas.openxmlformats.org/presentationml/2006/main" xmlns:r="http://schemas.openxmlformats.org/officeDocument/2006/relationships">
+  <p:cSld>
+    <p:bg>
+      <p:bgRef idx="1001">
+        <a:schemeClr val="bg1"/>
+      </p:bgRef>
+    </p:bg>
+    <p:spTree>
+      <p:nvGrpSpPr>
+        <p:cNvPr id="1" name=""/>
+        <p:cNvGrpSpPr/>
+        <p:nvPr/>
+      </p:nvGrpSpPr>
+      <p:grpSpPr>
+        <a:xfrm>
+          <a:off x="0" y="0"/>
+          <a:ext cx="0" cy="0"/>
+          <a:chOff x="0" y="0"/>
+          <a:chExt cx="0" cy="0"/>
+        </a:xfrm>
+      </p:grpSpPr>
+      <p:sp>
+        <p:nvSpPr>
+          <p:cNvPr id="2" name="Header Placeholder 1"/>
+          <p:cNvSpPr>
+            <a:spLocks noGrp="1"/>
+          </p:cNvSpPr>
+          <p:nvPr>
+            <p:ph type="hdr" sz="quarter"/>
+          </p:nvPr>
+        </p:nvSpPr>
+        <p:spPr>
+          <a:xfrm>
+            <a:off x="0" y="0"/>
+            <a:ext cx="2971800" cy="457200"/>
+          </a:xfrm>
+          <a:prstGeom prst="rect">
+            <a:avLst/>
+          </a:prstGeom>
+        </p:spPr>
+        <p:txBody>
+          <a:bodyPr vert="horz" lIns="91440" tIns="45720" rIns="91440" bIns="45720" rtlCol="0"/>
+          <a:lstStyle>
+            <a:lvl1pPr algn="l">
+              <a:defRPr sz="1200"/>
+            </a:lvl1pPr>
+          </a:lstStyle>
+          <a:p>
+            <a:endParaRPr lang="en-US"/>
+          </a:p>
+        </p:txBody>
+      </p:sp>
+      <p:sp>
+        <p:nvSpPr>
+          <p:cNvPr id="3" name="Date Placeholder 2"/>
+          <p:cNvSpPr>
+            <a:spLocks noGrp="1"/>
+          </p:cNvSpPr>
+          <p:nvPr>
+            <p:ph type="dt" idx="1"/>
+          </p:nvPr>
+        </p:nvSpPr>
+        <p:spPr>
+          <a:xfrm>
+            <a:off x="3884613" y="0"/>
+            <a:ext cx="2971800" cy="457200"/>
+          </a:xfrm>
+          <a:prstGeom prst="rect">
+            <a:avLst/>
+          </a:prstGeom>
+        </p:spPr>
+        <p:txBody>
+          <a:bodyPr vert="horz" lIns="91440" tIns="45720" rIns="91440" bIns="45720" rtlCol="0"/>
+          <a:lstStyle>
+            <a:lvl1pPr algn="r">
+              <a:defRPr sz="1200"/>
+            </a:lvl1pPr>
+          </a:lstStyle>
+          <a:p>
+            <a:fld id="{0F89C1C7-3DCD-1040-A9CF-14679D8B5DDD}" type="datetimeFigureOut">
+              <a:rPr lang="en-US" smtClean="0"/>
+              <a:t>10/17/16</a:t>
+            </a:fld>
+            <a:endParaRPr lang="en-US"/>
+          </a:p>
+        </p:txBody>
+      </p:sp>
+      <p:sp>
+        <p:nvSpPr>
+          <p:cNvPr id="4" name="Slide Image Placeholder 3"/>
+          <p:cNvSpPr>
+            <a:spLocks noGrp="1" noRot="1" noChangeAspect="1"/>
+          </p:cNvSpPr>
+          <p:nvPr>
+            <p:ph type="sldImg" idx="2"/>
+          </p:nvPr>
+        </p:nvSpPr>
+        <p:spPr>
+          <a:xfrm>
+            <a:off x="1143000" y="685800"/>
+            <a:ext cx="4572000" cy="3429000"/>
+          </a:xfrm>
+          <a:prstGeom prst="rect">
+            <a:avLst/>
+          </a:prstGeom>
+          <a:noFill/>
+          <a:ln w="12700">
+            <a:solidFill>
+              <a:prstClr val="black"/>
+            </a:solidFill>
+          </a:ln>
+        </p:spPr>
+        <p:txBody>
+          <a:bodyPr vert="horz" lIns="91440" tIns="45720" rIns="91440" bIns="45720" rtlCol="0" anchor="ctr"/>
+          <a:lstStyle/>
+          <a:p>
+            <a:endParaRPr lang="en-US"/>
+          </a:p>
+        </p:txBody>
+      </p:sp>
+      <p:sp>
+        <p:nvSpPr>
+          <p:cNvPr id="5" name="Notes Placeholder 4"/>
+          <p:cNvSpPr>
+            <a:spLocks noGrp="1"/>
+          </p:cNvSpPr>
+          <p:nvPr>
+            <p:ph type="body" sz="quarter" idx="3"/>
+          </p:nvPr>
+        </p:nvSpPr>
+        <p:spPr>
+          <a:xfrm>
+            <a:off x="685800" y="4343400"/>
+            <a:ext cx="5486400" cy="4114800"/>
+          </a:xfrm>
+          <a:prstGeom prst="rect">
+            <a:avLst/>
+          </a:prstGeom>
+        </p:spPr>
+        <p:txBody>
+          <a:bodyPr vert="horz" lIns="91440" tIns="45720" rIns="91440" bIns="45720" rtlCol="0"/>
+          <a:lstStyle/>
+          <a:p>
+            <a:pPr lvl="0"/>
+            <a:r>
+              <a:rPr lang="en-US" smtClean="0"/>
+              <a:t>Click to edit Master text styles</a:t>
+            </a:r>
+          </a:p>
+          <a:p>
+            <a:pPr lvl="1"/>
+            <a:r>
+              <a:rPr lang="en-US" smtClean="0"/>
+              <a:t>Second level</a:t>
+            </a:r>
+          </a:p>
+          <a:p>
+            <a:pPr lvl="2"/>
+            <a:r>
+              <a:rPr lang="en-US" smtClean="0"/>
+              <a:t>Third level</a:t>
+            </a:r>
+          </a:p>
+          <a:p>
+            <a:pPr lvl="3"/>
+            <a:r>
+              <a:rPr lang="en-US" smtClean="0"/>
+              <a:t>Fourth level</a:t>
+            </a:r>
+          </a:p>
+          <a:p>
+            <a:pPr lvl="4"/>
+            <a:r>
+              <a:rPr lang="en-US" smtClean="0"/>
+              <a:t>Fifth level</a:t>
+            </a:r>
+            <a:endParaRPr lang="en-US"/>
+          </a:p>
+        </p:txBody>
+      </p:sp>
+      <p:sp>
+        <p:nvSpPr>
+          <p:cNvPr id="6" name="Footer Placeholder 5"/>
+          <p:cNvSpPr>
+            <a:spLocks noGrp="1"/>
+          </p:cNvSpPr>
+          <p:nvPr>
+            <p:ph type="ftr" sz="quarter" idx="4"/>
+          </p:nvPr>
+        </p:nvSpPr>
+        <p:spPr>
+          <a:xfrm>
+            <a:off x="0" y="8685213"/>
+            <a:ext cx="2971800" cy="457200"/>
+          </a:xfrm>
+          <a:prstGeom prst="rect">
+            <a:avLst/>
+          </a:prstGeom>
+        </p:spPr>
+        <p:txBody>
+          <a:bodyPr vert="horz" lIns="91440" tIns="45720" rIns="91440" bIns="45720" rtlCol="0" anchor="b"/>
+          <a:lstStyle>
+            <a:lvl1pPr algn="l">
+              <a:defRPr sz="1200"/>
+            </a:lvl1pPr>
+          </a:lstStyle>
+          <a:p>
+            <a:endParaRPr lang="en-US"/>
+          </a:p>
+        </p:txBody>
+      </p:sp>
+      <p:sp>
+        <p:nvSpPr>
+          <p:cNvPr id="7" name="Slide Number Placeholder 6"/>
+          <p:cNvSpPr>
+            <a:spLocks noGrp="1"/>
+          </p:cNvSpPr>
+          <p:nvPr>
+            <p:ph type="sldNum" sz="quarter" idx="5"/>
+          </p:nvPr>
+        </p:nvSpPr>
+        <p:spPr>
+          <a:xfrm>
+            <a:off x="3884613" y="8685213"/>
+            <a:ext cx="2971800" cy="457200"/>
+          </a:xfrm>
+          <a:prstGeom prst="rect">
+            <a:avLst/>
+          </a:prstGeom>
+        </p:spPr>
+        <p:txBody>
+          <a:bodyPr vert="horz" lIns="91440" tIns="45720" rIns="91440" bIns="45720" rtlCol="0" anchor="b"/>
+          <a:lstStyle>
+            <a:lvl1pPr algn="r">
+              <a:defRPr sz="1200"/>
+            </a:lvl1pPr>
+          </a:lstStyle>
+          <a:p>
+            <a:fld id="{BB5E49A5-4136-284D-997B-48E1D791AD67}" type="slidenum">
+              <a:rPr lang="en-US" smtClean="0"/>
+              <a:t>‹#›</a:t>
+            </a:fld>
+            <a:endParaRPr lang="en-US"/>
+          </a:p>
+        </p:txBody>
+      </p:sp>
+    </p:spTree>
+    <p:extLst>
+      <p:ext uri="{BB962C8B-B14F-4D97-AF65-F5344CB8AC3E}">
+        <p14:creationId xmlns:p14="http://schemas.microsoft.com/office/powerpoint/2010/main" val="2623252185"/>
+      </p:ext>
+    </p:extLst>
+  </p:cSld>
+  <p:clrMap bg1="lt1" tx1="dk1" bg2="lt2" tx2="dk2" accent1="accent1" accent2="accent2" accent3="accent3" accent4="accent4" accent5="accent5" accent6="accent6" hlink="hlink" folHlink="folHlink"/>
+  <p:notesStyle>
+    <a:lvl1pPr marL="0" algn="l" defTabSz="457200" rtl="0" eaLnBrk="1" latinLnBrk="0" hangingPunct="1">
+      <a:defRPr sz="1200" kern="1200">
+        <a:solidFill>
+          <a:schemeClr val="tx1"/>
+        </a:solidFill>
+        <a:latin typeface="+mn-lt"/>
+        <a:ea typeface="+mn-ea"/>
+        <a:cs typeface="+mn-cs"/>
+      </a:defRPr>
+    </a:lvl1pPr>
+    <a:lvl2pPr marL="457200" algn="l" defTabSz="457200" rtl="0" eaLnBrk="1" latinLnBrk="0" hangingPunct="1">
+      <a:defRPr sz="1200" kern="1200">
+        <a:solidFill>
+          <a:schemeClr val="tx1"/>
+        </a:solidFill>
+        <a:latin typeface="+mn-lt"/>
+        <a:ea typeface="+mn-ea"/>
+        <a:cs typeface="+mn-cs"/>
+      </a:defRPr>
+    </a:lvl2pPr>
+    <a:lvl3pPr marL="914400" algn="l" defTabSz="457200" rtl="0" eaLnBrk="1" latinLnBrk="0" hangingPunct="1">
+      <a:defRPr sz="1200" kern="1200">
+        <a:solidFill>
+          <a:schemeClr val="tx1"/>
+        </a:solidFill>
+        <a:latin typeface="+mn-lt"/>
+        <a:ea typeface="+mn-ea"/>
+        <a:cs typeface="+mn-cs"/>
+      </a:defRPr>
+    </a:lvl3pPr>
+    <a:lvl4pPr marL="1371600" algn="l" defTabSz="457200" rtl="0" eaLnBrk="1" latinLnBrk="0" hangingPunct="1">
+      <a:defRPr sz="1200" kern="1200">
+        <a:solidFill>
+          <a:schemeClr val="tx1"/>
+        </a:solidFill>
+        <a:latin typeface="+mn-lt"/>
+        <a:ea typeface="+mn-ea"/>
+        <a:cs typeface="+mn-cs"/>
+      </a:defRPr>
+    </a:lvl4pPr>
+    <a:lvl5pPr marL="1828800" algn="l" defTabSz="457200" rtl="0" eaLnBrk="1" latinLnBrk="0" hangingPunct="1">
+      <a:defRPr sz="1200" kern="1200">
+        <a:solidFill>
+          <a:schemeClr val="tx1"/>
+        </a:solidFill>
+        <a:latin typeface="+mn-lt"/>
+        <a:ea typeface="+mn-ea"/>
+        <a:cs typeface="+mn-cs"/>
+      </a:defRPr>
+    </a:lvl5pPr>
+    <a:lvl6pPr marL="2286000" algn="l" defTabSz="457200" rtl="0" eaLnBrk="1" latinLnBrk="0" hangingPunct="1">
+      <a:defRPr sz="1200" kern="1200">
+        <a:solidFill>
+          <a:schemeClr val="tx1"/>
+        </a:solidFill>
+        <a:latin typeface="+mn-lt"/>
+        <a:ea typeface="+mn-ea"/>
+        <a:cs typeface="+mn-cs"/>
+      </a:defRPr>
+    </a:lvl6pPr>
+    <a:lvl7pPr marL="2743200" algn="l" defTabSz="457200" rtl="0" eaLnBrk="1" latinLnBrk="0" hangingPunct="1">
+      <a:defRPr sz="1200" kern="1200">
+        <a:solidFill>
+          <a:schemeClr val="tx1"/>
+        </a:solidFill>
+        <a:latin typeface="+mn-lt"/>
+        <a:ea typeface="+mn-ea"/>
+        <a:cs typeface="+mn-cs"/>
+      </a:defRPr>
+    </a:lvl7pPr>
+    <a:lvl8pPr marL="3200400" algn="l" defTabSz="457200" rtl="0" eaLnBrk="1" latinLnBrk="0" hangingPunct="1">
+      <a:defRPr sz="1200" kern="1200">
+        <a:solidFill>
+          <a:schemeClr val="tx1"/>
+        </a:solidFill>
+        <a:latin typeface="+mn-lt"/>
+        <a:ea typeface="+mn-ea"/>
+        <a:cs typeface="+mn-cs"/>
+      </a:defRPr>
+    </a:lvl8pPr>
+    <a:lvl9pPr marL="3657600" algn="l" defTabSz="457200" rtl="0" eaLnBrk="1" latinLnBrk="0" hangingPunct="1">
+      <a:defRPr sz="1200" kern="1200">
+        <a:solidFill>
+          <a:schemeClr val="tx1"/>
+        </a:solidFill>
+        <a:latin typeface="+mn-lt"/>
+        <a:ea typeface="+mn-ea"/>
+        <a:cs typeface="+mn-cs"/>
+      </a:defRPr>
+    </a:lvl9pPr>
+  </p:notesStyle>
+</p:notesMaster>
+</file>
+
+<file path=ppt/notesSlides/notesSlide1.xml><?xml version="1.0" encoding="utf-8"?>
+<p:notes xmlns:a="http://schemas.openxmlformats.org/drawingml/2006/main" xmlns:p="http://schemas.openxmlformats.org/presentationml/2006/main" xmlns:r="http://schemas.openxmlformats.org/officeDocument/2006/relationships">
+  <p:cSld>
+    <p:spTree>
+      <p:nvGrpSpPr>
+        <p:cNvPr id="1" name=""/>
+        <p:cNvGrpSpPr/>
+        <p:nvPr/>
+      </p:nvGrpSpPr>
+      <p:grpSpPr>
+        <a:xfrm>
+          <a:off x="0" y="0"/>
+          <a:ext cx="0" cy="0"/>
+          <a:chOff x="0" y="0"/>
+          <a:chExt cx="0" cy="0"/>
+        </a:xfrm>
+      </p:grpSpPr>
+      <p:sp>
+        <p:nvSpPr>
+          <p:cNvPr id="2" name="Slide Image Placeholder 1"/>
+          <p:cNvSpPr>
+            <a:spLocks noGrp="1"/>
+          </p:cNvSpPr>
+          <p:nvPr>
+            <p:ph type="sldImg" idx="2"/>
+          </p:nvPr>
+        </p:nvSpPr>
+        <p:spPr/>
+      </p:sp>
+      <p:sp>
+        <p:nvSpPr>
+          <p:cNvPr id="3" name="Notes Placeholder 2"/>
+          <p:cNvSpPr>
+            <a:spLocks noGrp="1"/>
+          </p:cNvSpPr>
+          <p:nvPr>
+            <p:ph type="body" idx="3" sz="quarter"/>
+          </p:nvPr>
+        </p:nvSpPr>
+        <p:spPr/>
+        <p:txBody>
+          <a:bodyPr/>
+          <a:lstStyle/>
+          <a:p>
+            <a:r>
+              <a:t>Open with the frame, not the repo. Two things I want you to leave with: (1) building your own tools is now a weekend, not a quarter — so build the one you wish existed; (2) making an AI dependable is an engineering problem with real patterns, and this repo is a compact worked example of them.</a:t>
+            </a:r>
+          </a:p>
+          <a:p>
+            <a:r>
+              <a:t>This is a real tool I use to run my backlog, not a demo. ~950 lines. Let it breathe, then go to the two takeaways.</a:t>
+            </a:r>
+          </a:p>
+        </p:txBody>
+      </p:sp>
+      <p:sp>
+        <p:nvSpPr>
+          <p:cNvPr id="4" name="Slide Number Placeholder 3"/>
+          <p:cNvSpPr>
+            <a:spLocks noGrp="1"/>
+          </p:cNvSpPr>
+          <p:nvPr>
+            <p:ph type="sldNum" idx="5" sz="quarter"/>
+          </p:nvPr>
+        </p:nvSpPr>
+        <p:spPr/>
+      </p:sp>
+    </p:spTree>
+  </p:cSld>
+  <p:clrMapOvr>
+    <a:masterClrMapping/>
+  </p:clrMapOvr>
+</p:notes>
+</file>
+
+<file path=ppt/notesSlides/notesSlide10.xml><?xml version="1.0" encoding="utf-8"?>
+<p:notes xmlns:a="http://schemas.openxmlformats.org/drawingml/2006/main" xmlns:p="http://schemas.openxmlformats.org/presentationml/2006/main" xmlns:r="http://schemas.openxmlformats.org/officeDocument/2006/relationships">
+  <p:cSld>
+    <p:spTree>
+      <p:nvGrpSpPr>
+        <p:cNvPr id="1" name=""/>
+        <p:cNvGrpSpPr/>
+        <p:nvPr/>
+      </p:nvGrpSpPr>
+      <p:grpSpPr>
+        <a:xfrm>
+          <a:off x="0" y="0"/>
+          <a:ext cx="0" cy="0"/>
+          <a:chOff x="0" y="0"/>
+          <a:chExt cx="0" cy="0"/>
+        </a:xfrm>
+      </p:grpSpPr>
+      <p:sp>
+        <p:nvSpPr>
+          <p:cNvPr id="2" name="Slide Image Placeholder 1"/>
+          <p:cNvSpPr>
+            <a:spLocks noGrp="1"/>
+          </p:cNvSpPr>
+          <p:nvPr>
+            <p:ph type="sldImg" idx="2"/>
+          </p:nvPr>
+        </p:nvSpPr>
+        <p:spPr/>
+      </p:sp>
+      <p:sp>
+        <p:nvSpPr>
+          <p:cNvPr id="3" name="Notes Placeholder 2"/>
+          <p:cNvSpPr>
+            <a:spLocks noGrp="1"/>
+          </p:cNvSpPr>
+          <p:nvPr>
+            <p:ph type="body" idx="3" sz="quarter"/>
+          </p:nvPr>
+        </p:nvSpPr>
+        <p:spPr/>
+        <p:txBody>
+          <a:bodyPr/>
+          <a:lstStyle/>
+          <a:p>
+            <a:r>
+              <a:t>One level up from single tasks: hand the whole merge→test→next-batch chain to one command. Each quoted arg is a batch of disjoint tasks.</a:t>
+            </a:r>
+          </a:p>
+          <a:p>
+            <a:r>
+              <a:t>The clever bit is step 3: after merging a batch's green branches it re-runs the full gate on the MERGED base — catching the 'each green alone but together red' case a per-task gate structurally cannot see. And it's safe: a conflict or red merged base halts, rolls the base back, and keeps every branch. Nothing is lost.</a:t>
+            </a:r>
+          </a:p>
+        </p:txBody>
+      </p:sp>
+      <p:sp>
+        <p:nvSpPr>
+          <p:cNvPr id="4" name="Slide Number Placeholder 3"/>
+          <p:cNvSpPr>
+            <a:spLocks noGrp="1"/>
+          </p:cNvSpPr>
+          <p:nvPr>
+            <p:ph type="sldNum" idx="5" sz="quarter"/>
+          </p:nvPr>
+        </p:nvSpPr>
+        <p:spPr/>
+      </p:sp>
+    </p:spTree>
+  </p:cSld>
+  <p:clrMapOvr>
+    <a:masterClrMapping/>
+  </p:clrMapOvr>
+</p:notes>
+</file>
+
+<file path=ppt/notesSlides/notesSlide11.xml><?xml version="1.0" encoding="utf-8"?>
+<p:notes xmlns:a="http://schemas.openxmlformats.org/drawingml/2006/main" xmlns:p="http://schemas.openxmlformats.org/presentationml/2006/main" xmlns:r="http://schemas.openxmlformats.org/officeDocument/2006/relationships">
+  <p:cSld>
+    <p:spTree>
+      <p:nvGrpSpPr>
+        <p:cNvPr id="1" name=""/>
+        <p:cNvGrpSpPr/>
+        <p:nvPr/>
+      </p:nvGrpSpPr>
+      <p:grpSpPr>
+        <a:xfrm>
+          <a:off x="0" y="0"/>
+          <a:ext cx="0" cy="0"/>
+          <a:chOff x="0" y="0"/>
+          <a:chExt cx="0" cy="0"/>
+        </a:xfrm>
+      </p:grpSpPr>
+      <p:sp>
+        <p:nvSpPr>
+          <p:cNvPr id="2" name="Slide Image Placeholder 1"/>
+          <p:cNvSpPr>
+            <a:spLocks noGrp="1"/>
+          </p:cNvSpPr>
+          <p:nvPr>
+            <p:ph type="sldImg" idx="2"/>
+          </p:nvPr>
+        </p:nvSpPr>
+        <p:spPr/>
+      </p:sp>
+      <p:sp>
+        <p:nvSpPr>
+          <p:cNvPr id="3" name="Notes Placeholder 2"/>
+          <p:cNvSpPr>
+            <a:spLocks noGrp="1"/>
+          </p:cNvSpPr>
+          <p:nvPr>
+            <p:ph type="body" idx="3" sz="quarter"/>
+          </p:nvPr>
+        </p:nvSpPr>
+        <p:spPr/>
+        <p:txBody>
+          <a:bodyPr/>
+          <a:lstStyle/>
+          <a:p>
+            <a:r>
+              <a:t>Step out and make the 'sharpen your tools' argument. ~950 lines, 2 days, no framework. Then the proportion bar: that 954 is 1.2% of what actually runs — the other ~76,500 lines are @ai-hero/sandcastle (Docker sandboxing, the agent, session capture), none of it mine and none of it counted.</a:t>
+            </a:r>
+          </a:p>
+          <a:p>
+            <a:r>
+              <a:t>The point isn't 'I wrote little.' It's that the leverage is in choosing the right primitive and wiring it with the right guarantee. That 1.2% is exactly where the 'agents can't grade themselves' rule lives. Segue: does it actually work?</a:t>
+            </a:r>
+          </a:p>
+        </p:txBody>
+      </p:sp>
+      <p:sp>
+        <p:nvSpPr>
+          <p:cNvPr id="4" name="Slide Number Placeholder 3"/>
+          <p:cNvSpPr>
+            <a:spLocks noGrp="1"/>
+          </p:cNvSpPr>
+          <p:nvPr>
+            <p:ph type="sldNum" idx="5" sz="quarter"/>
+          </p:nvPr>
+        </p:nvSpPr>
+        <p:spPr/>
+      </p:sp>
+    </p:spTree>
+  </p:cSld>
+  <p:clrMapOvr>
+    <a:masterClrMapping/>
+  </p:clrMapOvr>
+</p:notes>
+</file>
+
+<file path=ppt/notesSlides/notesSlide12.xml><?xml version="1.0" encoding="utf-8"?>
+<p:notes xmlns:a="http://schemas.openxmlformats.org/drawingml/2006/main" xmlns:p="http://schemas.openxmlformats.org/presentationml/2006/main" xmlns:r="http://schemas.openxmlformats.org/officeDocument/2006/relationships">
+  <p:cSld>
+    <p:spTree>
+      <p:nvGrpSpPr>
+        <p:cNvPr id="1" name=""/>
+        <p:cNvGrpSpPr/>
+        <p:nvPr/>
+      </p:nvGrpSpPr>
+      <p:grpSpPr>
+        <a:xfrm>
+          <a:off x="0" y="0"/>
+          <a:ext cx="0" cy="0"/>
+          <a:chOff x="0" y="0"/>
+          <a:chExt cx="0" cy="0"/>
+        </a:xfrm>
+      </p:grpSpPr>
+      <p:sp>
+        <p:nvSpPr>
+          <p:cNvPr id="2" name="Slide Image Placeholder 1"/>
+          <p:cNvSpPr>
+            <a:spLocks noGrp="1"/>
+          </p:cNvSpPr>
+          <p:nvPr>
+            <p:ph type="sldImg" idx="2"/>
+          </p:nvPr>
+        </p:nvSpPr>
+        <p:spPr/>
+      </p:sp>
+      <p:sp>
+        <p:nvSpPr>
+          <p:cNvPr id="3" name="Notes Placeholder 2"/>
+          <p:cNvSpPr>
+            <a:spLocks noGrp="1"/>
+          </p:cNvSpPr>
+          <p:nvPr>
+            <p:ph type="body" idx="3" sz="quarter"/>
+          </p:nvPr>
+        </p:nvSpPr>
+        <p:spPr/>
+        <p:txBody>
+          <a:bodyPr/>
+          <a:lstStyle/>
+          <a:p>
+            <a:r>
+              <a:t>The evidence. Every agent/&lt;task&gt; merge on jjforge landed in one 3-day burst that starts the day this tool was first committed — built it and immediately shipped with it. 69 tasks merged, 184 agent commits, 43 in the peak day.</a:t>
+            </a:r>
+          </a:p>
+          <a:p>
+            <a:r>
+              <a:t>The chip row is the important context: this isn't a toy. jjforge is a four-part monorepo — a Forgejo fork (Go), a jj fork (Rust), a Rust sidecar, and a client — hosting a version-control system whose entire promise is that it can't lose your work. That's the highest-stakes place imaginable to trust a test gate, which is the whole point. (Numbers are straight from git history; be ready to show the log.)</a:t>
+            </a:r>
+          </a:p>
+        </p:txBody>
+      </p:sp>
+      <p:sp>
+        <p:nvSpPr>
+          <p:cNvPr id="4" name="Slide Number Placeholder 3"/>
+          <p:cNvSpPr>
+            <a:spLocks noGrp="1"/>
+          </p:cNvSpPr>
+          <p:nvPr>
+            <p:ph type="sldNum" idx="5" sz="quarter"/>
+          </p:nvPr>
+        </p:nvSpPr>
+        <p:spPr/>
+      </p:sp>
+    </p:spTree>
+  </p:cSld>
+  <p:clrMapOvr>
+    <a:masterClrMapping/>
+  </p:clrMapOvr>
+</p:notes>
+</file>
+
+<file path=ppt/notesSlides/notesSlide13.xml><?xml version="1.0" encoding="utf-8"?>
+<p:notes xmlns:a="http://schemas.openxmlformats.org/drawingml/2006/main" xmlns:p="http://schemas.openxmlformats.org/presentationml/2006/main" xmlns:r="http://schemas.openxmlformats.org/officeDocument/2006/relationships">
+  <p:cSld>
+    <p:spTree>
+      <p:nvGrpSpPr>
+        <p:cNvPr id="1" name=""/>
+        <p:cNvGrpSpPr/>
+        <p:nvPr/>
+      </p:nvGrpSpPr>
+      <p:grpSpPr>
+        <a:xfrm>
+          <a:off x="0" y="0"/>
+          <a:ext cx="0" cy="0"/>
+          <a:chOff x="0" y="0"/>
+          <a:chExt cx="0" cy="0"/>
+        </a:xfrm>
+      </p:grpSpPr>
+      <p:sp>
+        <p:nvSpPr>
+          <p:cNvPr id="2" name="Slide Image Placeholder 1"/>
+          <p:cNvSpPr>
+            <a:spLocks noGrp="1"/>
+          </p:cNvSpPr>
+          <p:nvPr>
+            <p:ph type="sldImg" idx="2"/>
+          </p:nvPr>
+        </p:nvSpPr>
+        <p:spPr/>
+      </p:sp>
+      <p:sp>
+        <p:nvSpPr>
+          <p:cNvPr id="3" name="Notes Placeholder 2"/>
+          <p:cNvSpPr>
+            <a:spLocks noGrp="1"/>
+          </p:cNvSpPr>
+          <p:nvPr>
+            <p:ph type="body" idx="3" sz="quarter"/>
+          </p:nvPr>
+        </p:nvSpPr>
+        <p:spPr/>
+        <p:txBody>
+          <a:bodyPr/>
+          <a:lstStyle/>
+          <a:p>
+            <a:r>
+              <a:t>How the tool stays sharp — techniques that generalise. Cheapest-failure-first: baseline runs the toolchain + every gate with NO agent, so a broken image fails for free before you spend on a model. check-contract probes the upstream library's runtime behaviour in ~1s. Warm caches took a cold gate from 2571s to 330s — measured, not guessed.</a:t>
+            </a:r>
+          </a:p>
+          <a:p>
+            <a:r>
+              <a:t>Don't read all six; pick two that resonate with this audience and move. The meta-point: sharp tools come from fast, cheap feedback loops.</a:t>
+            </a:r>
+          </a:p>
+        </p:txBody>
+      </p:sp>
+      <p:sp>
+        <p:nvSpPr>
+          <p:cNvPr id="4" name="Slide Number Placeholder 3"/>
+          <p:cNvSpPr>
+            <a:spLocks noGrp="1"/>
+          </p:cNvSpPr>
+          <p:nvPr>
+            <p:ph type="sldNum" idx="5" sz="quarter"/>
+          </p:nvPr>
+        </p:nvSpPr>
+        <p:spPr/>
+      </p:sp>
+    </p:spTree>
+  </p:cSld>
+  <p:clrMapOvr>
+    <a:masterClrMapping/>
+  </p:clrMapOvr>
+</p:notes>
+</file>
+
+<file path=ppt/notesSlides/notesSlide14.xml><?xml version="1.0" encoding="utf-8"?>
+<p:notes xmlns:a="http://schemas.openxmlformats.org/drawingml/2006/main" xmlns:p="http://schemas.openxmlformats.org/presentationml/2006/main" xmlns:r="http://schemas.openxmlformats.org/officeDocument/2006/relationships">
+  <p:cSld>
+    <p:spTree>
+      <p:nvGrpSpPr>
+        <p:cNvPr id="1" name=""/>
+        <p:cNvGrpSpPr/>
+        <p:nvPr/>
+      </p:nvGrpSpPr>
+      <p:grpSpPr>
+        <a:xfrm>
+          <a:off x="0" y="0"/>
+          <a:ext cx="0" cy="0"/>
+          <a:chOff x="0" y="0"/>
+          <a:chExt cx="0" cy="0"/>
+        </a:xfrm>
+      </p:grpSpPr>
+      <p:sp>
+        <p:nvSpPr>
+          <p:cNvPr id="2" name="Slide Image Placeholder 1"/>
+          <p:cNvSpPr>
+            <a:spLocks noGrp="1"/>
+          </p:cNvSpPr>
+          <p:nvPr>
+            <p:ph type="sldImg" idx="2"/>
+          </p:nvPr>
+        </p:nvSpPr>
+        <p:spPr/>
+      </p:sp>
+      <p:sp>
+        <p:nvSpPr>
+          <p:cNvPr id="3" name="Notes Placeholder 2"/>
+          <p:cNvSpPr>
+            <a:spLocks noGrp="1"/>
+          </p:cNvSpPr>
+          <p:nvPr>
+            <p:ph type="body" idx="3" sz="quarter"/>
+          </p:nvPr>
+        </p:nvSpPr>
+        <p:spPr/>
+        <p:txBody>
+          <a:bodyPr/>
+          <a:lstStyle/>
+          <a:p>
+            <a:r>
+              <a:t>These are scar tissue — every rule was paid for by a failed run, so I wrote it down instead of re-learning it. Call out #2 (share package caches, never build outputs — that's the 2571→330 win, and sharing a build dir silently reintroduces the lock contention containers exist to kill) and #3 (host-only env in hostEnv, not .env — GIT_CONFIG_GLOBAL leaking into the container breaks the fork's own git tests).</a:t>
+            </a:r>
+          </a:p>
+          <a:p>
+            <a:r>
+              <a:t>The transferable habit: turn each incident into a written rule. That's what 'sharpening' actually is.</a:t>
+            </a:r>
+          </a:p>
+        </p:txBody>
+      </p:sp>
+      <p:sp>
+        <p:nvSpPr>
+          <p:cNvPr id="4" name="Slide Number Placeholder 3"/>
+          <p:cNvSpPr>
+            <a:spLocks noGrp="1"/>
+          </p:cNvSpPr>
+          <p:nvPr>
+            <p:ph type="sldNum" idx="5" sz="quarter"/>
+          </p:nvPr>
+        </p:nvSpPr>
+        <p:spPr/>
+      </p:sp>
+    </p:spTree>
+  </p:cSld>
+  <p:clrMapOvr>
+    <a:masterClrMapping/>
+  </p:clrMapOvr>
+</p:notes>
+</file>
+
+<file path=ppt/notesSlides/notesSlide15.xml><?xml version="1.0" encoding="utf-8"?>
+<p:notes xmlns:a="http://schemas.openxmlformats.org/drawingml/2006/main" xmlns:p="http://schemas.openxmlformats.org/presentationml/2006/main" xmlns:r="http://schemas.openxmlformats.org/officeDocument/2006/relationships">
+  <p:cSld>
+    <p:spTree>
+      <p:nvGrpSpPr>
+        <p:cNvPr id="1" name=""/>
+        <p:cNvGrpSpPr/>
+        <p:nvPr/>
+      </p:nvGrpSpPr>
+      <p:grpSpPr>
+        <a:xfrm>
+          <a:off x="0" y="0"/>
+          <a:ext cx="0" cy="0"/>
+          <a:chOff x="0" y="0"/>
+          <a:chExt cx="0" cy="0"/>
+        </a:xfrm>
+      </p:grpSpPr>
+      <p:sp>
+        <p:nvSpPr>
+          <p:cNvPr id="2" name="Slide Image Placeholder 1"/>
+          <p:cNvSpPr>
+            <a:spLocks noGrp="1"/>
+          </p:cNvSpPr>
+          <p:nvPr>
+            <p:ph type="sldImg" idx="2"/>
+          </p:nvPr>
+        </p:nvSpPr>
+        <p:spPr/>
+      </p:sp>
+      <p:sp>
+        <p:nvSpPr>
+          <p:cNvPr id="3" name="Notes Placeholder 2"/>
+          <p:cNvSpPr>
+            <a:spLocks noGrp="1"/>
+          </p:cNvSpPr>
+          <p:nvPr>
+            <p:ph type="body" idx="3" sz="quarter"/>
+          </p:nvPr>
+        </p:nvSpPr>
+        <p:spPr/>
+        <p:txBody>
+          <a:bodyPr/>
+          <a:lstStyle/>
+          <a:p>
+            <a:r>
+              <a:t>Make the 'borrow the hard parts' point concrete. My value wasn't writing a sandbox or an agent — it was composing sandcastle + the Claude CLI + Matt's skills + git worktrees + a Telegram bot, with the right contract between them.</a:t>
+            </a:r>
+          </a:p>
+          <a:p>
+            <a:r>
+              <a:t>Tie back to the 1.2% from slide 11. The skill on display is knowing which layers already exist and refusing to rebuild them.</a:t>
+            </a:r>
+          </a:p>
+        </p:txBody>
+      </p:sp>
+      <p:sp>
+        <p:nvSpPr>
+          <p:cNvPr id="4" name="Slide Number Placeholder 3"/>
+          <p:cNvSpPr>
+            <a:spLocks noGrp="1"/>
+          </p:cNvSpPr>
+          <p:nvPr>
+            <p:ph type="sldNum" idx="5" sz="quarter"/>
+          </p:nvPr>
+        </p:nvSpPr>
+        <p:spPr/>
+      </p:sp>
+    </p:spTree>
+  </p:cSld>
+  <p:clrMapOvr>
+    <a:masterClrMapping/>
+  </p:clrMapOvr>
+</p:notes>
+</file>
+
+<file path=ppt/notesSlides/notesSlide16.xml><?xml version="1.0" encoding="utf-8"?>
+<p:notes xmlns:a="http://schemas.openxmlformats.org/drawingml/2006/main" xmlns:p="http://schemas.openxmlformats.org/presentationml/2006/main" xmlns:r="http://schemas.openxmlformats.org/officeDocument/2006/relationships">
+  <p:cSld>
+    <p:spTree>
+      <p:nvGrpSpPr>
+        <p:cNvPr id="1" name=""/>
+        <p:cNvGrpSpPr/>
+        <p:nvPr/>
+      </p:nvGrpSpPr>
+      <p:grpSpPr>
+        <a:xfrm>
+          <a:off x="0" y="0"/>
+          <a:ext cx="0" cy="0"/>
+          <a:chOff x="0" y="0"/>
+          <a:chExt cx="0" cy="0"/>
+        </a:xfrm>
+      </p:grpSpPr>
+      <p:sp>
+        <p:nvSpPr>
+          <p:cNvPr id="2" name="Slide Image Placeholder 1"/>
+          <p:cNvSpPr>
+            <a:spLocks noGrp="1"/>
+          </p:cNvSpPr>
+          <p:nvPr>
+            <p:ph type="sldImg" idx="2"/>
+          </p:nvPr>
+        </p:nvSpPr>
+        <p:spPr/>
+      </p:sp>
+      <p:sp>
+        <p:nvSpPr>
+          <p:cNvPr id="3" name="Notes Placeholder 2"/>
+          <p:cNvSpPr>
+            <a:spLocks noGrp="1"/>
+          </p:cNvSpPr>
+          <p:nvPr>
+            <p:ph type="body" idx="3" sz="quarter"/>
+          </p:nvPr>
+        </p:nvSpPr>
+        <p:spPr/>
+        <p:txBody>
+          <a:bodyPr/>
+          <a:lstStyle/>
+          <a:p>
+            <a:r>
+              <a:t>The 'steal these' slide — the part I actually want them to apply Monday. Walk the six quickly: own 'done' outside the model; give ambiguity an explicit ask-a-human path; isolate before you parallelize; persist state so failure is the next prompt not a reset; borrow the hard parts; encode every lesson once.</a:t>
+            </a:r>
+          </a:p>
+          <a:p>
+            <a:r>
+              <a:t>These are provider- and project-agnostic — they apply to anything you build on an LLM, not just coding agents.</a:t>
+            </a:r>
+          </a:p>
+        </p:txBody>
+      </p:sp>
+      <p:sp>
+        <p:nvSpPr>
+          <p:cNvPr id="4" name="Slide Number Placeholder 3"/>
+          <p:cNvSpPr>
+            <a:spLocks noGrp="1"/>
+          </p:cNvSpPr>
+          <p:nvPr>
+            <p:ph type="sldNum" idx="5" sz="quarter"/>
+          </p:nvPr>
+        </p:nvSpPr>
+        <p:spPr/>
+      </p:sp>
+    </p:spTree>
+  </p:cSld>
+  <p:clrMapOvr>
+    <a:masterClrMapping/>
+  </p:clrMapOvr>
+</p:notes>
+</file>
+
+<file path=ppt/notesSlides/notesSlide17.xml><?xml version="1.0" encoding="utf-8"?>
+<p:notes xmlns:a="http://schemas.openxmlformats.org/drawingml/2006/main" xmlns:p="http://schemas.openxmlformats.org/presentationml/2006/main" xmlns:r="http://schemas.openxmlformats.org/officeDocument/2006/relationships">
+  <p:cSld>
+    <p:spTree>
+      <p:nvGrpSpPr>
+        <p:cNvPr id="1" name=""/>
+        <p:cNvGrpSpPr/>
+        <p:nvPr/>
+      </p:nvGrpSpPr>
+      <p:grpSpPr>
+        <a:xfrm>
+          <a:off x="0" y="0"/>
+          <a:ext cx="0" cy="0"/>
+          <a:chOff x="0" y="0"/>
+          <a:chExt cx="0" cy="0"/>
+        </a:xfrm>
+      </p:grpSpPr>
+      <p:sp>
+        <p:nvSpPr>
+          <p:cNvPr id="2" name="Slide Image Placeholder 1"/>
+          <p:cNvSpPr>
+            <a:spLocks noGrp="1"/>
+          </p:cNvSpPr>
+          <p:nvPr>
+            <p:ph type="sldImg" idx="2"/>
+          </p:nvPr>
+        </p:nvSpPr>
+        <p:spPr/>
+      </p:sp>
+      <p:sp>
+        <p:nvSpPr>
+          <p:cNvPr id="3" name="Notes Placeholder 2"/>
+          <p:cNvSpPr>
+            <a:spLocks noGrp="1"/>
+          </p:cNvSpPr>
+          <p:nvPr>
+            <p:ph type="body" idx="3" sz="quarter"/>
+          </p:nvPr>
+        </p:nvSpPr>
+        <p:spPr/>
+        <p:txBody>
+          <a:bodyPr/>
+          <a:lstStyle/>
+          <a:p>
+            <a:r>
+              <a:t>Land the plane on the thesis: build the tool you wish existed. The bottleneck isn't building anymore — it's knowing what you want and giving the AI the guardrails to be dependable.</a:t>
+            </a:r>
+          </a:p>
+          <a:p>
+            <a:r>
+              <a:t>Invite them in: it's on github (jjforge/sandcastle-tdd), built on @ai-hero/sandcastle. Open for questions — and I can show a live park→answer round-trip if there's interest.</a:t>
+            </a:r>
+          </a:p>
+        </p:txBody>
+      </p:sp>
+      <p:sp>
+        <p:nvSpPr>
+          <p:cNvPr id="4" name="Slide Number Placeholder 3"/>
+          <p:cNvSpPr>
+            <a:spLocks noGrp="1"/>
+          </p:cNvSpPr>
+          <p:nvPr>
+            <p:ph type="sldNum" idx="5" sz="quarter"/>
+          </p:nvPr>
+        </p:nvSpPr>
+        <p:spPr/>
+      </p:sp>
+    </p:spTree>
+  </p:cSld>
+  <p:clrMapOvr>
+    <a:masterClrMapping/>
+  </p:clrMapOvr>
+</p:notes>
+</file>
+
+<file path=ppt/notesSlides/notesSlide2.xml><?xml version="1.0" encoding="utf-8"?>
+<p:notes xmlns:a="http://schemas.openxmlformats.org/drawingml/2006/main" xmlns:p="http://schemas.openxmlformats.org/presentationml/2006/main" xmlns:r="http://schemas.openxmlformats.org/officeDocument/2006/relationships">
+  <p:cSld>
+    <p:spTree>
+      <p:nvGrpSpPr>
+        <p:cNvPr id="1" name=""/>
+        <p:cNvGrpSpPr/>
+        <p:nvPr/>
+      </p:nvGrpSpPr>
+      <p:grpSpPr>
+        <a:xfrm>
+          <a:off x="0" y="0"/>
+          <a:ext cx="0" cy="0"/>
+          <a:chOff x="0" y="0"/>
+          <a:chExt cx="0" cy="0"/>
+        </a:xfrm>
+      </p:grpSpPr>
+      <p:sp>
+        <p:nvSpPr>
+          <p:cNvPr id="2" name="Slide Image Placeholder 1"/>
+          <p:cNvSpPr>
+            <a:spLocks noGrp="1"/>
+          </p:cNvSpPr>
+          <p:nvPr>
+            <p:ph type="sldImg" idx="2"/>
+          </p:nvPr>
+        </p:nvSpPr>
+        <p:spPr/>
+      </p:sp>
+      <p:sp>
+        <p:nvSpPr>
+          <p:cNvPr id="3" name="Notes Placeholder 2"/>
+          <p:cNvSpPr>
+            <a:spLocks noGrp="1"/>
+          </p:cNvSpPr>
+          <p:nvPr>
+            <p:ph type="body" idx="3" sz="quarter"/>
+          </p:nvPr>
+        </p:nvSpPr>
+        <p:spPr/>
+        <p:txBody>
+          <a:bodyPr/>
+          <a:lstStyle/>
+          <a:p>
+            <a:r>
+              <a:t>State the two threads explicitly so people know which one each later slide serves. Left = the meta-story (fast prototyping, sharpen your tools). Right = the transferable engineering patterns (who owns 'done', what happens on ambiguity, isolation, resume).</a:t>
+            </a:r>
+          </a:p>
+          <a:p>
+            <a:r>
+              <a:t>Line to land: the bottleneck moved from 'can I build it' to 'do I know what I want.' Everything after this hangs on one of these two hooks.</a:t>
+            </a:r>
+          </a:p>
+        </p:txBody>
+      </p:sp>
+      <p:sp>
+        <p:nvSpPr>
+          <p:cNvPr id="4" name="Slide Number Placeholder 3"/>
+          <p:cNvSpPr>
+            <a:spLocks noGrp="1"/>
+          </p:cNvSpPr>
+          <p:nvPr>
+            <p:ph type="sldNum" idx="5" sz="quarter"/>
+          </p:nvPr>
+        </p:nvSpPr>
+        <p:spPr/>
+      </p:sp>
+    </p:spTree>
+  </p:cSld>
+  <p:clrMapOvr>
+    <a:masterClrMapping/>
+  </p:clrMapOvr>
+</p:notes>
+</file>
+
+<file path=ppt/notesSlides/notesSlide3.xml><?xml version="1.0" encoding="utf-8"?>
+<p:notes xmlns:a="http://schemas.openxmlformats.org/drawingml/2006/main" xmlns:p="http://schemas.openxmlformats.org/presentationml/2006/main" xmlns:r="http://schemas.openxmlformats.org/officeDocument/2006/relationships">
+  <p:cSld>
+    <p:spTree>
+      <p:nvGrpSpPr>
+        <p:cNvPr id="1" name=""/>
+        <p:cNvGrpSpPr/>
+        <p:nvPr/>
+      </p:nvGrpSpPr>
+      <p:grpSpPr>
+        <a:xfrm>
+          <a:off x="0" y="0"/>
+          <a:ext cx="0" cy="0"/>
+          <a:chOff x="0" y="0"/>
+          <a:chExt cx="0" cy="0"/>
+        </a:xfrm>
+      </p:grpSpPr>
+      <p:sp>
+        <p:nvSpPr>
+          <p:cNvPr id="2" name="Slide Image Placeholder 1"/>
+          <p:cNvSpPr>
+            <a:spLocks noGrp="1"/>
+          </p:cNvSpPr>
+          <p:nvPr>
+            <p:ph type="sldImg" idx="2"/>
+          </p:nvPr>
+        </p:nvSpPr>
+        <p:spPr/>
+      </p:sp>
+      <p:sp>
+        <p:nvSpPr>
+          <p:cNvPr id="3" name="Notes Placeholder 2"/>
+          <p:cNvSpPr>
+            <a:spLocks noGrp="1"/>
+          </p:cNvSpPr>
+          <p:nvPr>
+            <p:ph type="body" idx="3" sz="quarter"/>
+          </p:nvPr>
+        </p:nvSpPr>
+        <p:spPr/>
+        <p:txBody>
+          <a:bodyPr/>
+          <a:lstStyle/>
+          <a:p>
+            <a:r>
+              <a:t>The one-liner. Read it almost verbatim: run your backlog as parallel agents that can't mark their own work done and ask instead of guessing. Each task gets a container, a branch, and a TDD loop the orchestrator drives.</a:t>
+            </a:r>
+          </a:p>
+          <a:p>
+            <a:r>
+              <a:t>Don't go deep here — the four cards are just a map of the next section. If someone asks 'why not just let the agent run tests itself?', park it — slide 5 answers it.</a:t>
+            </a:r>
+          </a:p>
+        </p:txBody>
+      </p:sp>
+      <p:sp>
+        <p:nvSpPr>
+          <p:cNvPr id="4" name="Slide Number Placeholder 3"/>
+          <p:cNvSpPr>
+            <a:spLocks noGrp="1"/>
+          </p:cNvSpPr>
+          <p:nvPr>
+            <p:ph type="sldNum" idx="5" sz="quarter"/>
+          </p:nvPr>
+        </p:nvSpPr>
+        <p:spPr/>
+      </p:sp>
+    </p:spTree>
+  </p:cSld>
+  <p:clrMapOvr>
+    <a:masterClrMapping/>
+  </p:clrMapOvr>
+</p:notes>
+</file>
+
+<file path=ppt/notesSlides/notesSlide4.xml><?xml version="1.0" encoding="utf-8"?>
+<p:notes xmlns:a="http://schemas.openxmlformats.org/drawingml/2006/main" xmlns:p="http://schemas.openxmlformats.org/presentationml/2006/main" xmlns:r="http://schemas.openxmlformats.org/officeDocument/2006/relationships">
+  <p:cSld>
+    <p:spTree>
+      <p:nvGrpSpPr>
+        <p:cNvPr id="1" name=""/>
+        <p:cNvGrpSpPr/>
+        <p:nvPr/>
+      </p:nvGrpSpPr>
+      <p:grpSpPr>
+        <a:xfrm>
+          <a:off x="0" y="0"/>
+          <a:ext cx="0" cy="0"/>
+          <a:chOff x="0" y="0"/>
+          <a:chExt cx="0" cy="0"/>
+        </a:xfrm>
+      </p:grpSpPr>
+      <p:sp>
+        <p:nvSpPr>
+          <p:cNvPr id="2" name="Slide Image Placeholder 1"/>
+          <p:cNvSpPr>
+            <a:spLocks noGrp="1"/>
+          </p:cNvSpPr>
+          <p:nvPr>
+            <p:ph type="sldImg" idx="2"/>
+          </p:nvPr>
+        </p:nvSpPr>
+        <p:spPr/>
+      </p:sp>
+      <p:sp>
+        <p:nvSpPr>
+          <p:cNvPr id="3" name="Notes Placeholder 2"/>
+          <p:cNvSpPr>
+            <a:spLocks noGrp="1"/>
+          </p:cNvSpPr>
+          <p:nvPr>
+            <p:ph type="body" idx="3" sz="quarter"/>
+          </p:nvPr>
+        </p:nvSpPr>
+        <p:spPr/>
+        <p:txBody>
+          <a:bodyPr/>
+          <a:lstStyle/>
+          <a:p>
+            <a:r>
+              <a:t>Motivate the design by naming the failure modes everyone in the room has hit. Get nods. The killer is the first one: agents emit 'I'm done' over a red suite — a self-report is a claim, not evidence. The other three (guessing, stepping on each other, losing context) each map directly to a design decision on the next slide.</a:t>
+            </a:r>
+          </a:p>
+          <a:p>
+            <a:r>
+              <a:t>Transition: 'so the design is really four answers to these four problems.'</a:t>
+            </a:r>
+          </a:p>
+        </p:txBody>
+      </p:sp>
+      <p:sp>
+        <p:nvSpPr>
+          <p:cNvPr id="4" name="Slide Number Placeholder 3"/>
+          <p:cNvSpPr>
+            <a:spLocks noGrp="1"/>
+          </p:cNvSpPr>
+          <p:nvPr>
+            <p:ph type="sldNum" idx="5" sz="quarter"/>
+          </p:nvPr>
+        </p:nvSpPr>
+        <p:spPr/>
+      </p:sp>
+    </p:spTree>
+  </p:cSld>
+  <p:clrMapOvr>
+    <a:masterClrMapping/>
+  </p:clrMapOvr>
+</p:notes>
+</file>
+
+<file path=ppt/notesSlides/notesSlide5.xml><?xml version="1.0" encoding="utf-8"?>
+<p:notes xmlns:a="http://schemas.openxmlformats.org/drawingml/2006/main" xmlns:p="http://schemas.openxmlformats.org/presentationml/2006/main" xmlns:r="http://schemas.openxmlformats.org/officeDocument/2006/relationships">
+  <p:cSld>
+    <p:spTree>
+      <p:nvGrpSpPr>
+        <p:cNvPr id="1" name=""/>
+        <p:cNvGrpSpPr/>
+        <p:nvPr/>
+      </p:nvGrpSpPr>
+      <p:grpSpPr>
+        <a:xfrm>
+          <a:off x="0" y="0"/>
+          <a:ext cx="0" cy="0"/>
+          <a:chOff x="0" y="0"/>
+          <a:chExt cx="0" cy="0"/>
+        </a:xfrm>
+      </p:grpSpPr>
+      <p:sp>
+        <p:nvSpPr>
+          <p:cNvPr id="2" name="Slide Image Placeholder 1"/>
+          <p:cNvSpPr>
+            <a:spLocks noGrp="1"/>
+          </p:cNvSpPr>
+          <p:nvPr>
+            <p:ph type="sldImg" idx="2"/>
+          </p:nvPr>
+        </p:nvSpPr>
+        <p:spPr/>
+      </p:sp>
+      <p:sp>
+        <p:nvSpPr>
+          <p:cNvPr id="3" name="Notes Placeholder 2"/>
+          <p:cNvSpPr>
+            <a:spLocks noGrp="1"/>
+          </p:cNvSpPr>
+          <p:nvPr>
+            <p:ph type="body" idx="3" sz="quarter"/>
+          </p:nvPr>
+        </p:nvSpPr>
+        <p:spPr/>
+        <p:txBody>
+          <a:bodyPr/>
+          <a:lstStyle/>
+          <a:p>
+            <a:r>
+              <a:t>This is the intellectual core — slow down. Each principle is an answer to a slide-4 problem: orchestrator-owns-done answers self-certification; park-don't-guess answers guessing; isolation answers collision; resume answers context loss.</a:t>
+            </a:r>
+          </a:p>
+          <a:p>
+            <a:r>
+              <a:t>The single most important sentence in the whole talk: only a zero exit code is green; the agent's own claim decides nothing. If they remember one thing, make it that.</a:t>
+            </a:r>
+          </a:p>
+        </p:txBody>
+      </p:sp>
+      <p:sp>
+        <p:nvSpPr>
+          <p:cNvPr id="4" name="Slide Number Placeholder 3"/>
+          <p:cNvSpPr>
+            <a:spLocks noGrp="1"/>
+          </p:cNvSpPr>
+          <p:nvPr>
+            <p:ph type="sldNum" idx="5" sz="quarter"/>
+          </p:nvPr>
+        </p:nvSpPr>
+        <p:spPr/>
+      </p:sp>
+    </p:spTree>
+  </p:cSld>
+  <p:clrMapOvr>
+    <a:masterClrMapping/>
+  </p:clrMapOvr>
+</p:notes>
+</file>
+
+<file path=ppt/notesSlides/notesSlide6.xml><?xml version="1.0" encoding="utf-8"?>
+<p:notes xmlns:a="http://schemas.openxmlformats.org/drawingml/2006/main" xmlns:p="http://schemas.openxmlformats.org/presentationml/2006/main" xmlns:r="http://schemas.openxmlformats.org/officeDocument/2006/relationships">
+  <p:cSld>
+    <p:spTree>
+      <p:nvGrpSpPr>
+        <p:cNvPr id="1" name=""/>
+        <p:cNvGrpSpPr/>
+        <p:nvPr/>
+      </p:nvGrpSpPr>
+      <p:grpSpPr>
+        <a:xfrm>
+          <a:off x="0" y="0"/>
+          <a:ext cx="0" cy="0"/>
+          <a:chOff x="0" y="0"/>
+          <a:chExt cx="0" cy="0"/>
+        </a:xfrm>
+      </p:grpSpPr>
+      <p:sp>
+        <p:nvSpPr>
+          <p:cNvPr id="2" name="Slide Image Placeholder 1"/>
+          <p:cNvSpPr>
+            <a:spLocks noGrp="1"/>
+          </p:cNvSpPr>
+          <p:nvPr>
+            <p:ph type="sldImg" idx="2"/>
+          </p:nvPr>
+        </p:nvSpPr>
+        <p:spPr/>
+      </p:sp>
+      <p:sp>
+        <p:nvSpPr>
+          <p:cNvPr id="3" name="Notes Placeholder 2"/>
+          <p:cNvSpPr>
+            <a:spLocks noGrp="1"/>
+          </p:cNvSpPr>
+          <p:nvPr>
+            <p:ph type="body" idx="3" sz="quarter"/>
+          </p:nvPr>
+        </p:nvSpPr>
+        <p:spPr/>
+        <p:txBody>
+          <a:bodyPr/>
+          <a:lstStyle/>
+          <a:p>
+            <a:r>
+              <a:t>Walk it left to right, once. Orchestrator reads your config and keeps a bounded pool full. Each task is its own Docker container on its own branch/worktree — that's why they can't corrupt each other. After every 'done', the gate runs YOUR test command inside the box; green commits, red resumes the same session, blocked parks to Telegram.</a:t>
+            </a:r>
+          </a:p>
+          <a:p>
+            <a:r>
+              <a:t>Emphasise the bottom strip: the human loop is asynchronous — a park frees the slot and waits, so one stuck task never blocks the other nine.</a:t>
+            </a:r>
+          </a:p>
+        </p:txBody>
+      </p:sp>
+      <p:sp>
+        <p:nvSpPr>
+          <p:cNvPr id="4" name="Slide Number Placeholder 3"/>
+          <p:cNvSpPr>
+            <a:spLocks noGrp="1"/>
+          </p:cNvSpPr>
+          <p:nvPr>
+            <p:ph type="sldNum" idx="5" sz="quarter"/>
+          </p:nvPr>
+        </p:nvSpPr>
+        <p:spPr/>
+      </p:sp>
+    </p:spTree>
+  </p:cSld>
+  <p:clrMapOvr>
+    <a:masterClrMapping/>
+  </p:clrMapOvr>
+</p:notes>
+</file>
+
+<file path=ppt/notesSlides/notesSlide7.xml><?xml version="1.0" encoding="utf-8"?>
+<p:notes xmlns:a="http://schemas.openxmlformats.org/drawingml/2006/main" xmlns:p="http://schemas.openxmlformats.org/presentationml/2006/main" xmlns:r="http://schemas.openxmlformats.org/officeDocument/2006/relationships">
+  <p:cSld>
+    <p:spTree>
+      <p:nvGrpSpPr>
+        <p:cNvPr id="1" name=""/>
+        <p:cNvGrpSpPr/>
+        <p:nvPr/>
+      </p:nvGrpSpPr>
+      <p:grpSpPr>
+        <a:xfrm>
+          <a:off x="0" y="0"/>
+          <a:ext cx="0" cy="0"/>
+          <a:chOff x="0" y="0"/>
+          <a:chExt cx="0" cy="0"/>
+        </a:xfrm>
+      </p:grpSpPr>
+      <p:sp>
+        <p:nvSpPr>
+          <p:cNvPr id="2" name="Slide Image Placeholder 1"/>
+          <p:cNvSpPr>
+            <a:spLocks noGrp="1"/>
+          </p:cNvSpPr>
+          <p:nvPr>
+            <p:ph type="sldImg" idx="2"/>
+          </p:nvPr>
+        </p:nvSpPr>
+        <p:spPr/>
+      </p:sp>
+      <p:sp>
+        <p:nvSpPr>
+          <p:cNvPr id="3" name="Notes Placeholder 2"/>
+          <p:cNvSpPr>
+            <a:spLocks noGrp="1"/>
+          </p:cNvSpPr>
+          <p:nvPr>
+            <p:ph type="body" idx="3" sz="quarter"/>
+          </p:nvPr>
+        </p:nvSpPr>
+        <p:spPr/>
+        <p:txBody>
+          <a:bodyPr/>
+          <a:lstStyle/>
+          <a:p>
+            <a:r>
+              <a:t>The heartbeat. The non-obvious move is step 4b: a red gate doesn't restart the agent, it RESUMES the same session with the failure output pasted in. So the agent keeps everything it already figured out and fixes the actual failure.</a:t>
+            </a:r>
+          </a:p>
+          <a:p>
+            <a:r>
+              <a:t>Punchline at the bottom: a failing test isn't a dead end, it's the next prompt. That's why it converges instead of thrashing. Note COMPLETE is a structured signal, not free text.</a:t>
+            </a:r>
+          </a:p>
+        </p:txBody>
+      </p:sp>
+      <p:sp>
+        <p:nvSpPr>
+          <p:cNvPr id="4" name="Slide Number Placeholder 3"/>
+          <p:cNvSpPr>
+            <a:spLocks noGrp="1"/>
+          </p:cNvSpPr>
+          <p:nvPr>
+            <p:ph type="sldNum" idx="5" sz="quarter"/>
+          </p:nvPr>
+        </p:nvSpPr>
+        <p:spPr/>
+      </p:sp>
+    </p:spTree>
+  </p:cSld>
+  <p:clrMapOvr>
+    <a:masterClrMapping/>
+  </p:clrMapOvr>
+</p:notes>
+</file>
+
+<file path=ppt/notesSlides/notesSlide8.xml><?xml version="1.0" encoding="utf-8"?>
+<p:notes xmlns:a="http://schemas.openxmlformats.org/drawingml/2006/main" xmlns:p="http://schemas.openxmlformats.org/presentationml/2006/main" xmlns:r="http://schemas.openxmlformats.org/officeDocument/2006/relationships">
+  <p:cSld>
+    <p:spTree>
+      <p:nvGrpSpPr>
+        <p:cNvPr id="1" name=""/>
+        <p:cNvGrpSpPr/>
+        <p:nvPr/>
+      </p:nvGrpSpPr>
+      <p:grpSpPr>
+        <a:xfrm>
+          <a:off x="0" y="0"/>
+          <a:ext cx="0" cy="0"/>
+          <a:chOff x="0" y="0"/>
+          <a:chExt cx="0" cy="0"/>
+        </a:xfrm>
+      </p:grpSpPr>
+      <p:sp>
+        <p:nvSpPr>
+          <p:cNvPr id="2" name="Slide Image Placeholder 1"/>
+          <p:cNvSpPr>
+            <a:spLocks noGrp="1"/>
+          </p:cNvSpPr>
+          <p:nvPr>
+            <p:ph type="sldImg" idx="2"/>
+          </p:nvPr>
+        </p:nvSpPr>
+        <p:spPr/>
+      </p:sp>
+      <p:sp>
+        <p:nvSpPr>
+          <p:cNvPr id="3" name="Notes Placeholder 2"/>
+          <p:cNvSpPr>
+            <a:spLocks noGrp="1"/>
+          </p:cNvSpPr>
+          <p:nvPr>
+            <p:ph type="body" idx="3" sz="quarter"/>
+          </p:nvPr>
+        </p:nvSpPr>
+        <p:spPr/>
+        <p:txBody>
+          <a:bodyPr/>
+          <a:lstStyle/>
+          <a:p>
+            <a:r>
+              <a:t>Callout slide for gh/mattpocock/skills — credit where due. The agent's craft (how to write a good test, test at seams, avoid anti-patterns) isn't mine; it's Matt Pocock's tdd/codebase-design/code-review skills, baked into the container image at build time and auto-discovered by the plain claude CLI. Zero per-run cost, off every agent branch.</a:t>
+            </a:r>
+          </a:p>
+          <a:p>
+            <a:r>
+              <a:t>The load-bearing clause is the bottom bar: skills govern HOW you work; my contract governs WHETHER you're done. A skill's own notion of 'done' never ends a turn — only the gate does. Ties straight back to slide 5.</a:t>
+            </a:r>
+          </a:p>
+        </p:txBody>
+      </p:sp>
+      <p:sp>
+        <p:nvSpPr>
+          <p:cNvPr id="4" name="Slide Number Placeholder 3"/>
+          <p:cNvSpPr>
+            <a:spLocks noGrp="1"/>
+          </p:cNvSpPr>
+          <p:nvPr>
+            <p:ph type="sldNum" idx="5" sz="quarter"/>
+          </p:nvPr>
+        </p:nvSpPr>
+        <p:spPr/>
+      </p:sp>
+    </p:spTree>
+  </p:cSld>
+  <p:clrMapOvr>
+    <a:masterClrMapping/>
+  </p:clrMapOvr>
+</p:notes>
+</file>
+
+<file path=ppt/notesSlides/notesSlide9.xml><?xml version="1.0" encoding="utf-8"?>
+<p:notes xmlns:a="http://schemas.openxmlformats.org/drawingml/2006/main" xmlns:p="http://schemas.openxmlformats.org/presentationml/2006/main" xmlns:r="http://schemas.openxmlformats.org/officeDocument/2006/relationships">
+  <p:cSld>
+    <p:spTree>
+      <p:nvGrpSpPr>
+        <p:cNvPr id="1" name=""/>
+        <p:cNvGrpSpPr/>
+        <p:nvPr/>
+      </p:nvGrpSpPr>
+      <p:grpSpPr>
+        <a:xfrm>
+          <a:off x="0" y="0"/>
+          <a:ext cx="0" cy="0"/>
+          <a:chOff x="0" y="0"/>
+          <a:chExt cx="0" cy="0"/>
+        </a:xfrm>
+      </p:grpSpPr>
+      <p:sp>
+        <p:nvSpPr>
+          <p:cNvPr id="2" name="Slide Image Placeholder 1"/>
+          <p:cNvSpPr>
+            <a:spLocks noGrp="1"/>
+          </p:cNvSpPr>
+          <p:nvPr>
+            <p:ph type="sldImg" idx="2"/>
+          </p:nvPr>
+        </p:nvSpPr>
+        <p:spPr/>
+      </p:sp>
+      <p:sp>
+        <p:nvSpPr>
+          <p:cNvPr id="3" name="Notes Placeholder 2"/>
+          <p:cNvSpPr>
+            <a:spLocks noGrp="1"/>
+          </p:cNvSpPr>
+          <p:nvPr>
+            <p:ph type="body" idx="3" sz="quarter"/>
+          </p:nvPr>
+        </p:nvSpPr>
+        <p:spPr/>
+        <p:txBody>
+          <a:bodyPr/>
+          <a:lstStyle/>
+          <a:p>
+            <a:r>
+              <a:t>Reframe blocking as a feature. When an agent hits genuine ambiguity it writes its question + session to disk, tears down the container (frees the slot), and messages me. I reply to that message from my phone — hours or days later — and that exact agent resumes with full context.</a:t>
+            </a:r>
+          </a:p>
+          <a:p>
+            <a:r>
+              <a:t>The phone mock on the right is the entire UI. No dashboard. Mention it runs as a systemd user service so a park raised after I close my laptop still reaches me.</a:t>
+            </a:r>
+          </a:p>
+        </p:txBody>
+      </p:sp>
+      <p:sp>
+        <p:nvSpPr>
+          <p:cNvPr id="4" name="Slide Number Placeholder 3"/>
+          <p:cNvSpPr>
+            <a:spLocks noGrp="1"/>
+          </p:cNvSpPr>
+          <p:nvPr>
+            <p:ph type="sldNum" idx="5" sz="quarter"/>
+          </p:nvPr>
+        </p:nvSpPr>
+        <p:spPr/>
+      </p:sp>
+    </p:spTree>
+  </p:cSld>
+  <p:clrMapOvr>
+    <a:masterClrMapping/>
+  </p:clrMapOvr>
+</p:notes>
 </file>
 
 <file path=ppt/slideLayouts/slideLayout1.xml><?xml version="1.0" encoding="utf-8"?>
@@ -6342,22 +7967,67 @@
       </p:sp>
       <p:sp>
         <p:nvSpPr>
-          <p:cNvPr id="7" name="Rounded Rectangle 6"/>
+          <p:cNvPr id="7" name="TextBox 6"/>
+          <p:cNvSpPr txBox="1"/>
+          <p:nvPr/>
+        </p:nvSpPr>
+        <p:spPr>
+          <a:xfrm>
+            <a:off x="640080" y="2011680"/>
+            <a:ext cx="5486400" cy="219456"/>
+          </a:xfrm>
+          <a:prstGeom prst="rect">
+            <a:avLst/>
+          </a:prstGeom>
+          <a:noFill/>
+        </p:spPr>
+        <p:txBody>
+          <a:bodyPr wrap="square" anchor="t" lIns="0" rIns="0" tIns="0" bIns="0">
+            <a:spAutoFit/>
+          </a:bodyPr>
+          <a:lstStyle/>
+          <a:p>
+            <a:pPr algn="l">
+              <a:lnSpc>
+                <a:spcPct val="105000"/>
+              </a:lnSpc>
+              <a:spcBef>
+                <a:spcPts val="0"/>
+              </a:spcBef>
+              <a:spcAft>
+                <a:spcPts val="0"/>
+              </a:spcAft>
+            </a:pPr>
+            <a:r>
+              <a:rPr sz="1050" b="1" i="0">
+                <a:solidFill>
+                  <a:srgbClr val="94A3B8"/>
+                </a:solidFill>
+                <a:latin typeface="Arial"/>
+              </a:rPr>
+              <a:t>NOT A TOY TARGET — ONE MONOREPO, FOUR PARTS</a:t>
+            </a:r>
+          </a:p>
+        </p:txBody>
+      </p:sp>
+      <p:sp>
+        <p:nvSpPr>
+          <p:cNvPr id="8" name="Rounded Rectangle 7"/>
           <p:cNvSpPr/>
           <p:nvPr/>
         </p:nvSpPr>
         <p:spPr>
           <a:xfrm>
-            <a:off x="640080" y="2121408"/>
-            <a:ext cx="10881360" cy="566928"/>
+            <a:off x="640080" y="2249424"/>
+            <a:ext cx="1947672" cy="512064"/>
           </a:xfrm>
           <a:prstGeom prst="roundRect">
             <a:avLst>
-              <a:gd name="adj" fmla="val 5000"/>
+              <a:gd name="adj" fmla="val 11000"/>
             </a:avLst>
           </a:prstGeom>
           <a:solidFill>
-            <a:srgbClr val="162133"/>
+            <a:srgbClr val="1E293B"/>
           </a:solidFill>
           <a:ln>
             <a:noFill/>
@@ -6388,14 +8058,194 @@
       </p:sp>
       <p:sp>
         <p:nvSpPr>
-          <p:cNvPr id="8" name="Rectangle 7"/>
+          <p:cNvPr id="9" name="Rectangle 8"/>
           <p:cNvSpPr/>
           <p:nvPr/>
         </p:nvSpPr>
         <p:spPr>
           <a:xfrm>
-            <a:off x="640080" y="2121408"/>
-            <a:ext cx="91440" cy="566928"/>
+            <a:off x="640080" y="2249424"/>
+            <a:ext cx="1947672" cy="64008"/>
+          </a:xfrm>
+          <a:prstGeom prst="rect">
+            <a:avLst/>
+          </a:prstGeom>
+          <a:solidFill>
+            <a:srgbClr val="38BDF8"/>
+          </a:solidFill>
+          <a:ln>
+            <a:noFill/>
+          </a:ln>
+          <a:effectLst/>
+        </p:spPr>
+        <p:style>
+          <a:lnRef idx="1">
+            <a:schemeClr val="accent1"/>
+          </a:lnRef>
+          <a:fillRef idx="3">
+            <a:schemeClr val="accent1"/>
+          </a:fillRef>
+          <a:effectRef idx="2">
+            <a:schemeClr val="accent1"/>
+          </a:effectRef>
+          <a:fontRef idx="minor">
+            <a:schemeClr val="lt1"/>
+          </a:fontRef>
+        </p:style>
+        <p:txBody>
+          <a:bodyPr rtlCol="0" anchor="ctr"/>
+          <a:lstStyle/>
+          <a:p>
+            <a:pPr algn="ctr"/>
+          </a:p>
+        </p:txBody>
+      </p:sp>
+      <p:sp>
+        <p:nvSpPr>
+          <p:cNvPr id="10" name="TextBox 9"/>
+          <p:cNvSpPr txBox="1"/>
+          <p:nvPr/>
+        </p:nvSpPr>
+        <p:spPr>
+          <a:xfrm>
+            <a:off x="640080" y="2331720"/>
+            <a:ext cx="1947672" cy="237744"/>
+          </a:xfrm>
+          <a:prstGeom prst="rect">
+            <a:avLst/>
+          </a:prstGeom>
+          <a:noFill/>
+        </p:spPr>
+        <p:txBody>
+          <a:bodyPr wrap="square" anchor="t" lIns="0" rIns="0" tIns="0" bIns="0">
+            <a:spAutoFit/>
+          </a:bodyPr>
+          <a:lstStyle/>
+          <a:p>
+            <a:pPr algn="ctr">
+              <a:lnSpc>
+                <a:spcPct val="105000"/>
+              </a:lnSpc>
+              <a:spcBef>
+                <a:spcPts val="0"/>
+              </a:spcBef>
+              <a:spcAft>
+                <a:spcPts val="0"/>
+              </a:spcAft>
+            </a:pPr>
+            <a:r>
+              <a:rPr sz="1200" b="1" i="0">
+                <a:solidFill>
+                  <a:srgbClr val="F8FAFC"/>
+                </a:solidFill>
+                <a:latin typeface="Arial"/>
+              </a:rPr>
+              <a:t>Forgejo fork</a:t>
+            </a:r>
+          </a:p>
+        </p:txBody>
+      </p:sp>
+      <p:sp>
+        <p:nvSpPr>
+          <p:cNvPr id="11" name="TextBox 10"/>
+          <p:cNvSpPr txBox="1"/>
+          <p:nvPr/>
+        </p:nvSpPr>
+        <p:spPr>
+          <a:xfrm>
+            <a:off x="640080" y="2551176"/>
+            <a:ext cx="1947672" cy="182880"/>
+          </a:xfrm>
+          <a:prstGeom prst="rect">
+            <a:avLst/>
+          </a:prstGeom>
+          <a:noFill/>
+        </p:spPr>
+        <p:txBody>
+          <a:bodyPr wrap="square" anchor="t" lIns="0" rIns="0" tIns="0" bIns="0">
+            <a:spAutoFit/>
+          </a:bodyPr>
+          <a:lstStyle/>
+          <a:p>
+            <a:pPr algn="ctr">
+              <a:lnSpc>
+                <a:spcPct val="105000"/>
+              </a:lnSpc>
+              <a:spcBef>
+                <a:spcPts val="0"/>
+              </a:spcBef>
+              <a:spcAft>
+                <a:spcPts val="0"/>
+              </a:spcAft>
+            </a:pPr>
+            <a:r>
+              <a:rPr sz="900" b="0" i="0">
+                <a:solidFill>
+                  <a:srgbClr val="94A3B8"/>
+                </a:solidFill>
+                <a:latin typeface="Arial"/>
+              </a:rPr>
+              <a:t>Go · web forge</a:t>
+            </a:r>
+          </a:p>
+        </p:txBody>
+      </p:sp>
+      <p:sp>
+        <p:nvSpPr>
+          <p:cNvPr id="12" name="Rounded Rectangle 11"/>
+          <p:cNvSpPr/>
+          <p:nvPr/>
+        </p:nvSpPr>
+        <p:spPr>
+          <a:xfrm>
+            <a:off x="2697480" y="2249424"/>
+            <a:ext cx="1947672" cy="512064"/>
+          </a:xfrm>
+          <a:prstGeom prst="roundRect">
+            <a:avLst>
+              <a:gd name="adj" fmla="val 11000"/>
+            </a:avLst>
+          </a:prstGeom>
+          <a:solidFill>
+            <a:srgbClr val="1E293B"/>
+          </a:solidFill>
+          <a:ln>
+            <a:noFill/>
+          </a:ln>
+          <a:effectLst/>
+        </p:spPr>
+        <p:style>
+          <a:lnRef idx="1">
+            <a:schemeClr val="accent1"/>
+          </a:lnRef>
+          <a:fillRef idx="3">
+            <a:schemeClr val="accent1"/>
+          </a:fillRef>
+          <a:effectRef idx="2">
+            <a:schemeClr val="accent1"/>
+          </a:effectRef>
+          <a:fontRef idx="minor">
+            <a:schemeClr val="lt1"/>
+          </a:fontRef>
+        </p:style>
+        <p:txBody>
+          <a:bodyPr rtlCol="0" anchor="ctr"/>
+          <a:lstStyle/>
+          <a:p>
+            <a:pPr algn="ctr"/>
+          </a:p>
+        </p:txBody>
+      </p:sp>
+      <p:sp>
+        <p:nvSpPr>
+          <p:cNvPr id="13" name="Rectangle 12"/>
+          <p:cNvSpPr/>
+          <p:nvPr/>
+        </p:nvSpPr>
+        <p:spPr>
+          <a:xfrm>
+            <a:off x="2697480" y="2249424"/>
+            <a:ext cx="1947672" cy="64008"/>
           </a:xfrm>
           <a:prstGeom prst="rect">
             <a:avLst/>
@@ -6432,14 +8282,14 @@
       </p:sp>
       <p:sp>
         <p:nvSpPr>
-          <p:cNvPr id="9" name="TextBox 8"/>
+          <p:cNvPr id="14" name="TextBox 13"/>
           <p:cNvSpPr txBox="1"/>
           <p:nvPr/>
         </p:nvSpPr>
         <p:spPr>
           <a:xfrm>
-            <a:off x="914400" y="2121408"/>
-            <a:ext cx="10424160" cy="566928"/>
+            <a:off x="2697480" y="2331720"/>
+            <a:ext cx="1947672" cy="237744"/>
           </a:xfrm>
           <a:prstGeom prst="rect">
             <a:avLst/>
@@ -6447,75 +8297,93 @@
           <a:noFill/>
         </p:spPr>
         <p:txBody>
-          <a:bodyPr wrap="square" anchor="ctr" lIns="0" rIns="0" tIns="0" bIns="0">
+          <a:bodyPr wrap="square" anchor="t" lIns="0" rIns="0" tIns="0" bIns="0">
             <a:spAutoFit/>
           </a:bodyPr>
           <a:lstStyle/>
           <a:p>
-            <a:pPr algn="l">
-              <a:lnSpc>
-                <a:spcPct val="108000"/>
-              </a:lnSpc>
-              <a:spcBef>
-                <a:spcPts val="0"/>
-              </a:spcBef>
-              <a:spcAft>
-                <a:spcPts val="0"/>
-              </a:spcAft>
-            </a:pPr>
-            <a:r>
-              <a:rPr sz="1250" b="1" i="0">
-                <a:solidFill>
-                  <a:srgbClr val="F59E0B"/>
-                </a:solidFill>
-                <a:latin typeface="Arial"/>
-              </a:rPr>
-              <a:t>And it's not a toy target: </a:t>
-            </a:r>
-            <a:r>
-              <a:rPr sz="1250" b="0" i="0">
-                <a:solidFill>
-                  <a:srgbClr val="E2E8F0"/>
-                </a:solidFill>
-                <a:latin typeface="Arial"/>
-              </a:rPr>
-              <a:t>two forks + a Rust sidecar + a client, wrapping Jujutsu — a version-control system whose whole promise is it </a:t>
-            </a:r>
-            <a:r>
-              <a:rPr sz="1250" b="1" i="0">
+            <a:pPr algn="ctr">
+              <a:lnSpc>
+                <a:spcPct val="105000"/>
+              </a:lnSpc>
+              <a:spcBef>
+                <a:spcPts val="0"/>
+              </a:spcBef>
+              <a:spcAft>
+                <a:spcPts val="0"/>
+              </a:spcAft>
+            </a:pPr>
+            <a:r>
+              <a:rPr sz="1200" b="1" i="0">
                 <a:solidFill>
                   <a:srgbClr val="F8FAFC"/>
                 </a:solidFill>
                 <a:latin typeface="Arial"/>
               </a:rPr>
-              <a:t>can't lose your work</a:t>
-            </a:r>
-            <a:r>
-              <a:rPr sz="1250" b="0" i="0">
-                <a:solidFill>
-                  <a:srgbClr val="E2E8F0"/>
-                </a:solidFill>
-                <a:latin typeface="Arial"/>
-              </a:rPr>
-              <a:t>. Exactly where a real test gate earns its keep.</a:t>
-            </a:r>
-          </a:p>
-        </p:txBody>
-      </p:sp>
-      <p:sp>
-        <p:nvSpPr>
-          <p:cNvPr id="10" name="Rounded Rectangle 9"/>
+              <a:t>jj fork</a:t>
+            </a:r>
+          </a:p>
+        </p:txBody>
+      </p:sp>
+      <p:sp>
+        <p:nvSpPr>
+          <p:cNvPr id="15" name="TextBox 14"/>
+          <p:cNvSpPr txBox="1"/>
+          <p:nvPr/>
+        </p:nvSpPr>
+        <p:spPr>
+          <a:xfrm>
+            <a:off x="2697480" y="2551176"/>
+            <a:ext cx="1947672" cy="182880"/>
+          </a:xfrm>
+          <a:prstGeom prst="rect">
+            <a:avLst/>
+          </a:prstGeom>
+          <a:noFill/>
+        </p:spPr>
+        <p:txBody>
+          <a:bodyPr wrap="square" anchor="t" lIns="0" rIns="0" tIns="0" bIns="0">
+            <a:spAutoFit/>
+          </a:bodyPr>
+          <a:lstStyle/>
+          <a:p>
+            <a:pPr algn="ctr">
+              <a:lnSpc>
+                <a:spcPct val="105000"/>
+              </a:lnSpc>
+              <a:spcBef>
+                <a:spcPts val="0"/>
+              </a:spcBef>
+              <a:spcAft>
+                <a:spcPts val="0"/>
+              </a:spcAft>
+            </a:pPr>
+            <a:r>
+              <a:rPr sz="900" b="0" i="0">
+                <a:solidFill>
+                  <a:srgbClr val="94A3B8"/>
+                </a:solidFill>
+                <a:latin typeface="Arial"/>
+              </a:rPr>
+              <a:t>Rust · the VCS</a:t>
+            </a:r>
+          </a:p>
+        </p:txBody>
+      </p:sp>
+      <p:sp>
+        <p:nvSpPr>
+          <p:cNvPr id="16" name="Rounded Rectangle 15"/>
           <p:cNvSpPr/>
           <p:nvPr/>
         </p:nvSpPr>
         <p:spPr>
           <a:xfrm>
-            <a:off x="640080" y="2852928"/>
-            <a:ext cx="2606040" cy="1572768"/>
+            <a:off x="4754880" y="2249424"/>
+            <a:ext cx="1947672" cy="512064"/>
           </a:xfrm>
           <a:prstGeom prst="roundRect">
             <a:avLst>
-              <a:gd name="adj" fmla="val 6000"/>
+              <a:gd name="adj" fmla="val 11000"/>
             </a:avLst>
           </a:prstGeom>
           <a:solidFill>
@@ -6550,14 +8418,14 @@
       </p:sp>
       <p:sp>
         <p:nvSpPr>
-          <p:cNvPr id="11" name="Rectangle 10"/>
+          <p:cNvPr id="17" name="Rectangle 16"/>
           <p:cNvSpPr/>
           <p:nvPr/>
         </p:nvSpPr>
         <p:spPr>
           <a:xfrm>
-            <a:off x="640080" y="2852928"/>
-            <a:ext cx="2606040" cy="109728"/>
+            <a:off x="4754880" y="2249424"/>
+            <a:ext cx="1947672" cy="64008"/>
           </a:xfrm>
           <a:prstGeom prst="rect">
             <a:avLst/>
@@ -6594,14 +8462,14 @@
       </p:sp>
       <p:sp>
         <p:nvSpPr>
-          <p:cNvPr id="12" name="TextBox 11"/>
+          <p:cNvPr id="18" name="TextBox 17"/>
           <p:cNvSpPr txBox="1"/>
           <p:nvPr/>
         </p:nvSpPr>
         <p:spPr>
           <a:xfrm>
-            <a:off x="640080" y="3035808"/>
-            <a:ext cx="2606040" cy="777240"/>
+            <a:off x="4754880" y="2331720"/>
+            <a:ext cx="1947672" cy="237744"/>
           </a:xfrm>
           <a:prstGeom prst="rect">
             <a:avLst/>
@@ -6626,27 +8494,27 @@
               </a:spcAft>
             </a:pPr>
             <a:r>
-              <a:rPr sz="3800" b="1" i="0">
-                <a:solidFill>
-                  <a:srgbClr val="F59E0B"/>
-                </a:solidFill>
-                <a:latin typeface="Arial"/>
-              </a:rPr>
-              <a:t>69</a:t>
-            </a:r>
-          </a:p>
-        </p:txBody>
-      </p:sp>
-      <p:sp>
-        <p:nvSpPr>
-          <p:cNvPr id="13" name="TextBox 12"/>
+              <a:rPr sz="1200" b="1" i="0">
+                <a:solidFill>
+                  <a:srgbClr val="F8FAFC"/>
+                </a:solidFill>
+                <a:latin typeface="Arial"/>
+              </a:rPr>
+              <a:t>Sidecar</a:t>
+            </a:r>
+          </a:p>
+        </p:txBody>
+      </p:sp>
+      <p:sp>
+        <p:nvSpPr>
+          <p:cNvPr id="19" name="TextBox 18"/>
           <p:cNvSpPr txBox="1"/>
           <p:nvPr/>
         </p:nvSpPr>
         <p:spPr>
           <a:xfrm>
-            <a:off x="640080" y="3840480"/>
-            <a:ext cx="2606040" cy="548640"/>
+            <a:off x="4754880" y="2551176"/>
+            <a:ext cx="1947672" cy="182880"/>
           </a:xfrm>
           <a:prstGeom prst="rect">
             <a:avLst/>
@@ -6671,31 +8539,31 @@
               </a:spcAft>
             </a:pPr>
             <a:r>
-              <a:rPr sz="1200" b="0" i="0">
+              <a:rPr sz="900" b="0" i="0">
                 <a:solidFill>
                   <a:srgbClr val="94A3B8"/>
                 </a:solidFill>
                 <a:latin typeface="Arial"/>
               </a:rPr>
-              <a:t>tasks merged Aug 16–18</a:t>
-            </a:r>
-          </a:p>
-        </p:txBody>
-      </p:sp>
-      <p:sp>
-        <p:nvSpPr>
-          <p:cNvPr id="14" name="Rounded Rectangle 13"/>
+              <a:t>Rust · sync + blobs</a:t>
+            </a:r>
+          </a:p>
+        </p:txBody>
+      </p:sp>
+      <p:sp>
+        <p:nvSpPr>
+          <p:cNvPr id="20" name="Rounded Rectangle 19"/>
           <p:cNvSpPr/>
           <p:nvPr/>
         </p:nvSpPr>
         <p:spPr>
           <a:xfrm>
-            <a:off x="3410711" y="2852928"/>
-            <a:ext cx="2606040" cy="1572768"/>
+            <a:off x="6812280" y="2249424"/>
+            <a:ext cx="1947672" cy="512064"/>
           </a:xfrm>
           <a:prstGeom prst="roundRect">
             <a:avLst>
-              <a:gd name="adj" fmla="val 6000"/>
+              <a:gd name="adj" fmla="val 11000"/>
             </a:avLst>
           </a:prstGeom>
           <a:solidFill>
@@ -6730,7 +8598,482 @@
       </p:sp>
       <p:sp>
         <p:nvSpPr>
-          <p:cNvPr id="15" name="Rectangle 14"/>
+          <p:cNvPr id="21" name="Rectangle 20"/>
+          <p:cNvSpPr/>
+          <p:nvPr/>
+        </p:nvSpPr>
+        <p:spPr>
+          <a:xfrm>
+            <a:off x="6812280" y="2249424"/>
+            <a:ext cx="1947672" cy="64008"/>
+          </a:xfrm>
+          <a:prstGeom prst="rect">
+            <a:avLst/>
+          </a:prstGeom>
+          <a:solidFill>
+            <a:srgbClr val="C084FC"/>
+          </a:solidFill>
+          <a:ln>
+            <a:noFill/>
+          </a:ln>
+          <a:effectLst/>
+        </p:spPr>
+        <p:style>
+          <a:lnRef idx="1">
+            <a:schemeClr val="accent1"/>
+          </a:lnRef>
+          <a:fillRef idx="3">
+            <a:schemeClr val="accent1"/>
+          </a:fillRef>
+          <a:effectRef idx="2">
+            <a:schemeClr val="accent1"/>
+          </a:effectRef>
+          <a:fontRef idx="minor">
+            <a:schemeClr val="lt1"/>
+          </a:fontRef>
+        </p:style>
+        <p:txBody>
+          <a:bodyPr rtlCol="0" anchor="ctr"/>
+          <a:lstStyle/>
+          <a:p>
+            <a:pPr algn="ctr"/>
+          </a:p>
+        </p:txBody>
+      </p:sp>
+      <p:sp>
+        <p:nvSpPr>
+          <p:cNvPr id="22" name="TextBox 21"/>
+          <p:cNvSpPr txBox="1"/>
+          <p:nvPr/>
+        </p:nvSpPr>
+        <p:spPr>
+          <a:xfrm>
+            <a:off x="6812280" y="2331720"/>
+            <a:ext cx="1947672" cy="237744"/>
+          </a:xfrm>
+          <a:prstGeom prst="rect">
+            <a:avLst/>
+          </a:prstGeom>
+          <a:noFill/>
+        </p:spPr>
+        <p:txBody>
+          <a:bodyPr wrap="square" anchor="t" lIns="0" rIns="0" tIns="0" bIns="0">
+            <a:spAutoFit/>
+          </a:bodyPr>
+          <a:lstStyle/>
+          <a:p>
+            <a:pPr algn="ctr">
+              <a:lnSpc>
+                <a:spcPct val="105000"/>
+              </a:lnSpc>
+              <a:spcBef>
+                <a:spcPts val="0"/>
+              </a:spcBef>
+              <a:spcAft>
+                <a:spcPts val="0"/>
+              </a:spcAft>
+            </a:pPr>
+            <a:r>
+              <a:rPr sz="1200" b="1" i="0">
+                <a:solidFill>
+                  <a:srgbClr val="F8FAFC"/>
+                </a:solidFill>
+                <a:latin typeface="Arial"/>
+              </a:rPr>
+              <a:t>jjf CLI</a:t>
+            </a:r>
+          </a:p>
+        </p:txBody>
+      </p:sp>
+      <p:sp>
+        <p:nvSpPr>
+          <p:cNvPr id="23" name="TextBox 22"/>
+          <p:cNvSpPr txBox="1"/>
+          <p:nvPr/>
+        </p:nvSpPr>
+        <p:spPr>
+          <a:xfrm>
+            <a:off x="6812280" y="2551176"/>
+            <a:ext cx="1947672" cy="182880"/>
+          </a:xfrm>
+          <a:prstGeom prst="rect">
+            <a:avLst/>
+          </a:prstGeom>
+          <a:noFill/>
+        </p:spPr>
+        <p:txBody>
+          <a:bodyPr wrap="square" anchor="t" lIns="0" rIns="0" tIns="0" bIns="0">
+            <a:spAutoFit/>
+          </a:bodyPr>
+          <a:lstStyle/>
+          <a:p>
+            <a:pPr algn="ctr">
+              <a:lnSpc>
+                <a:spcPct val="105000"/>
+              </a:lnSpc>
+              <a:spcBef>
+                <a:spcPts val="0"/>
+              </a:spcBef>
+              <a:spcAft>
+                <a:spcPts val="0"/>
+              </a:spcAft>
+            </a:pPr>
+            <a:r>
+              <a:rPr sz="900" b="0" i="0">
+                <a:solidFill>
+                  <a:srgbClr val="94A3B8"/>
+                </a:solidFill>
+                <a:latin typeface="Arial"/>
+              </a:rPr>
+              <a:t>the platform client</a:t>
+            </a:r>
+          </a:p>
+        </p:txBody>
+      </p:sp>
+      <p:sp>
+        <p:nvSpPr>
+          <p:cNvPr id="24" name="Rounded Rectangle 23"/>
+          <p:cNvSpPr/>
+          <p:nvPr/>
+        </p:nvSpPr>
+        <p:spPr>
+          <a:xfrm>
+            <a:off x="8887968" y="2249424"/>
+            <a:ext cx="2633472" cy="512064"/>
+          </a:xfrm>
+          <a:prstGeom prst="roundRect">
+            <a:avLst>
+              <a:gd name="adj" fmla="val 11000"/>
+            </a:avLst>
+          </a:prstGeom>
+          <a:solidFill>
+            <a:srgbClr val="162133"/>
+          </a:solidFill>
+          <a:ln w="15240">
+            <a:solidFill>
+              <a:srgbClr val="F87171"/>
+            </a:solidFill>
+          </a:ln>
+          <a:effectLst/>
+        </p:spPr>
+        <p:style>
+          <a:lnRef idx="1">
+            <a:schemeClr val="accent1"/>
+          </a:lnRef>
+          <a:fillRef idx="3">
+            <a:schemeClr val="accent1"/>
+          </a:fillRef>
+          <a:effectRef idx="2">
+            <a:schemeClr val="accent1"/>
+          </a:effectRef>
+          <a:fontRef idx="minor">
+            <a:schemeClr val="lt1"/>
+          </a:fontRef>
+        </p:style>
+        <p:txBody>
+          <a:bodyPr rtlCol="0" anchor="ctr"/>
+          <a:lstStyle/>
+          <a:p>
+            <a:pPr algn="ctr"/>
+          </a:p>
+        </p:txBody>
+      </p:sp>
+      <p:sp>
+        <p:nvSpPr>
+          <p:cNvPr id="25" name="TextBox 24"/>
+          <p:cNvSpPr txBox="1"/>
+          <p:nvPr/>
+        </p:nvSpPr>
+        <p:spPr>
+          <a:xfrm>
+            <a:off x="9052560" y="2249424"/>
+            <a:ext cx="2331720" cy="512064"/>
+          </a:xfrm>
+          <a:prstGeom prst="rect">
+            <a:avLst/>
+          </a:prstGeom>
+          <a:noFill/>
+        </p:spPr>
+        <p:txBody>
+          <a:bodyPr wrap="square" anchor="ctr" lIns="0" rIns="0" tIns="0" bIns="0">
+            <a:spAutoFit/>
+          </a:bodyPr>
+          <a:lstStyle/>
+          <a:p>
+            <a:pPr algn="l">
+              <a:lnSpc>
+                <a:spcPct val="102000"/>
+              </a:lnSpc>
+              <a:spcBef>
+                <a:spcPts val="0"/>
+              </a:spcBef>
+              <a:spcAft>
+                <a:spcPts val="0"/>
+              </a:spcAft>
+            </a:pPr>
+            <a:r>
+              <a:rPr sz="1000" b="0" i="0">
+                <a:solidFill>
+                  <a:srgbClr val="E2E8F0"/>
+                </a:solidFill>
+                <a:latin typeface="Arial"/>
+              </a:rPr>
+              <a:t>⚠  a VCS whose whole job is</a:t>
+            </a:r>
+          </a:p>
+          <a:p>
+            <a:pPr algn="l">
+              <a:lnSpc>
+                <a:spcPct val="102000"/>
+              </a:lnSpc>
+              <a:spcBef>
+                <a:spcPts val="0"/>
+              </a:spcBef>
+              <a:spcAft>
+                <a:spcPts val="0"/>
+              </a:spcAft>
+            </a:pPr>
+            <a:r>
+              <a:rPr sz="1100" b="1" i="0">
+                <a:solidFill>
+                  <a:srgbClr val="F87171"/>
+                </a:solidFill>
+                <a:latin typeface="Arial"/>
+              </a:rPr>
+              <a:t>to never lose your work</a:t>
+            </a:r>
+          </a:p>
+        </p:txBody>
+      </p:sp>
+      <p:sp>
+        <p:nvSpPr>
+          <p:cNvPr id="26" name="Rounded Rectangle 25"/>
+          <p:cNvSpPr/>
+          <p:nvPr/>
+        </p:nvSpPr>
+        <p:spPr>
+          <a:xfrm>
+            <a:off x="640080" y="2852928"/>
+            <a:ext cx="2606040" cy="1572768"/>
+          </a:xfrm>
+          <a:prstGeom prst="roundRect">
+            <a:avLst>
+              <a:gd name="adj" fmla="val 6000"/>
+            </a:avLst>
+          </a:prstGeom>
+          <a:solidFill>
+            <a:srgbClr val="1E293B"/>
+          </a:solidFill>
+          <a:ln>
+            <a:noFill/>
+          </a:ln>
+          <a:effectLst/>
+        </p:spPr>
+        <p:style>
+          <a:lnRef idx="1">
+            <a:schemeClr val="accent1"/>
+          </a:lnRef>
+          <a:fillRef idx="3">
+            <a:schemeClr val="accent1"/>
+          </a:fillRef>
+          <a:effectRef idx="2">
+            <a:schemeClr val="accent1"/>
+          </a:effectRef>
+          <a:fontRef idx="minor">
+            <a:schemeClr val="lt1"/>
+          </a:fontRef>
+        </p:style>
+        <p:txBody>
+          <a:bodyPr rtlCol="0" anchor="ctr"/>
+          <a:lstStyle/>
+          <a:p>
+            <a:pPr algn="ctr"/>
+          </a:p>
+        </p:txBody>
+      </p:sp>
+      <p:sp>
+        <p:nvSpPr>
+          <p:cNvPr id="27" name="Rectangle 26"/>
+          <p:cNvSpPr/>
+          <p:nvPr/>
+        </p:nvSpPr>
+        <p:spPr>
+          <a:xfrm>
+            <a:off x="640080" y="2852928"/>
+            <a:ext cx="2606040" cy="109728"/>
+          </a:xfrm>
+          <a:prstGeom prst="rect">
+            <a:avLst/>
+          </a:prstGeom>
+          <a:solidFill>
+            <a:srgbClr val="F59E0B"/>
+          </a:solidFill>
+          <a:ln>
+            <a:noFill/>
+          </a:ln>
+          <a:effectLst/>
+        </p:spPr>
+        <p:style>
+          <a:lnRef idx="1">
+            <a:schemeClr val="accent1"/>
+          </a:lnRef>
+          <a:fillRef idx="3">
+            <a:schemeClr val="accent1"/>
+          </a:fillRef>
+          <a:effectRef idx="2">
+            <a:schemeClr val="accent1"/>
+          </a:effectRef>
+          <a:fontRef idx="minor">
+            <a:schemeClr val="lt1"/>
+          </a:fontRef>
+        </p:style>
+        <p:txBody>
+          <a:bodyPr rtlCol="0" anchor="ctr"/>
+          <a:lstStyle/>
+          <a:p>
+            <a:pPr algn="ctr"/>
+          </a:p>
+        </p:txBody>
+      </p:sp>
+      <p:sp>
+        <p:nvSpPr>
+          <p:cNvPr id="28" name="TextBox 27"/>
+          <p:cNvSpPr txBox="1"/>
+          <p:nvPr/>
+        </p:nvSpPr>
+        <p:spPr>
+          <a:xfrm>
+            <a:off x="640080" y="3035808"/>
+            <a:ext cx="2606040" cy="777240"/>
+          </a:xfrm>
+          <a:prstGeom prst="rect">
+            <a:avLst/>
+          </a:prstGeom>
+          <a:noFill/>
+        </p:spPr>
+        <p:txBody>
+          <a:bodyPr wrap="square" anchor="t" lIns="0" rIns="0" tIns="0" bIns="0">
+            <a:spAutoFit/>
+          </a:bodyPr>
+          <a:lstStyle/>
+          <a:p>
+            <a:pPr algn="ctr">
+              <a:lnSpc>
+                <a:spcPct val="105000"/>
+              </a:lnSpc>
+              <a:spcBef>
+                <a:spcPts val="0"/>
+              </a:spcBef>
+              <a:spcAft>
+                <a:spcPts val="0"/>
+              </a:spcAft>
+            </a:pPr>
+            <a:r>
+              <a:rPr sz="3800" b="1" i="0">
+                <a:solidFill>
+                  <a:srgbClr val="F59E0B"/>
+                </a:solidFill>
+                <a:latin typeface="Arial"/>
+              </a:rPr>
+              <a:t>69</a:t>
+            </a:r>
+          </a:p>
+        </p:txBody>
+      </p:sp>
+      <p:sp>
+        <p:nvSpPr>
+          <p:cNvPr id="29" name="TextBox 28"/>
+          <p:cNvSpPr txBox="1"/>
+          <p:nvPr/>
+        </p:nvSpPr>
+        <p:spPr>
+          <a:xfrm>
+            <a:off x="640080" y="3840480"/>
+            <a:ext cx="2606040" cy="548640"/>
+          </a:xfrm>
+          <a:prstGeom prst="rect">
+            <a:avLst/>
+          </a:prstGeom>
+          <a:noFill/>
+        </p:spPr>
+        <p:txBody>
+          <a:bodyPr wrap="square" anchor="t" lIns="0" rIns="0" tIns="0" bIns="0">
+            <a:spAutoFit/>
+          </a:bodyPr>
+          <a:lstStyle/>
+          <a:p>
+            <a:pPr algn="ctr">
+              <a:lnSpc>
+                <a:spcPct val="105000"/>
+              </a:lnSpc>
+              <a:spcBef>
+                <a:spcPts val="0"/>
+              </a:spcBef>
+              <a:spcAft>
+                <a:spcPts val="0"/>
+              </a:spcAft>
+            </a:pPr>
+            <a:r>
+              <a:rPr sz="1200" b="0" i="0">
+                <a:solidFill>
+                  <a:srgbClr val="94A3B8"/>
+                </a:solidFill>
+                <a:latin typeface="Arial"/>
+              </a:rPr>
+              <a:t>tasks merged Aug 16–18</a:t>
+            </a:r>
+          </a:p>
+        </p:txBody>
+      </p:sp>
+      <p:sp>
+        <p:nvSpPr>
+          <p:cNvPr id="30" name="Rounded Rectangle 29"/>
+          <p:cNvSpPr/>
+          <p:nvPr/>
+        </p:nvSpPr>
+        <p:spPr>
+          <a:xfrm>
+            <a:off x="3410711" y="2852928"/>
+            <a:ext cx="2606040" cy="1572768"/>
+          </a:xfrm>
+          <a:prstGeom prst="roundRect">
+            <a:avLst>
+              <a:gd name="adj" fmla="val 6000"/>
+            </a:avLst>
+          </a:prstGeom>
+          <a:solidFill>
+            <a:srgbClr val="1E293B"/>
+          </a:solidFill>
+          <a:ln>
+            <a:noFill/>
+          </a:ln>
+          <a:effectLst/>
+        </p:spPr>
+        <p:style>
+          <a:lnRef idx="1">
+            <a:schemeClr val="accent1"/>
+          </a:lnRef>
+          <a:fillRef idx="3">
+            <a:schemeClr val="accent1"/>
+          </a:fillRef>
+          <a:effectRef idx="2">
+            <a:schemeClr val="accent1"/>
+          </a:effectRef>
+          <a:fontRef idx="minor">
+            <a:schemeClr val="lt1"/>
+          </a:fontRef>
+        </p:style>
+        <p:txBody>
+          <a:bodyPr rtlCol="0" anchor="ctr"/>
+          <a:lstStyle/>
+          <a:p>
+            <a:pPr algn="ctr"/>
+          </a:p>
+        </p:txBody>
+      </p:sp>
+      <p:sp>
+        <p:nvSpPr>
+          <p:cNvPr id="31" name="Rectangle 30"/>
           <p:cNvSpPr/>
           <p:nvPr/>
         </p:nvSpPr>
@@ -6774,7 +9117,7 @@
       </p:sp>
       <p:sp>
         <p:nvSpPr>
-          <p:cNvPr id="16" name="TextBox 15"/>
+          <p:cNvPr id="32" name="TextBox 31"/>
           <p:cNvSpPr txBox="1"/>
           <p:nvPr/>
         </p:nvSpPr>
@@ -6819,7 +9162,7 @@
       </p:sp>
       <p:sp>
         <p:nvSpPr>
-          <p:cNvPr id="17" name="TextBox 16"/>
+          <p:cNvPr id="33" name="TextBox 32"/>
           <p:cNvSpPr txBox="1"/>
           <p:nvPr/>
         </p:nvSpPr>
@@ -6864,7 +9207,7 @@
       </p:sp>
       <p:sp>
         <p:nvSpPr>
-          <p:cNvPr id="18" name="Rounded Rectangle 17"/>
+          <p:cNvPr id="34" name="Rounded Rectangle 33"/>
           <p:cNvSpPr/>
           <p:nvPr/>
         </p:nvSpPr>
@@ -6910,7 +9253,7 @@
       </p:sp>
       <p:sp>
         <p:nvSpPr>
-          <p:cNvPr id="19" name="Rectangle 18"/>
+          <p:cNvPr id="35" name="Rectangle 34"/>
           <p:cNvSpPr/>
           <p:nvPr/>
         </p:nvSpPr>
@@ -6954,7 +9297,7 @@
       </p:sp>
       <p:sp>
         <p:nvSpPr>
-          <p:cNvPr id="20" name="TextBox 19"/>
+          <p:cNvPr id="36" name="TextBox 35"/>
           <p:cNvSpPr txBox="1"/>
           <p:nvPr/>
         </p:nvSpPr>
@@ -6999,7 +9342,7 @@
       </p:sp>
       <p:sp>
         <p:nvSpPr>
-          <p:cNvPr id="21" name="TextBox 20"/>
+          <p:cNvPr id="37" name="TextBox 36"/>
           <p:cNvSpPr txBox="1"/>
           <p:nvPr/>
         </p:nvSpPr>
@@ -7044,7 +9387,7 @@
       </p:sp>
       <p:sp>
         <p:nvSpPr>
-          <p:cNvPr id="22" name="Rounded Rectangle 21"/>
+          <p:cNvPr id="38" name="Rounded Rectangle 37"/>
           <p:cNvSpPr/>
           <p:nvPr/>
         </p:nvSpPr>
@@ -7090,7 +9433,7 @@
       </p:sp>
       <p:sp>
         <p:nvSpPr>
-          <p:cNvPr id="23" name="Rectangle 22"/>
+          <p:cNvPr id="39" name="Rectangle 38"/>
           <p:cNvSpPr/>
           <p:nvPr/>
         </p:nvSpPr>
@@ -7134,7 +9477,7 @@
       </p:sp>
       <p:sp>
         <p:nvSpPr>
-          <p:cNvPr id="24" name="TextBox 23"/>
+          <p:cNvPr id="40" name="TextBox 39"/>
           <p:cNvSpPr txBox="1"/>
           <p:nvPr/>
         </p:nvSpPr>
@@ -7179,7 +9522,7 @@
       </p:sp>
       <p:sp>
         <p:nvSpPr>
-          <p:cNvPr id="25" name="TextBox 24"/>
+          <p:cNvPr id="41" name="TextBox 40"/>
           <p:cNvSpPr txBox="1"/>
           <p:nvPr/>
         </p:nvSpPr>
@@ -7224,7 +9567,7 @@
       </p:sp>
       <p:sp>
         <p:nvSpPr>
-          <p:cNvPr id="26" name="Rounded Rectangle 25"/>
+          <p:cNvPr id="42" name="Rounded Rectangle 41"/>
           <p:cNvSpPr/>
           <p:nvPr/>
         </p:nvSpPr>
@@ -7270,7 +9613,7 @@
       </p:sp>
       <p:sp>
         <p:nvSpPr>
-          <p:cNvPr id="27" name="Rectangle 26"/>
+          <p:cNvPr id="43" name="Rectangle 42"/>
           <p:cNvSpPr/>
           <p:nvPr/>
         </p:nvSpPr>
@@ -7314,7 +9657,7 @@
       </p:sp>
       <p:sp>
         <p:nvSpPr>
-          <p:cNvPr id="28" name="TextBox 27"/>
+          <p:cNvPr id="44" name="TextBox 43"/>
           <p:cNvSpPr txBox="1"/>
           <p:nvPr/>
         </p:nvSpPr>
@@ -7381,7 +9724,7 @@
       </p:sp>
       <p:sp>
         <p:nvSpPr>
-          <p:cNvPr id="29" name="Rounded Rectangle 28"/>
+          <p:cNvPr id="45" name="Rounded Rectangle 44"/>
           <p:cNvSpPr/>
           <p:nvPr/>
         </p:nvSpPr>
@@ -7427,7 +9770,7 @@
       </p:sp>
       <p:sp>
         <p:nvSpPr>
-          <p:cNvPr id="30" name="Rectangle 29"/>
+          <p:cNvPr id="46" name="Rectangle 45"/>
           <p:cNvSpPr/>
           <p:nvPr/>
         </p:nvSpPr>
@@ -7471,7 +9814,7 @@
       </p:sp>
       <p:sp>
         <p:nvSpPr>
-          <p:cNvPr id="31" name="TextBox 30"/>
+          <p:cNvPr id="47" name="TextBox 46"/>
           <p:cNvSpPr txBox="1"/>
           <p:nvPr/>
         </p:nvSpPr>
@@ -7538,7 +9881,7 @@
       </p:sp>
       <p:sp>
         <p:nvSpPr>
-          <p:cNvPr id="32" name="TextBox 31"/>
+          <p:cNvPr id="48" name="TextBox 47"/>
           <p:cNvSpPr txBox="1"/>
           <p:nvPr/>
         </p:nvSpPr>
@@ -7583,7 +9926,7 @@
       </p:sp>
       <p:sp>
         <p:nvSpPr>
-          <p:cNvPr id="33" name="TextBox 32"/>
+          <p:cNvPr id="49" name="TextBox 48"/>
           <p:cNvSpPr txBox="1"/>
           <p:nvPr/>
         </p:nvSpPr>
@@ -7628,7 +9971,7 @@
       </p:sp>
       <p:sp>
         <p:nvSpPr>
-          <p:cNvPr id="34" name="TextBox 33"/>
+          <p:cNvPr id="50" name="TextBox 49"/>
           <p:cNvSpPr txBox="1"/>
           <p:nvPr/>
         </p:nvSpPr>
@@ -22842,4 +25185,324 @@
   </a:objectDefaults>
   <a:extraClrSchemeLst/>
 </a:theme>
+</file>
+
+<file path=ppt/theme/theme2.xml><?xml version="1.0" encoding="utf-8"?>
+<a:theme xmlns:a="http://schemas.openxmlformats.org/drawingml/2006/main" name="Office Theme">
+  <a:themeElements>
+    <a:clrScheme name="Office">
+      <a:dk1>
+        <a:sysClr val="windowText" lastClr="000000"/>
+      </a:dk1>
+      <a:lt1>
+        <a:sysClr val="window" lastClr="FFFFFF"/>
+      </a:lt1>
+      <a:dk2>
+        <a:srgbClr val="1F497D"/>
+      </a:dk2>
+      <a:lt2>
+        <a:srgbClr val="EEECE1"/>
+      </a:lt2>
+      <a:accent1>
+        <a:srgbClr val="4F81BD"/>
+      </a:accent1>
+      <a:accent2>
+        <a:srgbClr val="C0504D"/>
+      </a:accent2>
+      <a:accent3>
+        <a:srgbClr val="9BBB59"/>
+      </a:accent3>
+      <a:accent4>
+        <a:srgbClr val="8064A2"/>
+      </a:accent4>
+      <a:accent5>
+        <a:srgbClr val="4BACC6"/>
+      </a:accent5>
+      <a:accent6>
+        <a:srgbClr val="F79646"/>
+      </a:accent6>
+      <a:hlink>
+        <a:srgbClr val="0000FF"/>
+      </a:hlink>
+      <a:folHlink>
+        <a:srgbClr val="800080"/>
+      </a:folHlink>
+    </a:clrScheme>
+    <a:fontScheme name="Office">
+      <a:majorFont>
+        <a:latin typeface="Calibri"/>
+        <a:ea typeface=""/>
+        <a:cs typeface=""/>
+        <a:font script="Jpan" typeface="ＭＳ Ｐゴシック"/>
+        <a:font script="Hang" typeface="맑은 고딕"/>
+        <a:font script="Hans" typeface="宋体"/>
+        <a:font script="Hant" typeface="新細明體"/>
+        <a:font script="Arab" typeface="Times New Roman"/>
+        <a:font script="Hebr" typeface="Times New Roman"/>
+        <a:font script="Thai" typeface="Angsana New"/>
+        <a:font script="Ethi" typeface="Nyala"/>
+        <a:font script="Beng" typeface="Vrinda"/>
+        <a:font script="Gujr" typeface="Shruti"/>
+        <a:font script="Khmr" typeface="MoolBoran"/>
+        <a:font script="Knda" typeface="Tunga"/>
+        <a:font script="Guru" typeface="Raavi"/>
+        <a:font script="Cans" typeface="Euphemia"/>
+        <a:font script="Cher" typeface="Plantagenet Cherokee"/>
+        <a:font script="Yiii" typeface="Microsoft Yi Baiti"/>
+        <a:font script="Tibt" typeface="Microsoft Himalaya"/>
+        <a:font script="Thaa" typeface="MV Boli"/>
+        <a:font script="Deva" typeface="Mangal"/>
+        <a:font script="Telu" typeface="Gautami"/>
+        <a:font script="Taml" typeface="Latha"/>
+        <a:font script="Syrc" typeface="Estrangelo Edessa"/>
+        <a:font script="Orya" typeface="Kalinga"/>
+        <a:font script="Mlym" typeface="Kartika"/>
+        <a:font script="Laoo" typeface="DokChampa"/>
+        <a:font script="Sinh" typeface="Iskoola Pota"/>
+        <a:font script="Mong" typeface="Mongolian Baiti"/>
+        <a:font script="Viet" typeface="Times New Roman"/>
+        <a:font script="Uigh" typeface="Microsoft Uighur"/>
+        <a:font script="Geor" typeface="Sylfaen"/>
+      </a:majorFont>
+      <a:minorFont>
+        <a:latin typeface="Calibri"/>
+        <a:ea typeface=""/>
+        <a:cs typeface=""/>
+        <a:font script="Jpan" typeface="ＭＳ Ｐゴシック"/>
+        <a:font script="Hang" typeface="맑은 고딕"/>
+        <a:font script="Hans" typeface="宋体"/>
+        <a:font script="Hant" typeface="新細明體"/>
+        <a:font script="Arab" typeface="Arial"/>
+        <a:font script="Hebr" typeface="Arial"/>
+        <a:font script="Thai" typeface="Cordia New"/>
+        <a:font script="Ethi" typeface="Nyala"/>
+        <a:font script="Beng" typeface="Vrinda"/>
+        <a:font script="Gujr" typeface="Shruti"/>
+        <a:font script="Khmr" typeface="DaunPenh"/>
+        <a:font script="Knda" typeface="Tunga"/>
+        <a:font script="Guru" typeface="Raavi"/>
+        <a:font script="Cans" typeface="Euphemia"/>
+        <a:font script="Cher" typeface="Plantagenet Cherokee"/>
+        <a:font script="Yiii" typeface="Microsoft Yi Baiti"/>
+        <a:font script="Tibt" typeface="Microsoft Himalaya"/>
+        <a:font script="Thaa" typeface="MV Boli"/>
+        <a:font script="Deva" typeface="Mangal"/>
+        <a:font script="Telu" typeface="Gautami"/>
+        <a:font script="Taml" typeface="Latha"/>
+        <a:font script="Syrc" typeface="Estrangelo Edessa"/>
+        <a:font script="Orya" typeface="Kalinga"/>
+        <a:font script="Mlym" typeface="Kartika"/>
+        <a:font script="Laoo" typeface="DokChampa"/>
+        <a:font script="Sinh" typeface="Iskoola Pota"/>
+        <a:font script="Mong" typeface="Mongolian Baiti"/>
+        <a:font script="Viet" typeface="Arial"/>
+        <a:font script="Uigh" typeface="Microsoft Uighur"/>
+        <a:font script="Geor" typeface="Sylfaen"/>
+      </a:minorFont>
+    </a:fontScheme>
+    <a:fmtScheme name="Office">
+      <a:fillStyleLst>
+        <a:solidFill>
+          <a:schemeClr val="phClr"/>
+        </a:solidFill>
+        <a:gradFill rotWithShape="1">
+          <a:gsLst>
+            <a:gs pos="0">
+              <a:schemeClr val="phClr">
+                <a:tint val="50000"/>
+                <a:satMod val="300000"/>
+              </a:schemeClr>
+            </a:gs>
+            <a:gs pos="35000">
+              <a:schemeClr val="phClr">
+                <a:tint val="37000"/>
+                <a:satMod val="300000"/>
+              </a:schemeClr>
+            </a:gs>
+            <a:gs pos="100000">
+              <a:schemeClr val="phClr">
+                <a:tint val="15000"/>
+                <a:satMod val="350000"/>
+              </a:schemeClr>
+            </a:gs>
+          </a:gsLst>
+          <a:lin ang="16200000" scaled="1"/>
+        </a:gradFill>
+        <a:gradFill rotWithShape="1">
+          <a:gsLst>
+            <a:gs pos="0">
+              <a:schemeClr val="phClr">
+                <a:tint val="100000"/>
+                <a:shade val="100000"/>
+                <a:satMod val="130000"/>
+              </a:schemeClr>
+            </a:gs>
+            <a:gs pos="100000">
+              <a:schemeClr val="phClr">
+                <a:tint val="50000"/>
+                <a:shade val="100000"/>
+                <a:satMod val="350000"/>
+              </a:schemeClr>
+            </a:gs>
+          </a:gsLst>
+          <a:lin ang="16200000" scaled="0"/>
+        </a:gradFill>
+      </a:fillStyleLst>
+      <a:lnStyleLst>
+        <a:ln w="9525" cap="flat" cmpd="sng" algn="ctr">
+          <a:solidFill>
+            <a:schemeClr val="phClr">
+              <a:shade val="95000"/>
+              <a:satMod val="105000"/>
+            </a:schemeClr>
+          </a:solidFill>
+          <a:prstDash val="solid"/>
+        </a:ln>
+        <a:ln w="25400" cap="flat" cmpd="sng" algn="ctr">
+          <a:solidFill>
+            <a:schemeClr val="phClr"/>
+          </a:solidFill>
+          <a:prstDash val="solid"/>
+        </a:ln>
+        <a:ln w="38100" cap="flat" cmpd="sng" algn="ctr">
+          <a:solidFill>
+            <a:schemeClr val="phClr"/>
+          </a:solidFill>
+          <a:prstDash val="solid"/>
+        </a:ln>
+      </a:lnStyleLst>
+      <a:effectStyleLst>
+        <a:effectStyle>
+          <a:effectLst>
+            <a:outerShdw blurRad="40000" dist="20000" dir="5400000" rotWithShape="0">
+              <a:srgbClr val="000000">
+                <a:alpha val="38000"/>
+              </a:srgbClr>
+            </a:outerShdw>
+          </a:effectLst>
+        </a:effectStyle>
+        <a:effectStyle>
+          <a:effectLst>
+            <a:outerShdw blurRad="40000" dist="23000" dir="5400000" rotWithShape="0">
+              <a:srgbClr val="000000">
+                <a:alpha val="35000"/>
+              </a:srgbClr>
+            </a:outerShdw>
+          </a:effectLst>
+        </a:effectStyle>
+        <a:effectStyle>
+          <a:effectLst>
+            <a:outerShdw blurRad="40000" dist="23000" dir="5400000" rotWithShape="0">
+              <a:srgbClr val="000000">
+                <a:alpha val="35000"/>
+              </a:srgbClr>
+            </a:outerShdw>
+          </a:effectLst>
+          <a:scene3d>
+            <a:camera prst="orthographicFront">
+              <a:rot lat="0" lon="0" rev="0"/>
+            </a:camera>
+            <a:lightRig rig="threePt" dir="t">
+              <a:rot lat="0" lon="0" rev="1200000"/>
+            </a:lightRig>
+          </a:scene3d>
+          <a:sp3d>
+            <a:bevelT w="63500" h="25400"/>
+          </a:sp3d>
+        </a:effectStyle>
+      </a:effectStyleLst>
+      <a:bgFillStyleLst>
+        <a:solidFill>
+          <a:schemeClr val="phClr"/>
+        </a:solidFill>
+        <a:gradFill rotWithShape="1">
+          <a:gsLst>
+            <a:gs pos="0">
+              <a:schemeClr val="phClr">
+                <a:tint val="40000"/>
+                <a:satMod val="350000"/>
+              </a:schemeClr>
+            </a:gs>
+            <a:gs pos="40000">
+              <a:schemeClr val="phClr">
+                <a:tint val="45000"/>
+                <a:shade val="99000"/>
+                <a:satMod val="350000"/>
+              </a:schemeClr>
+            </a:gs>
+            <a:gs pos="100000">
+              <a:schemeClr val="phClr">
+                <a:shade val="20000"/>
+                <a:satMod val="255000"/>
+              </a:schemeClr>
+            </a:gs>
+          </a:gsLst>
+          <a:path path="circle">
+            <a:fillToRect l="50000" t="-80000" r="50000" b="180000"/>
+          </a:path>
+        </a:gradFill>
+        <a:gradFill rotWithShape="1">
+          <a:gsLst>
+            <a:gs pos="0">
+              <a:schemeClr val="phClr">
+                <a:tint val="80000"/>
+                <a:satMod val="300000"/>
+              </a:schemeClr>
+            </a:gs>
+            <a:gs pos="100000">
+              <a:schemeClr val="phClr">
+                <a:shade val="30000"/>
+                <a:satMod val="200000"/>
+              </a:schemeClr>
+            </a:gs>
+          </a:gsLst>
+          <a:path path="circle">
+            <a:fillToRect l="50000" t="50000" r="50000" b="50000"/>
+          </a:path>
+        </a:gradFill>
+      </a:bgFillStyleLst>
+    </a:fmtScheme>
+  </a:themeElements>
+  <a:objectDefaults>
+    <a:spDef>
+      <a:spPr/>
+      <a:bodyPr/>
+      <a:lstStyle/>
+      <a:style>
+        <a:lnRef idx="1">
+          <a:schemeClr val="accent1"/>
+        </a:lnRef>
+        <a:fillRef idx="3">
+          <a:schemeClr val="accent1"/>
+        </a:fillRef>
+        <a:effectRef idx="2">
+          <a:schemeClr val="accent1"/>
+        </a:effectRef>
+        <a:fontRef idx="minor">
+          <a:schemeClr val="lt1"/>
+        </a:fontRef>
+      </a:style>
+    </a:spDef>
+    <a:lnDef>
+      <a:spPr/>
+      <a:bodyPr/>
+      <a:lstStyle/>
+      <a:style>
+        <a:lnRef idx="2">
+          <a:schemeClr val="accent1"/>
+        </a:lnRef>
+        <a:fillRef idx="0">
+          <a:schemeClr val="accent1"/>
+        </a:fillRef>
+        <a:effectRef idx="1">
+          <a:schemeClr val="accent1"/>
+        </a:effectRef>
+        <a:fontRef idx="minor">
+          <a:schemeClr val="tx1"/>
+        </a:fontRef>
+      </a:style>
+    </a:lnDef>
+  </a:objectDefaults>
+  <a:extraClrSchemeLst/>
+</a:theme>
 </file>
</xml_diff>

<commit_message>
docs(deck): add jjforge architecture diagram as appendix slide
New slide 18 (appendix): a component/data-flow diagram of jjforge —
clients (browser, jj fork CLI, jjf CLI) → Caddy → Forgejo fork (Go) and
the Rust sidecar, with the VCSBackend/JjBackend HTTP path, Postgres, and
content-addressed blob storage. Color-coded by language, with a flow
footnote. Includes a matching speaker note.

Co-Authored-By: Claude Opus 4.8 (1M context) <noreply@anthropic.com>
</commit_message>
<xml_diff>
--- a/sandcastle-tdd-deck.pptx
+++ b/sandcastle-tdd-deck.pptx
@@ -22,6 +22,7 @@
     <p:sldId id="270" r:id="rId21"/>
     <p:sldId id="271" r:id="rId22"/>
     <p:sldId id="272" r:id="rId23"/>
+    <p:sldId id="273" r:id="rId24"/>
   </p:sldIdLst>
   <p:sldSz cx="12191695" cy="6858000" type="screen4x3"/>
   <p:notesSz cx="6858000" cy="9144000"/>
@@ -1124,6 +1125,81 @@
           <a:p>
             <a:r>
               <a:t>Invite them in: it's on github (jjforge/sandcastle-tdd), built on @ai-hero/sandcastle. Open for questions — and I can show a live park→answer round-trip if there's interest.</a:t>
+            </a:r>
+          </a:p>
+        </p:txBody>
+      </p:sp>
+      <p:sp>
+        <p:nvSpPr>
+          <p:cNvPr id="4" name="Slide Number Placeholder 3"/>
+          <p:cNvSpPr>
+            <a:spLocks noGrp="1"/>
+          </p:cNvSpPr>
+          <p:nvPr>
+            <p:ph type="sldNum" idx="5" sz="quarter"/>
+          </p:nvPr>
+        </p:nvSpPr>
+        <p:spPr/>
+      </p:sp>
+    </p:spTree>
+  </p:cSld>
+  <p:clrMapOvr>
+    <a:masterClrMapping/>
+  </p:clrMapOvr>
+</p:notes>
+</file>
+
+<file path=ppt/notesSlides/notesSlide18.xml><?xml version="1.0" encoding="utf-8"?>
+<p:notes xmlns:a="http://schemas.openxmlformats.org/drawingml/2006/main" xmlns:p="http://schemas.openxmlformats.org/presentationml/2006/main" xmlns:r="http://schemas.openxmlformats.org/officeDocument/2006/relationships">
+  <p:cSld>
+    <p:spTree>
+      <p:nvGrpSpPr>
+        <p:cNvPr id="1" name=""/>
+        <p:cNvGrpSpPr/>
+        <p:nvPr/>
+      </p:nvGrpSpPr>
+      <p:grpSpPr>
+        <a:xfrm>
+          <a:off x="0" y="0"/>
+          <a:ext cx="0" cy="0"/>
+          <a:chOff x="0" y="0"/>
+          <a:chExt cx="0" cy="0"/>
+        </a:xfrm>
+      </p:grpSpPr>
+      <p:sp>
+        <p:nvSpPr>
+          <p:cNvPr id="2" name="Slide Image Placeholder 1"/>
+          <p:cNvSpPr>
+            <a:spLocks noGrp="1"/>
+          </p:cNvSpPr>
+          <p:nvPr>
+            <p:ph type="sldImg" idx="2"/>
+          </p:nvPr>
+        </p:nvSpPr>
+        <p:spPr/>
+      </p:sp>
+      <p:sp>
+        <p:nvSpPr>
+          <p:cNvPr id="3" name="Notes Placeholder 2"/>
+          <p:cNvSpPr>
+            <a:spLocks noGrp="1"/>
+          </p:cNvSpPr>
+          <p:nvPr>
+            <p:ph type="body" idx="3" sz="quarter"/>
+          </p:nvPr>
+        </p:nvSpPr>
+        <p:spPr/>
+        <p:txBody>
+          <a:bodyPr/>
+          <a:lstStyle/>
+          <a:p>
+            <a:r>
+              <a:t>Backup slide — pull it up only if someone asks 'what actually is jjforge?' or wants proof it's a serious target. It's jj-native repository hosting: push/pull/clone Jujutsu repos over a native sync protocol with no git-compat layer.</a:t>
+            </a:r>
+          </a:p>
+          <a:p>
+            <a:r>
+              <a:t>Four parts: a Forgejo fork (Go) for the web forge, a jj fork (Rust) for the CLI, a Rust sidecar that speaks the sync protocol and stores content-addressed blobs, and the jjf CLI. Browser and jjf CLI hit Forgejo; the jj CLI hits the sidecar. Forgejo dispatches all repo content through a VCSBackend interface — JjBackend calls the sidecar over HTTP; git hosting exists but is disabled. Both forks are vendored as git subtrees. Point: a full hosting stack where a green test genuinely protects people's version history.</a:t>
             </a:r>
           </a:p>
         </p:txBody>
@@ -15329,6 +15405,2064 @@
                 <a:latin typeface="Arial"/>
               </a:rPr>
               <a:t>Built on @ai-hero/sandcastle  ·  Questions?</a:t>
+            </a:r>
+          </a:p>
+        </p:txBody>
+      </p:sp>
+    </p:spTree>
+  </p:cSld>
+  <p:clrMapOvr>
+    <a:masterClrMapping/>
+  </p:clrMapOvr>
+</p:sld>
+</file>
+
+<file path=ppt/slides/slide18.xml><?xml version="1.0" encoding="utf-8"?>
+<p:sld xmlns:a="http://schemas.openxmlformats.org/drawingml/2006/main" xmlns:p="http://schemas.openxmlformats.org/presentationml/2006/main" xmlns:r="http://schemas.openxmlformats.org/officeDocument/2006/relationships">
+  <p:cSld>
+    <p:spTree>
+      <p:nvGrpSpPr>
+        <p:cNvPr id="1" name=""/>
+        <p:cNvGrpSpPr/>
+        <p:nvPr/>
+      </p:nvGrpSpPr>
+      <p:grpSpPr/>
+      <p:sp>
+        <p:nvSpPr>
+          <p:cNvPr id="2" name="Rectangle 1"/>
+          <p:cNvSpPr/>
+          <p:nvPr/>
+        </p:nvSpPr>
+        <p:spPr>
+          <a:xfrm>
+            <a:off x="0" y="0"/>
+            <a:ext cx="12191695" cy="6858000"/>
+          </a:xfrm>
+          <a:prstGeom prst="rect">
+            <a:avLst/>
+          </a:prstGeom>
+          <a:solidFill>
+            <a:srgbClr val="0F172A"/>
+          </a:solidFill>
+          <a:ln>
+            <a:noFill/>
+          </a:ln>
+          <a:effectLst/>
+        </p:spPr>
+        <p:style>
+          <a:lnRef idx="1">
+            <a:schemeClr val="accent1"/>
+          </a:lnRef>
+          <a:fillRef idx="3">
+            <a:schemeClr val="accent1"/>
+          </a:fillRef>
+          <a:effectRef idx="2">
+            <a:schemeClr val="accent1"/>
+          </a:effectRef>
+          <a:fontRef idx="minor">
+            <a:schemeClr val="lt1"/>
+          </a:fontRef>
+        </p:style>
+        <p:txBody>
+          <a:bodyPr rtlCol="0" anchor="ctr"/>
+          <a:lstStyle/>
+          <a:p>
+            <a:pPr algn="ctr"/>
+          </a:p>
+        </p:txBody>
+      </p:sp>
+      <p:sp>
+        <p:nvSpPr>
+          <p:cNvPr id="3" name="TextBox 2"/>
+          <p:cNvSpPr txBox="1"/>
+          <p:nvPr/>
+        </p:nvSpPr>
+        <p:spPr>
+          <a:xfrm>
+            <a:off x="640080" y="502920"/>
+            <a:ext cx="10881360" cy="365760"/>
+          </a:xfrm>
+          <a:prstGeom prst="rect">
+            <a:avLst/>
+          </a:prstGeom>
+          <a:noFill/>
+        </p:spPr>
+        <p:txBody>
+          <a:bodyPr wrap="square" anchor="t" lIns="0" rIns="0" tIns="0" bIns="0">
+            <a:spAutoFit/>
+          </a:bodyPr>
+          <a:lstStyle/>
+          <a:p>
+            <a:pPr algn="l">
+              <a:lnSpc>
+                <a:spcPct val="105000"/>
+              </a:lnSpc>
+              <a:spcBef>
+                <a:spcPts val="0"/>
+              </a:spcBef>
+              <a:spcAft>
+                <a:spcPts val="0"/>
+              </a:spcAft>
+            </a:pPr>
+            <a:r>
+              <a:rPr sz="1400" b="1" i="0">
+                <a:solidFill>
+                  <a:srgbClr val="F59E0B"/>
+                </a:solidFill>
+                <a:latin typeface="Arial"/>
+              </a:rPr>
+              <a:t>APPENDIX</a:t>
+            </a:r>
+          </a:p>
+        </p:txBody>
+      </p:sp>
+      <p:sp>
+        <p:nvSpPr>
+          <p:cNvPr id="4" name="TextBox 3"/>
+          <p:cNvSpPr txBox="1"/>
+          <p:nvPr/>
+        </p:nvSpPr>
+        <p:spPr>
+          <a:xfrm>
+            <a:off x="621792" y="822960"/>
+            <a:ext cx="10881360" cy="640080"/>
+          </a:xfrm>
+          <a:prstGeom prst="rect">
+            <a:avLst/>
+          </a:prstGeom>
+          <a:noFill/>
+        </p:spPr>
+        <p:txBody>
+          <a:bodyPr wrap="square" anchor="t" lIns="0" rIns="0" tIns="0" bIns="0">
+            <a:spAutoFit/>
+          </a:bodyPr>
+          <a:lstStyle/>
+          <a:p>
+            <a:pPr algn="l">
+              <a:lnSpc>
+                <a:spcPct val="105000"/>
+              </a:lnSpc>
+              <a:spcBef>
+                <a:spcPts val="0"/>
+              </a:spcBef>
+              <a:spcAft>
+                <a:spcPts val="0"/>
+              </a:spcAft>
+            </a:pPr>
+            <a:r>
+              <a:rPr sz="2700" b="1" i="0">
+                <a:solidFill>
+                  <a:srgbClr val="F8FAFC"/>
+                </a:solidFill>
+                <a:latin typeface="Arial"/>
+              </a:rPr>
+              <a:t>jjforge architecture — the target this ran against</a:t>
+            </a:r>
+          </a:p>
+        </p:txBody>
+      </p:sp>
+      <p:sp>
+        <p:nvSpPr>
+          <p:cNvPr id="5" name="Rectangle 4"/>
+          <p:cNvSpPr/>
+          <p:nvPr/>
+        </p:nvSpPr>
+        <p:spPr>
+          <a:xfrm>
+            <a:off x="640080" y="1417320"/>
+            <a:ext cx="1371600" cy="54864"/>
+          </a:xfrm>
+          <a:prstGeom prst="rect">
+            <a:avLst/>
+          </a:prstGeom>
+          <a:solidFill>
+            <a:srgbClr val="F59E0B"/>
+          </a:solidFill>
+          <a:ln>
+            <a:noFill/>
+          </a:ln>
+          <a:effectLst/>
+        </p:spPr>
+        <p:style>
+          <a:lnRef idx="1">
+            <a:schemeClr val="accent1"/>
+          </a:lnRef>
+          <a:fillRef idx="3">
+            <a:schemeClr val="accent1"/>
+          </a:fillRef>
+          <a:effectRef idx="2">
+            <a:schemeClr val="accent1"/>
+          </a:effectRef>
+          <a:fontRef idx="minor">
+            <a:schemeClr val="lt1"/>
+          </a:fontRef>
+        </p:style>
+        <p:txBody>
+          <a:bodyPr rtlCol="0" anchor="ctr"/>
+          <a:lstStyle/>
+          <a:p>
+            <a:pPr algn="ctr"/>
+          </a:p>
+        </p:txBody>
+      </p:sp>
+      <p:sp>
+        <p:nvSpPr>
+          <p:cNvPr id="6" name="Rectangle 5"/>
+          <p:cNvSpPr/>
+          <p:nvPr/>
+        </p:nvSpPr>
+        <p:spPr>
+          <a:xfrm>
+            <a:off x="9052560" y="566928"/>
+            <a:ext cx="201168" cy="201168"/>
+          </a:xfrm>
+          <a:prstGeom prst="rect">
+            <a:avLst/>
+          </a:prstGeom>
+          <a:solidFill>
+            <a:srgbClr val="38BDF8"/>
+          </a:solidFill>
+          <a:ln>
+            <a:noFill/>
+          </a:ln>
+          <a:effectLst/>
+        </p:spPr>
+        <p:style>
+          <a:lnRef idx="1">
+            <a:schemeClr val="accent1"/>
+          </a:lnRef>
+          <a:fillRef idx="3">
+            <a:schemeClr val="accent1"/>
+          </a:fillRef>
+          <a:effectRef idx="2">
+            <a:schemeClr val="accent1"/>
+          </a:effectRef>
+          <a:fontRef idx="minor">
+            <a:schemeClr val="lt1"/>
+          </a:fontRef>
+        </p:style>
+        <p:txBody>
+          <a:bodyPr rtlCol="0" anchor="ctr"/>
+          <a:lstStyle/>
+          <a:p>
+            <a:pPr algn="ctr"/>
+          </a:p>
+        </p:txBody>
+      </p:sp>
+      <p:sp>
+        <p:nvSpPr>
+          <p:cNvPr id="7" name="TextBox 6"/>
+          <p:cNvSpPr txBox="1"/>
+          <p:nvPr/>
+        </p:nvSpPr>
+        <p:spPr>
+          <a:xfrm>
+            <a:off x="9326880" y="548640"/>
+            <a:ext cx="914400" cy="274320"/>
+          </a:xfrm>
+          <a:prstGeom prst="rect">
+            <a:avLst/>
+          </a:prstGeom>
+          <a:noFill/>
+        </p:spPr>
+        <p:txBody>
+          <a:bodyPr wrap="square" anchor="t" lIns="0" rIns="0" tIns="0" bIns="0">
+            <a:spAutoFit/>
+          </a:bodyPr>
+          <a:lstStyle/>
+          <a:p>
+            <a:pPr algn="l">
+              <a:lnSpc>
+                <a:spcPct val="105000"/>
+              </a:lnSpc>
+              <a:spcBef>
+                <a:spcPts val="0"/>
+              </a:spcBef>
+              <a:spcAft>
+                <a:spcPts val="0"/>
+              </a:spcAft>
+            </a:pPr>
+            <a:r>
+              <a:rPr sz="1200" b="1" i="0">
+                <a:solidFill>
+                  <a:srgbClr val="94A3B8"/>
+                </a:solidFill>
+                <a:latin typeface="Arial"/>
+              </a:rPr>
+              <a:t>Go</a:t>
+            </a:r>
+          </a:p>
+        </p:txBody>
+      </p:sp>
+      <p:sp>
+        <p:nvSpPr>
+          <p:cNvPr id="8" name="Rectangle 7"/>
+          <p:cNvSpPr/>
+          <p:nvPr/>
+        </p:nvSpPr>
+        <p:spPr>
+          <a:xfrm>
+            <a:off x="9829800" y="566928"/>
+            <a:ext cx="201168" cy="201168"/>
+          </a:xfrm>
+          <a:prstGeom prst="rect">
+            <a:avLst/>
+          </a:prstGeom>
+          <a:solidFill>
+            <a:srgbClr val="F59E0B"/>
+          </a:solidFill>
+          <a:ln>
+            <a:noFill/>
+          </a:ln>
+          <a:effectLst/>
+        </p:spPr>
+        <p:style>
+          <a:lnRef idx="1">
+            <a:schemeClr val="accent1"/>
+          </a:lnRef>
+          <a:fillRef idx="3">
+            <a:schemeClr val="accent1"/>
+          </a:fillRef>
+          <a:effectRef idx="2">
+            <a:schemeClr val="accent1"/>
+          </a:effectRef>
+          <a:fontRef idx="minor">
+            <a:schemeClr val="lt1"/>
+          </a:fontRef>
+        </p:style>
+        <p:txBody>
+          <a:bodyPr rtlCol="0" anchor="ctr"/>
+          <a:lstStyle/>
+          <a:p>
+            <a:pPr algn="ctr"/>
+          </a:p>
+        </p:txBody>
+      </p:sp>
+      <p:sp>
+        <p:nvSpPr>
+          <p:cNvPr id="9" name="TextBox 8"/>
+          <p:cNvSpPr txBox="1"/>
+          <p:nvPr/>
+        </p:nvSpPr>
+        <p:spPr>
+          <a:xfrm>
+            <a:off x="10104120" y="548640"/>
+            <a:ext cx="1371600" cy="274320"/>
+          </a:xfrm>
+          <a:prstGeom prst="rect">
+            <a:avLst/>
+          </a:prstGeom>
+          <a:noFill/>
+        </p:spPr>
+        <p:txBody>
+          <a:bodyPr wrap="square" anchor="t" lIns="0" rIns="0" tIns="0" bIns="0">
+            <a:spAutoFit/>
+          </a:bodyPr>
+          <a:lstStyle/>
+          <a:p>
+            <a:pPr algn="l">
+              <a:lnSpc>
+                <a:spcPct val="105000"/>
+              </a:lnSpc>
+              <a:spcBef>
+                <a:spcPts val="0"/>
+              </a:spcBef>
+              <a:spcAft>
+                <a:spcPts val="0"/>
+              </a:spcAft>
+            </a:pPr>
+            <a:r>
+              <a:rPr sz="1200" b="1" i="0">
+                <a:solidFill>
+                  <a:srgbClr val="94A3B8"/>
+                </a:solidFill>
+                <a:latin typeface="Arial"/>
+              </a:rPr>
+              <a:t>Rust</a:t>
+            </a:r>
+          </a:p>
+        </p:txBody>
+      </p:sp>
+      <p:sp>
+        <p:nvSpPr>
+          <p:cNvPr id="10" name="Rounded Rectangle 9"/>
+          <p:cNvSpPr/>
+          <p:nvPr/>
+        </p:nvSpPr>
+        <p:spPr>
+          <a:xfrm>
+            <a:off x="640080" y="1691640"/>
+            <a:ext cx="3291840" cy="777240"/>
+          </a:xfrm>
+          <a:prstGeom prst="roundRect">
+            <a:avLst>
+              <a:gd name="adj" fmla="val 6000"/>
+            </a:avLst>
+          </a:prstGeom>
+          <a:solidFill>
+            <a:srgbClr val="1E293B"/>
+          </a:solidFill>
+          <a:ln w="12700">
+            <a:solidFill>
+              <a:srgbClr val="E2E8F0"/>
+            </a:solidFill>
+          </a:ln>
+          <a:effectLst/>
+        </p:spPr>
+        <p:style>
+          <a:lnRef idx="1">
+            <a:schemeClr val="accent1"/>
+          </a:lnRef>
+          <a:fillRef idx="3">
+            <a:schemeClr val="accent1"/>
+          </a:fillRef>
+          <a:effectRef idx="2">
+            <a:schemeClr val="accent1"/>
+          </a:effectRef>
+          <a:fontRef idx="minor">
+            <a:schemeClr val="lt1"/>
+          </a:fontRef>
+        </p:style>
+        <p:txBody>
+          <a:bodyPr rtlCol="0" anchor="ctr"/>
+          <a:lstStyle/>
+          <a:p>
+            <a:pPr algn="ctr"/>
+          </a:p>
+        </p:txBody>
+      </p:sp>
+      <p:sp>
+        <p:nvSpPr>
+          <p:cNvPr id="11" name="TextBox 10"/>
+          <p:cNvSpPr txBox="1"/>
+          <p:nvPr/>
+        </p:nvSpPr>
+        <p:spPr>
+          <a:xfrm>
+            <a:off x="640080" y="1810512"/>
+            <a:ext cx="3291840" cy="320040"/>
+          </a:xfrm>
+          <a:prstGeom prst="rect">
+            <a:avLst/>
+          </a:prstGeom>
+          <a:noFill/>
+        </p:spPr>
+        <p:txBody>
+          <a:bodyPr wrap="square" anchor="t" lIns="0" rIns="0" tIns="0" bIns="0">
+            <a:spAutoFit/>
+          </a:bodyPr>
+          <a:lstStyle/>
+          <a:p>
+            <a:pPr algn="ctr">
+              <a:lnSpc>
+                <a:spcPct val="105000"/>
+              </a:lnSpc>
+              <a:spcBef>
+                <a:spcPts val="0"/>
+              </a:spcBef>
+              <a:spcAft>
+                <a:spcPts val="0"/>
+              </a:spcAft>
+            </a:pPr>
+            <a:r>
+              <a:rPr sz="1400" b="1" i="0">
+                <a:solidFill>
+                  <a:srgbClr val="F8FAFC"/>
+                </a:solidFill>
+                <a:latin typeface="Arial"/>
+              </a:rPr>
+              <a:t>Web browser</a:t>
+            </a:r>
+          </a:p>
+        </p:txBody>
+      </p:sp>
+      <p:sp>
+        <p:nvSpPr>
+          <p:cNvPr id="12" name="TextBox 11"/>
+          <p:cNvSpPr txBox="1"/>
+          <p:nvPr/>
+        </p:nvSpPr>
+        <p:spPr>
+          <a:xfrm>
+            <a:off x="640080" y="2121408"/>
+            <a:ext cx="3291840" cy="274320"/>
+          </a:xfrm>
+          <a:prstGeom prst="rect">
+            <a:avLst/>
+          </a:prstGeom>
+          <a:noFill/>
+        </p:spPr>
+        <p:txBody>
+          <a:bodyPr wrap="square" anchor="t" lIns="0" rIns="0" tIns="0" bIns="0">
+            <a:spAutoFit/>
+          </a:bodyPr>
+          <a:lstStyle/>
+          <a:p>
+            <a:pPr algn="ctr">
+              <a:lnSpc>
+                <a:spcPct val="105000"/>
+              </a:lnSpc>
+              <a:spcBef>
+                <a:spcPts val="0"/>
+              </a:spcBef>
+              <a:spcAft>
+                <a:spcPts val="0"/>
+              </a:spcAft>
+            </a:pPr>
+            <a:r>
+              <a:rPr sz="1050" b="0" i="0">
+                <a:solidFill>
+                  <a:srgbClr val="94A3B8"/>
+                </a:solidFill>
+                <a:latin typeface="Arial"/>
+              </a:rPr>
+              <a:t>the web forge UI</a:t>
+            </a:r>
+          </a:p>
+        </p:txBody>
+      </p:sp>
+      <p:sp>
+        <p:nvSpPr>
+          <p:cNvPr id="13" name="Rounded Rectangle 12"/>
+          <p:cNvSpPr/>
+          <p:nvPr/>
+        </p:nvSpPr>
+        <p:spPr>
+          <a:xfrm>
+            <a:off x="4448556" y="1691640"/>
+            <a:ext cx="3291840" cy="777240"/>
+          </a:xfrm>
+          <a:prstGeom prst="roundRect">
+            <a:avLst>
+              <a:gd name="adj" fmla="val 6000"/>
+            </a:avLst>
+          </a:prstGeom>
+          <a:solidFill>
+            <a:srgbClr val="1E293B"/>
+          </a:solidFill>
+          <a:ln w="12700">
+            <a:solidFill>
+              <a:srgbClr val="F59E0B"/>
+            </a:solidFill>
+          </a:ln>
+          <a:effectLst/>
+        </p:spPr>
+        <p:style>
+          <a:lnRef idx="1">
+            <a:schemeClr val="accent1"/>
+          </a:lnRef>
+          <a:fillRef idx="3">
+            <a:schemeClr val="accent1"/>
+          </a:fillRef>
+          <a:effectRef idx="2">
+            <a:schemeClr val="accent1"/>
+          </a:effectRef>
+          <a:fontRef idx="minor">
+            <a:schemeClr val="lt1"/>
+          </a:fontRef>
+        </p:style>
+        <p:txBody>
+          <a:bodyPr rtlCol="0" anchor="ctr"/>
+          <a:lstStyle/>
+          <a:p>
+            <a:pPr algn="ctr"/>
+          </a:p>
+        </p:txBody>
+      </p:sp>
+      <p:sp>
+        <p:nvSpPr>
+          <p:cNvPr id="14" name="TextBox 13"/>
+          <p:cNvSpPr txBox="1"/>
+          <p:nvPr/>
+        </p:nvSpPr>
+        <p:spPr>
+          <a:xfrm>
+            <a:off x="4448556" y="1810512"/>
+            <a:ext cx="3291840" cy="320040"/>
+          </a:xfrm>
+          <a:prstGeom prst="rect">
+            <a:avLst/>
+          </a:prstGeom>
+          <a:noFill/>
+        </p:spPr>
+        <p:txBody>
+          <a:bodyPr wrap="square" anchor="t" lIns="0" rIns="0" tIns="0" bIns="0">
+            <a:spAutoFit/>
+          </a:bodyPr>
+          <a:lstStyle/>
+          <a:p>
+            <a:pPr algn="ctr">
+              <a:lnSpc>
+                <a:spcPct val="105000"/>
+              </a:lnSpc>
+              <a:spcBef>
+                <a:spcPts val="0"/>
+              </a:spcBef>
+              <a:spcAft>
+                <a:spcPts val="0"/>
+              </a:spcAft>
+            </a:pPr>
+            <a:r>
+              <a:rPr sz="1400" b="1" i="0">
+                <a:solidFill>
+                  <a:srgbClr val="F8FAFC"/>
+                </a:solidFill>
+                <a:latin typeface="Arial"/>
+              </a:rPr>
+              <a:t>jj fork  ·  Rust</a:t>
+            </a:r>
+          </a:p>
+        </p:txBody>
+      </p:sp>
+      <p:sp>
+        <p:nvSpPr>
+          <p:cNvPr id="15" name="TextBox 14"/>
+          <p:cNvSpPr txBox="1"/>
+          <p:nvPr/>
+        </p:nvSpPr>
+        <p:spPr>
+          <a:xfrm>
+            <a:off x="4448556" y="2121408"/>
+            <a:ext cx="3291840" cy="274320"/>
+          </a:xfrm>
+          <a:prstGeom prst="rect">
+            <a:avLst/>
+          </a:prstGeom>
+          <a:noFill/>
+        </p:spPr>
+        <p:txBody>
+          <a:bodyPr wrap="square" anchor="t" lIns="0" rIns="0" tIns="0" bIns="0">
+            <a:spAutoFit/>
+          </a:bodyPr>
+          <a:lstStyle/>
+          <a:p>
+            <a:pPr algn="ctr">
+              <a:lnSpc>
+                <a:spcPct val="105000"/>
+              </a:lnSpc>
+              <a:spcBef>
+                <a:spcPts val="0"/>
+              </a:spcBef>
+              <a:spcAft>
+                <a:spcPts val="0"/>
+              </a:spcAft>
+            </a:pPr>
+            <a:r>
+              <a:rPr sz="1050" b="0" i="0">
+                <a:solidFill>
+                  <a:srgbClr val="94A3B8"/>
+                </a:solidFill>
+                <a:latin typeface="Arial"/>
+              </a:rPr>
+              <a:t>jj forge push / pull / clone</a:t>
+            </a:r>
+          </a:p>
+        </p:txBody>
+      </p:sp>
+      <p:sp>
+        <p:nvSpPr>
+          <p:cNvPr id="16" name="Rounded Rectangle 15"/>
+          <p:cNvSpPr/>
+          <p:nvPr/>
+        </p:nvSpPr>
+        <p:spPr>
+          <a:xfrm>
+            <a:off x="8257032" y="1691640"/>
+            <a:ext cx="3291840" cy="777240"/>
+          </a:xfrm>
+          <a:prstGeom prst="roundRect">
+            <a:avLst>
+              <a:gd name="adj" fmla="val 6000"/>
+            </a:avLst>
+          </a:prstGeom>
+          <a:solidFill>
+            <a:srgbClr val="1E293B"/>
+          </a:solidFill>
+          <a:ln w="12700">
+            <a:solidFill>
+              <a:srgbClr val="C084FC"/>
+            </a:solidFill>
+          </a:ln>
+          <a:effectLst/>
+        </p:spPr>
+        <p:style>
+          <a:lnRef idx="1">
+            <a:schemeClr val="accent1"/>
+          </a:lnRef>
+          <a:fillRef idx="3">
+            <a:schemeClr val="accent1"/>
+          </a:fillRef>
+          <a:effectRef idx="2">
+            <a:schemeClr val="accent1"/>
+          </a:effectRef>
+          <a:fontRef idx="minor">
+            <a:schemeClr val="lt1"/>
+          </a:fontRef>
+        </p:style>
+        <p:txBody>
+          <a:bodyPr rtlCol="0" anchor="ctr"/>
+          <a:lstStyle/>
+          <a:p>
+            <a:pPr algn="ctr"/>
+          </a:p>
+        </p:txBody>
+      </p:sp>
+      <p:sp>
+        <p:nvSpPr>
+          <p:cNvPr id="17" name="TextBox 16"/>
+          <p:cNvSpPr txBox="1"/>
+          <p:nvPr/>
+        </p:nvSpPr>
+        <p:spPr>
+          <a:xfrm>
+            <a:off x="8257032" y="1810512"/>
+            <a:ext cx="3291840" cy="320040"/>
+          </a:xfrm>
+          <a:prstGeom prst="rect">
+            <a:avLst/>
+          </a:prstGeom>
+          <a:noFill/>
+        </p:spPr>
+        <p:txBody>
+          <a:bodyPr wrap="square" anchor="t" lIns="0" rIns="0" tIns="0" bIns="0">
+            <a:spAutoFit/>
+          </a:bodyPr>
+          <a:lstStyle/>
+          <a:p>
+            <a:pPr algn="ctr">
+              <a:lnSpc>
+                <a:spcPct val="105000"/>
+              </a:lnSpc>
+              <a:spcBef>
+                <a:spcPts val="0"/>
+              </a:spcBef>
+              <a:spcAft>
+                <a:spcPts val="0"/>
+              </a:spcAft>
+            </a:pPr>
+            <a:r>
+              <a:rPr sz="1400" b="1" i="0">
+                <a:solidFill>
+                  <a:srgbClr val="F8FAFC"/>
+                </a:solidFill>
+                <a:latin typeface="Arial"/>
+              </a:rPr>
+              <a:t>jjf CLI</a:t>
+            </a:r>
+          </a:p>
+        </p:txBody>
+      </p:sp>
+      <p:sp>
+        <p:nvSpPr>
+          <p:cNvPr id="18" name="TextBox 17"/>
+          <p:cNvSpPr txBox="1"/>
+          <p:nvPr/>
+        </p:nvSpPr>
+        <p:spPr>
+          <a:xfrm>
+            <a:off x="8257032" y="2121408"/>
+            <a:ext cx="3291840" cy="274320"/>
+          </a:xfrm>
+          <a:prstGeom prst="rect">
+            <a:avLst/>
+          </a:prstGeom>
+          <a:noFill/>
+        </p:spPr>
+        <p:txBody>
+          <a:bodyPr wrap="square" anchor="t" lIns="0" rIns="0" tIns="0" bIns="0">
+            <a:spAutoFit/>
+          </a:bodyPr>
+          <a:lstStyle/>
+          <a:p>
+            <a:pPr algn="ctr">
+              <a:lnSpc>
+                <a:spcPct val="105000"/>
+              </a:lnSpc>
+              <a:spcBef>
+                <a:spcPts val="0"/>
+              </a:spcBef>
+              <a:spcAft>
+                <a:spcPts val="0"/>
+              </a:spcAft>
+            </a:pPr>
+            <a:r>
+              <a:rPr sz="1050" b="0" i="0">
+                <a:solidFill>
+                  <a:srgbClr val="94A3B8"/>
+                </a:solidFill>
+                <a:latin typeface="Arial"/>
+              </a:rPr>
+              <a:t>platform ops: repos, issues, reviews</a:t>
+            </a:r>
+          </a:p>
+        </p:txBody>
+      </p:sp>
+      <p:sp>
+        <p:nvSpPr>
+          <p:cNvPr id="19" name="TextBox 18"/>
+          <p:cNvSpPr txBox="1"/>
+          <p:nvPr/>
+        </p:nvSpPr>
+        <p:spPr>
+          <a:xfrm>
+            <a:off x="640080" y="1463040"/>
+            <a:ext cx="5486400" cy="201168"/>
+          </a:xfrm>
+          <a:prstGeom prst="rect">
+            <a:avLst/>
+          </a:prstGeom>
+          <a:noFill/>
+        </p:spPr>
+        <p:txBody>
+          <a:bodyPr wrap="square" anchor="t" lIns="0" rIns="0" tIns="0" bIns="0">
+            <a:spAutoFit/>
+          </a:bodyPr>
+          <a:lstStyle/>
+          <a:p>
+            <a:pPr algn="l">
+              <a:lnSpc>
+                <a:spcPct val="105000"/>
+              </a:lnSpc>
+              <a:spcBef>
+                <a:spcPts val="0"/>
+              </a:spcBef>
+              <a:spcAft>
+                <a:spcPts val="0"/>
+              </a:spcAft>
+            </a:pPr>
+            <a:r>
+              <a:rPr sz="1000" b="1" i="0">
+                <a:solidFill>
+                  <a:srgbClr val="94A3B8"/>
+                </a:solidFill>
+                <a:latin typeface="Arial"/>
+              </a:rPr>
+              <a:t>CLIENTS</a:t>
+            </a:r>
+          </a:p>
+        </p:txBody>
+      </p:sp>
+      <p:sp>
+        <p:nvSpPr>
+          <p:cNvPr id="20" name="Rounded Rectangle 19"/>
+          <p:cNvSpPr/>
+          <p:nvPr/>
+        </p:nvSpPr>
+        <p:spPr>
+          <a:xfrm>
+            <a:off x="640080" y="2880360"/>
+            <a:ext cx="10908792" cy="475488"/>
+          </a:xfrm>
+          <a:prstGeom prst="roundRect">
+            <a:avLst>
+              <a:gd name="adj" fmla="val 5000"/>
+            </a:avLst>
+          </a:prstGeom>
+          <a:solidFill>
+            <a:srgbClr val="162133"/>
+          </a:solidFill>
+          <a:ln w="9525">
+            <a:solidFill>
+              <a:srgbClr val="94A3B8"/>
+            </a:solidFill>
+          </a:ln>
+          <a:effectLst/>
+        </p:spPr>
+        <p:style>
+          <a:lnRef idx="1">
+            <a:schemeClr val="accent1"/>
+          </a:lnRef>
+          <a:fillRef idx="3">
+            <a:schemeClr val="accent1"/>
+          </a:fillRef>
+          <a:effectRef idx="2">
+            <a:schemeClr val="accent1"/>
+          </a:effectRef>
+          <a:fontRef idx="minor">
+            <a:schemeClr val="lt1"/>
+          </a:fontRef>
+        </p:style>
+        <p:txBody>
+          <a:bodyPr rtlCol="0" anchor="ctr"/>
+          <a:lstStyle/>
+          <a:p>
+            <a:pPr algn="ctr"/>
+          </a:p>
+        </p:txBody>
+      </p:sp>
+      <p:sp>
+        <p:nvSpPr>
+          <p:cNvPr id="21" name="TextBox 20"/>
+          <p:cNvSpPr txBox="1"/>
+          <p:nvPr/>
+        </p:nvSpPr>
+        <p:spPr>
+          <a:xfrm>
+            <a:off x="640080" y="2880360"/>
+            <a:ext cx="10908792" cy="475488"/>
+          </a:xfrm>
+          <a:prstGeom prst="rect">
+            <a:avLst/>
+          </a:prstGeom>
+          <a:noFill/>
+        </p:spPr>
+        <p:txBody>
+          <a:bodyPr wrap="square" anchor="ctr" lIns="0" rIns="0" tIns="0" bIns="0">
+            <a:spAutoFit/>
+          </a:bodyPr>
+          <a:lstStyle/>
+          <a:p>
+            <a:pPr algn="ctr">
+              <a:lnSpc>
+                <a:spcPct val="105000"/>
+              </a:lnSpc>
+              <a:spcBef>
+                <a:spcPts val="0"/>
+              </a:spcBef>
+              <a:spcAft>
+                <a:spcPts val="0"/>
+              </a:spcAft>
+            </a:pPr>
+            <a:r>
+              <a:rPr sz="1400" b="1" i="0">
+                <a:solidFill>
+                  <a:srgbClr val="F8FAFC"/>
+                </a:solidFill>
+                <a:latin typeface="Arial"/>
+              </a:rPr>
+              <a:t>Caddy</a:t>
+            </a:r>
+            <a:r>
+              <a:rPr sz="1250" b="0" i="0">
+                <a:solidFill>
+                  <a:srgbClr val="94A3B8"/>
+                </a:solidFill>
+                <a:latin typeface="Arial"/>
+              </a:rPr>
+              <a:t>   —   reverse proxy · TLS ingress</a:t>
+            </a:r>
+          </a:p>
+        </p:txBody>
+      </p:sp>
+      <p:sp>
+        <p:nvSpPr>
+          <p:cNvPr id="22" name="Rounded Rectangle 21"/>
+          <p:cNvSpPr/>
+          <p:nvPr/>
+        </p:nvSpPr>
+        <p:spPr>
+          <a:xfrm>
+            <a:off x="640080" y="3611880"/>
+            <a:ext cx="5532120" cy="1554480"/>
+          </a:xfrm>
+          <a:prstGeom prst="roundRect">
+            <a:avLst>
+              <a:gd name="adj" fmla="val 5000"/>
+            </a:avLst>
+          </a:prstGeom>
+          <a:solidFill>
+            <a:srgbClr val="1E293B"/>
+          </a:solidFill>
+          <a:ln w="16510">
+            <a:solidFill>
+              <a:srgbClr val="38BDF8"/>
+            </a:solidFill>
+          </a:ln>
+          <a:effectLst/>
+        </p:spPr>
+        <p:style>
+          <a:lnRef idx="1">
+            <a:schemeClr val="accent1"/>
+          </a:lnRef>
+          <a:fillRef idx="3">
+            <a:schemeClr val="accent1"/>
+          </a:fillRef>
+          <a:effectRef idx="2">
+            <a:schemeClr val="accent1"/>
+          </a:effectRef>
+          <a:fontRef idx="minor">
+            <a:schemeClr val="lt1"/>
+          </a:fontRef>
+        </p:style>
+        <p:txBody>
+          <a:bodyPr rtlCol="0" anchor="ctr"/>
+          <a:lstStyle/>
+          <a:p>
+            <a:pPr algn="ctr"/>
+          </a:p>
+        </p:txBody>
+      </p:sp>
+      <p:sp>
+        <p:nvSpPr>
+          <p:cNvPr id="23" name="TextBox 22"/>
+          <p:cNvSpPr txBox="1"/>
+          <p:nvPr/>
+        </p:nvSpPr>
+        <p:spPr>
+          <a:xfrm>
+            <a:off x="868680" y="3730752"/>
+            <a:ext cx="5120640" cy="365760"/>
+          </a:xfrm>
+          <a:prstGeom prst="rect">
+            <a:avLst/>
+          </a:prstGeom>
+          <a:noFill/>
+        </p:spPr>
+        <p:txBody>
+          <a:bodyPr wrap="square" anchor="t" lIns="0" rIns="0" tIns="0" bIns="0">
+            <a:spAutoFit/>
+          </a:bodyPr>
+          <a:lstStyle/>
+          <a:p>
+            <a:pPr algn="l">
+              <a:lnSpc>
+                <a:spcPct val="105000"/>
+              </a:lnSpc>
+              <a:spcBef>
+                <a:spcPts val="0"/>
+              </a:spcBef>
+              <a:spcAft>
+                <a:spcPts val="0"/>
+              </a:spcAft>
+            </a:pPr>
+            <a:r>
+              <a:rPr sz="1500" b="1" i="0">
+                <a:solidFill>
+                  <a:srgbClr val="F8FAFC"/>
+                </a:solidFill>
+                <a:latin typeface="Arial"/>
+              </a:rPr>
+              <a:t>Forgejo fork</a:t>
+            </a:r>
+            <a:r>
+              <a:rPr sz="1100" b="0" i="0">
+                <a:solidFill>
+                  <a:srgbClr val="38BDF8"/>
+                </a:solidFill>
+                <a:latin typeface="Arial"/>
+              </a:rPr>
+              <a:t>   Go · git subtree</a:t>
+            </a:r>
+          </a:p>
+        </p:txBody>
+      </p:sp>
+      <p:sp>
+        <p:nvSpPr>
+          <p:cNvPr id="24" name="TextBox 23"/>
+          <p:cNvSpPr txBox="1"/>
+          <p:nvPr/>
+        </p:nvSpPr>
+        <p:spPr>
+          <a:xfrm>
+            <a:off x="868680" y="4096512"/>
+            <a:ext cx="5120640" cy="365760"/>
+          </a:xfrm>
+          <a:prstGeom prst="rect">
+            <a:avLst/>
+          </a:prstGeom>
+          <a:noFill/>
+        </p:spPr>
+        <p:txBody>
+          <a:bodyPr wrap="square" anchor="t" lIns="0" rIns="0" tIns="0" bIns="0">
+            <a:spAutoFit/>
+          </a:bodyPr>
+          <a:lstStyle/>
+          <a:p>
+            <a:pPr algn="l">
+              <a:lnSpc>
+                <a:spcPct val="105000"/>
+              </a:lnSpc>
+              <a:spcBef>
+                <a:spcPts val="0"/>
+              </a:spcBef>
+              <a:spcAft>
+                <a:spcPts val="0"/>
+              </a:spcAft>
+            </a:pPr>
+            <a:r>
+              <a:rPr sz="1100" b="0" i="0">
+                <a:solidFill>
+                  <a:srgbClr val="94A3B8"/>
+                </a:solidFill>
+                <a:latin typeface="Arial"/>
+              </a:rPr>
+              <a:t>web UI · auth · issues · change-based code review</a:t>
+            </a:r>
+          </a:p>
+        </p:txBody>
+      </p:sp>
+      <p:sp>
+        <p:nvSpPr>
+          <p:cNvPr id="25" name="Rounded Rectangle 24"/>
+          <p:cNvSpPr/>
+          <p:nvPr/>
+        </p:nvSpPr>
+        <p:spPr>
+          <a:xfrm>
+            <a:off x="868680" y="4434840"/>
+            <a:ext cx="5074920" cy="621792"/>
+          </a:xfrm>
+          <a:prstGeom prst="roundRect">
+            <a:avLst>
+              <a:gd name="adj" fmla="val 8000"/>
+            </a:avLst>
+          </a:prstGeom>
+          <a:solidFill>
+            <a:srgbClr val="162133"/>
+          </a:solidFill>
+          <a:ln w="9525">
+            <a:solidFill>
+              <a:srgbClr val="94A3B8"/>
+            </a:solidFill>
+          </a:ln>
+          <a:effectLst/>
+        </p:spPr>
+        <p:style>
+          <a:lnRef idx="1">
+            <a:schemeClr val="accent1"/>
+          </a:lnRef>
+          <a:fillRef idx="3">
+            <a:schemeClr val="accent1"/>
+          </a:fillRef>
+          <a:effectRef idx="2">
+            <a:schemeClr val="accent1"/>
+          </a:effectRef>
+          <a:fontRef idx="minor">
+            <a:schemeClr val="lt1"/>
+          </a:fontRef>
+        </p:style>
+        <p:txBody>
+          <a:bodyPr rtlCol="0" anchor="ctr"/>
+          <a:lstStyle/>
+          <a:p>
+            <a:pPr algn="ctr"/>
+          </a:p>
+        </p:txBody>
+      </p:sp>
+      <p:sp>
+        <p:nvSpPr>
+          <p:cNvPr id="26" name="TextBox 25"/>
+          <p:cNvSpPr txBox="1"/>
+          <p:nvPr/>
+        </p:nvSpPr>
+        <p:spPr>
+          <a:xfrm>
+            <a:off x="1005840" y="4434840"/>
+            <a:ext cx="4846320" cy="621792"/>
+          </a:xfrm>
+          <a:prstGeom prst="rect">
+            <a:avLst/>
+          </a:prstGeom>
+          <a:noFill/>
+        </p:spPr>
+        <p:txBody>
+          <a:bodyPr wrap="square" anchor="ctr" lIns="0" rIns="0" tIns="0" bIns="0">
+            <a:spAutoFit/>
+          </a:bodyPr>
+          <a:lstStyle/>
+          <a:p>
+            <a:pPr algn="l">
+              <a:lnSpc>
+                <a:spcPct val="105000"/>
+              </a:lnSpc>
+              <a:spcBef>
+                <a:spcPts val="0"/>
+              </a:spcBef>
+              <a:spcAft>
+                <a:spcPts val="0"/>
+              </a:spcAft>
+            </a:pPr>
+            <a:r>
+              <a:rPr sz="1100" b="1" i="0">
+                <a:solidFill>
+                  <a:srgbClr val="F59E0B"/>
+                </a:solidFill>
+                <a:latin typeface="Arial"/>
+              </a:rPr>
+              <a:t>VCSBackend interface</a:t>
+            </a:r>
+          </a:p>
+          <a:p>
+            <a:pPr algn="l">
+              <a:lnSpc>
+                <a:spcPct val="105000"/>
+              </a:lnSpc>
+              <a:spcBef>
+                <a:spcPts val="0"/>
+              </a:spcBef>
+              <a:spcAft>
+                <a:spcPts val="0"/>
+              </a:spcAft>
+            </a:pPr>
+            <a:r>
+              <a:rPr sz="1000" b="0" i="0">
+                <a:solidFill>
+                  <a:srgbClr val="94A3B8"/>
+                </a:solidFill>
+                <a:latin typeface="Arial"/>
+              </a:rPr>
+              <a:t>JjBackend (active) · GitBackend (present, unreachable)</a:t>
+            </a:r>
+          </a:p>
+        </p:txBody>
+      </p:sp>
+      <p:sp>
+        <p:nvSpPr>
+          <p:cNvPr id="27" name="Rounded Rectangle 26"/>
+          <p:cNvSpPr/>
+          <p:nvPr/>
+        </p:nvSpPr>
+        <p:spPr>
+          <a:xfrm>
+            <a:off x="6355080" y="3611880"/>
+            <a:ext cx="5193792" cy="1554480"/>
+          </a:xfrm>
+          <a:prstGeom prst="roundRect">
+            <a:avLst>
+              <a:gd name="adj" fmla="val 5000"/>
+            </a:avLst>
+          </a:prstGeom>
+          <a:solidFill>
+            <a:srgbClr val="1E293B"/>
+          </a:solidFill>
+          <a:ln w="16510">
+            <a:solidFill>
+              <a:srgbClr val="F59E0B"/>
+            </a:solidFill>
+          </a:ln>
+          <a:effectLst/>
+        </p:spPr>
+        <p:style>
+          <a:lnRef idx="1">
+            <a:schemeClr val="accent1"/>
+          </a:lnRef>
+          <a:fillRef idx="3">
+            <a:schemeClr val="accent1"/>
+          </a:fillRef>
+          <a:effectRef idx="2">
+            <a:schemeClr val="accent1"/>
+          </a:effectRef>
+          <a:fontRef idx="minor">
+            <a:schemeClr val="lt1"/>
+          </a:fontRef>
+        </p:style>
+        <p:txBody>
+          <a:bodyPr rtlCol="0" anchor="ctr"/>
+          <a:lstStyle/>
+          <a:p>
+            <a:pPr algn="ctr"/>
+          </a:p>
+        </p:txBody>
+      </p:sp>
+      <p:sp>
+        <p:nvSpPr>
+          <p:cNvPr id="28" name="TextBox 27"/>
+          <p:cNvSpPr txBox="1"/>
+          <p:nvPr/>
+        </p:nvSpPr>
+        <p:spPr>
+          <a:xfrm>
+            <a:off x="6583680" y="3730752"/>
+            <a:ext cx="4754880" cy="365760"/>
+          </a:xfrm>
+          <a:prstGeom prst="rect">
+            <a:avLst/>
+          </a:prstGeom>
+          <a:noFill/>
+        </p:spPr>
+        <p:txBody>
+          <a:bodyPr wrap="square" anchor="t" lIns="0" rIns="0" tIns="0" bIns="0">
+            <a:spAutoFit/>
+          </a:bodyPr>
+          <a:lstStyle/>
+          <a:p>
+            <a:pPr algn="l">
+              <a:lnSpc>
+                <a:spcPct val="105000"/>
+              </a:lnSpc>
+              <a:spcBef>
+                <a:spcPts val="0"/>
+              </a:spcBef>
+              <a:spcAft>
+                <a:spcPts val="0"/>
+              </a:spcAft>
+            </a:pPr>
+            <a:r>
+              <a:rPr sz="1500" b="1" i="0">
+                <a:solidFill>
+                  <a:srgbClr val="F8FAFC"/>
+                </a:solidFill>
+                <a:latin typeface="Arial"/>
+              </a:rPr>
+              <a:t>Sidecar</a:t>
+            </a:r>
+            <a:r>
+              <a:rPr sz="1100" b="0" i="0">
+                <a:solidFill>
+                  <a:srgbClr val="F59E0B"/>
+                </a:solidFill>
+                <a:latin typeface="Arial"/>
+              </a:rPr>
+              <a:t>   Rust</a:t>
+            </a:r>
+          </a:p>
+        </p:txBody>
+      </p:sp>
+      <p:sp>
+        <p:nvSpPr>
+          <p:cNvPr id="29" name="TextBox 28"/>
+          <p:cNvSpPr txBox="1"/>
+          <p:nvPr/>
+        </p:nvSpPr>
+        <p:spPr>
+          <a:xfrm>
+            <a:off x="6583680" y="4114800"/>
+            <a:ext cx="4800600" cy="914400"/>
+          </a:xfrm>
+          <a:prstGeom prst="rect">
+            <a:avLst/>
+          </a:prstGeom>
+          <a:noFill/>
+        </p:spPr>
+        <p:txBody>
+          <a:bodyPr wrap="square" anchor="t" lIns="0" rIns="0" tIns="0" bIns="0">
+            <a:spAutoFit/>
+          </a:bodyPr>
+          <a:lstStyle/>
+          <a:p>
+            <a:pPr algn="l">
+              <a:lnSpc>
+                <a:spcPct val="128000"/>
+              </a:lnSpc>
+              <a:spcBef>
+                <a:spcPts val="0"/>
+              </a:spcBef>
+              <a:spcAft>
+                <a:spcPts val="0"/>
+              </a:spcAft>
+            </a:pPr>
+            <a:r>
+              <a:rPr sz="1150" b="0" i="0">
+                <a:solidFill>
+                  <a:srgbClr val="E2E8F0"/>
+                </a:solidFill>
+                <a:latin typeface="Arial"/>
+              </a:rPr>
+              <a:t>• jj sync protocol — push / pull / clone</a:t>
+            </a:r>
+          </a:p>
+          <a:p>
+            <a:pPr algn="l">
+              <a:lnSpc>
+                <a:spcPct val="128000"/>
+              </a:lnSpc>
+              <a:spcBef>
+                <a:spcPts val="0"/>
+              </a:spcBef>
+              <a:spcAft>
+                <a:spcPts val="0"/>
+              </a:spcAft>
+            </a:pPr>
+            <a:r>
+              <a:rPr sz="1150" b="0" i="0">
+                <a:solidFill>
+                  <a:srgbClr val="E2E8F0"/>
+                </a:solidFill>
+                <a:latin typeface="Arial"/>
+              </a:rPr>
+              <a:t>• browse API for the forge UI</a:t>
+            </a:r>
+          </a:p>
+          <a:p>
+            <a:pPr algn="l">
+              <a:lnSpc>
+                <a:spcPct val="128000"/>
+              </a:lnSpc>
+              <a:spcBef>
+                <a:spcPts val="0"/>
+              </a:spcBef>
+              <a:spcAft>
+                <a:spcPts val="0"/>
+              </a:spcAft>
+            </a:pPr>
+            <a:r>
+              <a:rPr sz="1150" b="0" i="0">
+                <a:solidFill>
+                  <a:srgbClr val="E2E8F0"/>
+                </a:solidFill>
+                <a:latin typeface="Arial"/>
+              </a:rPr>
+              <a:t>• content-addressed blob storage</a:t>
+            </a:r>
+          </a:p>
+        </p:txBody>
+      </p:sp>
+      <p:sp>
+        <p:nvSpPr>
+          <p:cNvPr id="30" name="Rounded Rectangle 29"/>
+          <p:cNvSpPr/>
+          <p:nvPr/>
+        </p:nvSpPr>
+        <p:spPr>
+          <a:xfrm>
+            <a:off x="640080" y="5349240"/>
+            <a:ext cx="5532120" cy="731520"/>
+          </a:xfrm>
+          <a:prstGeom prst="roundRect">
+            <a:avLst>
+              <a:gd name="adj" fmla="val 5000"/>
+            </a:avLst>
+          </a:prstGeom>
+          <a:solidFill>
+            <a:srgbClr val="162133"/>
+          </a:solidFill>
+          <a:ln w="9525">
+            <a:solidFill>
+              <a:srgbClr val="94A3B8"/>
+            </a:solidFill>
+          </a:ln>
+          <a:effectLst/>
+        </p:spPr>
+        <p:style>
+          <a:lnRef idx="1">
+            <a:schemeClr val="accent1"/>
+          </a:lnRef>
+          <a:fillRef idx="3">
+            <a:schemeClr val="accent1"/>
+          </a:fillRef>
+          <a:effectRef idx="2">
+            <a:schemeClr val="accent1"/>
+          </a:effectRef>
+          <a:fontRef idx="minor">
+            <a:schemeClr val="lt1"/>
+          </a:fontRef>
+        </p:style>
+        <p:txBody>
+          <a:bodyPr rtlCol="0" anchor="ctr"/>
+          <a:lstStyle/>
+          <a:p>
+            <a:pPr algn="ctr"/>
+          </a:p>
+        </p:txBody>
+      </p:sp>
+      <p:sp>
+        <p:nvSpPr>
+          <p:cNvPr id="31" name="TextBox 30"/>
+          <p:cNvSpPr txBox="1"/>
+          <p:nvPr/>
+        </p:nvSpPr>
+        <p:spPr>
+          <a:xfrm>
+            <a:off x="640080" y="5349240"/>
+            <a:ext cx="5532120" cy="731520"/>
+          </a:xfrm>
+          <a:prstGeom prst="rect">
+            <a:avLst/>
+          </a:prstGeom>
+          <a:noFill/>
+        </p:spPr>
+        <p:txBody>
+          <a:bodyPr wrap="square" anchor="ctr" lIns="0" rIns="0" tIns="0" bIns="0">
+            <a:spAutoFit/>
+          </a:bodyPr>
+          <a:lstStyle/>
+          <a:p>
+            <a:pPr algn="ctr">
+              <a:lnSpc>
+                <a:spcPct val="105000"/>
+              </a:lnSpc>
+              <a:spcBef>
+                <a:spcPts val="0"/>
+              </a:spcBef>
+              <a:spcAft>
+                <a:spcPts val="0"/>
+              </a:spcAft>
+            </a:pPr>
+            <a:r>
+              <a:rPr sz="1300" b="1" i="0">
+                <a:solidFill>
+                  <a:srgbClr val="F8FAFC"/>
+                </a:solidFill>
+                <a:latin typeface="Arial"/>
+              </a:rPr>
+              <a:t>PostgreSQL</a:t>
+            </a:r>
+          </a:p>
+          <a:p>
+            <a:pPr algn="ctr">
+              <a:lnSpc>
+                <a:spcPct val="105000"/>
+              </a:lnSpc>
+              <a:spcBef>
+                <a:spcPts val="0"/>
+              </a:spcBef>
+              <a:spcAft>
+                <a:spcPts val="0"/>
+              </a:spcAft>
+            </a:pPr>
+            <a:r>
+              <a:rPr sz="1050" b="0" i="0">
+                <a:solidFill>
+                  <a:srgbClr val="94A3B8"/>
+                </a:solidFill>
+                <a:latin typeface="Arial"/>
+              </a:rPr>
+              <a:t>forge metadata: users, issues, reviews</a:t>
+            </a:r>
+          </a:p>
+        </p:txBody>
+      </p:sp>
+      <p:sp>
+        <p:nvSpPr>
+          <p:cNvPr id="32" name="Rounded Rectangle 31"/>
+          <p:cNvSpPr/>
+          <p:nvPr/>
+        </p:nvSpPr>
+        <p:spPr>
+          <a:xfrm>
+            <a:off x="6355080" y="5349240"/>
+            <a:ext cx="5193792" cy="731520"/>
+          </a:xfrm>
+          <a:prstGeom prst="roundRect">
+            <a:avLst>
+              <a:gd name="adj" fmla="val 5000"/>
+            </a:avLst>
+          </a:prstGeom>
+          <a:solidFill>
+            <a:srgbClr val="162133"/>
+          </a:solidFill>
+          <a:ln w="9525">
+            <a:solidFill>
+              <a:srgbClr val="94A3B8"/>
+            </a:solidFill>
+          </a:ln>
+          <a:effectLst/>
+        </p:spPr>
+        <p:style>
+          <a:lnRef idx="1">
+            <a:schemeClr val="accent1"/>
+          </a:lnRef>
+          <a:fillRef idx="3">
+            <a:schemeClr val="accent1"/>
+          </a:fillRef>
+          <a:effectRef idx="2">
+            <a:schemeClr val="accent1"/>
+          </a:effectRef>
+          <a:fontRef idx="minor">
+            <a:schemeClr val="lt1"/>
+          </a:fontRef>
+        </p:style>
+        <p:txBody>
+          <a:bodyPr rtlCol="0" anchor="ctr"/>
+          <a:lstStyle/>
+          <a:p>
+            <a:pPr algn="ctr"/>
+          </a:p>
+        </p:txBody>
+      </p:sp>
+      <p:sp>
+        <p:nvSpPr>
+          <p:cNvPr id="33" name="TextBox 32"/>
+          <p:cNvSpPr txBox="1"/>
+          <p:nvPr/>
+        </p:nvSpPr>
+        <p:spPr>
+          <a:xfrm>
+            <a:off x="6355080" y="5349240"/>
+            <a:ext cx="5193792" cy="731520"/>
+          </a:xfrm>
+          <a:prstGeom prst="rect">
+            <a:avLst/>
+          </a:prstGeom>
+          <a:noFill/>
+        </p:spPr>
+        <p:txBody>
+          <a:bodyPr wrap="square" anchor="ctr" lIns="0" rIns="0" tIns="0" bIns="0">
+            <a:spAutoFit/>
+          </a:bodyPr>
+          <a:lstStyle/>
+          <a:p>
+            <a:pPr algn="ctr">
+              <a:lnSpc>
+                <a:spcPct val="105000"/>
+              </a:lnSpc>
+              <a:spcBef>
+                <a:spcPts val="0"/>
+              </a:spcBef>
+              <a:spcAft>
+                <a:spcPts val="0"/>
+              </a:spcAft>
+            </a:pPr>
+            <a:r>
+              <a:rPr sz="1300" b="1" i="0">
+                <a:solidFill>
+                  <a:srgbClr val="F8FAFC"/>
+                </a:solidFill>
+                <a:latin typeface="Arial"/>
+              </a:rPr>
+              <a:t>Blob storage</a:t>
+            </a:r>
+          </a:p>
+          <a:p>
+            <a:pPr algn="ctr">
+              <a:lnSpc>
+                <a:spcPct val="105000"/>
+              </a:lnSpc>
+              <a:spcBef>
+                <a:spcPts val="0"/>
+              </a:spcBef>
+              <a:spcAft>
+                <a:spcPts val="0"/>
+              </a:spcAft>
+            </a:pPr>
+            <a:r>
+              <a:rPr sz="1050" b="0" i="0">
+                <a:solidFill>
+                  <a:srgbClr val="94A3B8"/>
+                </a:solidFill>
+                <a:latin typeface="Arial"/>
+              </a:rPr>
+              <a:t>content-addressed object store</a:t>
+            </a:r>
+          </a:p>
+        </p:txBody>
+      </p:sp>
+      <p:cxnSp>
+        <p:nvCxnSpPr>
+          <p:cNvPr id="34" name="Connector 33"/>
+          <p:cNvCxnSpPr/>
+          <p:nvPr/>
+        </p:nvCxnSpPr>
+        <p:spPr>
+          <a:xfrm>
+            <a:off x="2286000" y="2468880"/>
+            <a:ext cx="0" cy="411480"/>
+          </a:xfrm>
+          <a:prstGeom prst="bentConnector3">
+            <a:avLst/>
+          </a:prstGeom>
+          <a:ln w="16510">
+            <a:solidFill>
+              <a:srgbClr val="38BDF8"/>
+            </a:solidFill>
+            <a:tailEnd type="triangle" w="med" len="med"/>
+          </a:ln>
+          <a:effectLst/>
+        </p:spPr>
+        <p:style>
+          <a:lnRef idx="2">
+            <a:schemeClr val="accent1"/>
+          </a:lnRef>
+          <a:fillRef idx="0">
+            <a:schemeClr val="accent1"/>
+          </a:fillRef>
+          <a:effectRef idx="1">
+            <a:schemeClr val="accent1"/>
+          </a:effectRef>
+          <a:fontRef idx="minor">
+            <a:schemeClr val="tx1"/>
+          </a:fontRef>
+        </p:style>
+      </p:cxnSp>
+      <p:cxnSp>
+        <p:nvCxnSpPr>
+          <p:cNvPr id="35" name="Connector 34"/>
+          <p:cNvCxnSpPr/>
+          <p:nvPr/>
+        </p:nvCxnSpPr>
+        <p:spPr>
+          <a:xfrm>
+            <a:off x="6089904" y="2468880"/>
+            <a:ext cx="0" cy="411480"/>
+          </a:xfrm>
+          <a:prstGeom prst="bentConnector3">
+            <a:avLst/>
+          </a:prstGeom>
+          <a:ln w="16510">
+            <a:solidFill>
+              <a:srgbClr val="F59E0B"/>
+            </a:solidFill>
+            <a:tailEnd type="triangle" w="med" len="med"/>
+          </a:ln>
+          <a:effectLst/>
+        </p:spPr>
+        <p:style>
+          <a:lnRef idx="2">
+            <a:schemeClr val="accent1"/>
+          </a:lnRef>
+          <a:fillRef idx="0">
+            <a:schemeClr val="accent1"/>
+          </a:fillRef>
+          <a:effectRef idx="1">
+            <a:schemeClr val="accent1"/>
+          </a:effectRef>
+          <a:fontRef idx="minor">
+            <a:schemeClr val="tx1"/>
+          </a:fontRef>
+        </p:style>
+      </p:cxnSp>
+      <p:cxnSp>
+        <p:nvCxnSpPr>
+          <p:cNvPr id="36" name="Connector 35"/>
+          <p:cNvCxnSpPr/>
+          <p:nvPr/>
+        </p:nvCxnSpPr>
+        <p:spPr>
+          <a:xfrm>
+            <a:off x="9893808" y="2468880"/>
+            <a:ext cx="0" cy="411480"/>
+          </a:xfrm>
+          <a:prstGeom prst="bentConnector3">
+            <a:avLst/>
+          </a:prstGeom>
+          <a:ln w="16510">
+            <a:solidFill>
+              <a:srgbClr val="C084FC"/>
+            </a:solidFill>
+            <a:tailEnd type="triangle" w="med" len="med"/>
+          </a:ln>
+          <a:effectLst/>
+        </p:spPr>
+        <p:style>
+          <a:lnRef idx="2">
+            <a:schemeClr val="accent1"/>
+          </a:lnRef>
+          <a:fillRef idx="0">
+            <a:schemeClr val="accent1"/>
+          </a:fillRef>
+          <a:effectRef idx="1">
+            <a:schemeClr val="accent1"/>
+          </a:effectRef>
+          <a:fontRef idx="minor">
+            <a:schemeClr val="tx1"/>
+          </a:fontRef>
+        </p:style>
+      </p:cxnSp>
+      <p:cxnSp>
+        <p:nvCxnSpPr>
+          <p:cNvPr id="37" name="Connector 36"/>
+          <p:cNvCxnSpPr/>
+          <p:nvPr/>
+        </p:nvCxnSpPr>
+        <p:spPr>
+          <a:xfrm>
+            <a:off x="3383280" y="3355848"/>
+            <a:ext cx="0" cy="256032"/>
+          </a:xfrm>
+          <a:prstGeom prst="bentConnector3">
+            <a:avLst/>
+          </a:prstGeom>
+          <a:ln w="16510">
+            <a:solidFill>
+              <a:srgbClr val="94A3B8"/>
+            </a:solidFill>
+            <a:tailEnd type="triangle" w="med" len="med"/>
+          </a:ln>
+          <a:effectLst/>
+        </p:spPr>
+        <p:style>
+          <a:lnRef idx="2">
+            <a:schemeClr val="accent1"/>
+          </a:lnRef>
+          <a:fillRef idx="0">
+            <a:schemeClr val="accent1"/>
+          </a:fillRef>
+          <a:effectRef idx="1">
+            <a:schemeClr val="accent1"/>
+          </a:effectRef>
+          <a:fontRef idx="minor">
+            <a:schemeClr val="tx1"/>
+          </a:fontRef>
+        </p:style>
+      </p:cxnSp>
+      <p:cxnSp>
+        <p:nvCxnSpPr>
+          <p:cNvPr id="38" name="Connector 37"/>
+          <p:cNvCxnSpPr/>
+          <p:nvPr/>
+        </p:nvCxnSpPr>
+        <p:spPr>
+          <a:xfrm>
+            <a:off x="8961120" y="3355848"/>
+            <a:ext cx="0" cy="256032"/>
+          </a:xfrm>
+          <a:prstGeom prst="bentConnector3">
+            <a:avLst/>
+          </a:prstGeom>
+          <a:ln w="16510">
+            <a:solidFill>
+              <a:srgbClr val="94A3B8"/>
+            </a:solidFill>
+            <a:tailEnd type="triangle" w="med" len="med"/>
+          </a:ln>
+          <a:effectLst/>
+        </p:spPr>
+        <p:style>
+          <a:lnRef idx="2">
+            <a:schemeClr val="accent1"/>
+          </a:lnRef>
+          <a:fillRef idx="0">
+            <a:schemeClr val="accent1"/>
+          </a:fillRef>
+          <a:effectRef idx="1">
+            <a:schemeClr val="accent1"/>
+          </a:effectRef>
+          <a:fontRef idx="minor">
+            <a:schemeClr val="tx1"/>
+          </a:fontRef>
+        </p:style>
+      </p:cxnSp>
+      <p:cxnSp>
+        <p:nvCxnSpPr>
+          <p:cNvPr id="39" name="Connector 38"/>
+          <p:cNvCxnSpPr/>
+          <p:nvPr/>
+        </p:nvCxnSpPr>
+        <p:spPr>
+          <a:xfrm>
+            <a:off x="5943600" y="4745736"/>
+            <a:ext cx="411480" cy="0"/>
+          </a:xfrm>
+          <a:prstGeom prst="bentConnector3">
+            <a:avLst/>
+          </a:prstGeom>
+          <a:ln w="16510">
+            <a:solidFill>
+              <a:srgbClr val="F59E0B"/>
+            </a:solidFill>
+            <a:tailEnd type="triangle" w="med" len="med"/>
+          </a:ln>
+          <a:effectLst/>
+        </p:spPr>
+        <p:style>
+          <a:lnRef idx="2">
+            <a:schemeClr val="accent1"/>
+          </a:lnRef>
+          <a:fillRef idx="0">
+            <a:schemeClr val="accent1"/>
+          </a:fillRef>
+          <a:effectRef idx="1">
+            <a:schemeClr val="accent1"/>
+          </a:effectRef>
+          <a:fontRef idx="minor">
+            <a:schemeClr val="tx1"/>
+          </a:fontRef>
+        </p:style>
+      </p:cxnSp>
+      <p:cxnSp>
+        <p:nvCxnSpPr>
+          <p:cNvPr id="40" name="Connector 39"/>
+          <p:cNvCxnSpPr/>
+          <p:nvPr/>
+        </p:nvCxnSpPr>
+        <p:spPr>
+          <a:xfrm>
+            <a:off x="3383280" y="5166360"/>
+            <a:ext cx="0" cy="182880"/>
+          </a:xfrm>
+          <a:prstGeom prst="bentConnector3">
+            <a:avLst/>
+          </a:prstGeom>
+          <a:ln w="16510">
+            <a:solidFill>
+              <a:srgbClr val="94A3B8"/>
+            </a:solidFill>
+            <a:tailEnd type="triangle" w="med" len="med"/>
+          </a:ln>
+          <a:effectLst/>
+        </p:spPr>
+        <p:style>
+          <a:lnRef idx="2">
+            <a:schemeClr val="accent1"/>
+          </a:lnRef>
+          <a:fillRef idx="0">
+            <a:schemeClr val="accent1"/>
+          </a:fillRef>
+          <a:effectRef idx="1">
+            <a:schemeClr val="accent1"/>
+          </a:effectRef>
+          <a:fontRef idx="minor">
+            <a:schemeClr val="tx1"/>
+          </a:fontRef>
+        </p:style>
+      </p:cxnSp>
+      <p:cxnSp>
+        <p:nvCxnSpPr>
+          <p:cNvPr id="41" name="Connector 40"/>
+          <p:cNvCxnSpPr/>
+          <p:nvPr/>
+        </p:nvCxnSpPr>
+        <p:spPr>
+          <a:xfrm>
+            <a:off x="8961120" y="5166360"/>
+            <a:ext cx="0" cy="182880"/>
+          </a:xfrm>
+          <a:prstGeom prst="bentConnector3">
+            <a:avLst/>
+          </a:prstGeom>
+          <a:ln w="16510">
+            <a:solidFill>
+              <a:srgbClr val="94A3B8"/>
+            </a:solidFill>
+            <a:tailEnd type="triangle" w="med" len="med"/>
+          </a:ln>
+          <a:effectLst/>
+        </p:spPr>
+        <p:style>
+          <a:lnRef idx="2">
+            <a:schemeClr val="accent1"/>
+          </a:lnRef>
+          <a:fillRef idx="0">
+            <a:schemeClr val="accent1"/>
+          </a:fillRef>
+          <a:effectRef idx="1">
+            <a:schemeClr val="accent1"/>
+          </a:effectRef>
+          <a:fontRef idx="minor">
+            <a:schemeClr val="tx1"/>
+          </a:fontRef>
+        </p:style>
+      </p:cxnSp>
+      <p:sp>
+        <p:nvSpPr>
+          <p:cNvPr id="42" name="TextBox 41"/>
+          <p:cNvSpPr txBox="1"/>
+          <p:nvPr/>
+        </p:nvSpPr>
+        <p:spPr>
+          <a:xfrm>
+            <a:off x="4709160" y="4480560"/>
+            <a:ext cx="1737360" cy="228600"/>
+          </a:xfrm>
+          <a:prstGeom prst="rect">
+            <a:avLst/>
+          </a:prstGeom>
+          <a:noFill/>
+        </p:spPr>
+        <p:txBody>
+          <a:bodyPr wrap="square" anchor="t" lIns="0" rIns="0" tIns="0" bIns="0">
+            <a:spAutoFit/>
+          </a:bodyPr>
+          <a:lstStyle/>
+          <a:p>
+            <a:pPr algn="ctr">
+              <a:lnSpc>
+                <a:spcPct val="105000"/>
+              </a:lnSpc>
+              <a:spcBef>
+                <a:spcPts val="0"/>
+              </a:spcBef>
+              <a:spcAft>
+                <a:spcPts val="0"/>
+              </a:spcAft>
+            </a:pPr>
+            <a:r>
+              <a:rPr sz="850" b="1" i="0">
+                <a:solidFill>
+                  <a:srgbClr val="F59E0B"/>
+                </a:solidFill>
+                <a:latin typeface="Arial"/>
+              </a:rPr>
+              <a:t>JjBackend</a:t>
+            </a:r>
+          </a:p>
+        </p:txBody>
+      </p:sp>
+      <p:sp>
+        <p:nvSpPr>
+          <p:cNvPr id="43" name="TextBox 42"/>
+          <p:cNvSpPr txBox="1"/>
+          <p:nvPr/>
+        </p:nvSpPr>
+        <p:spPr>
+          <a:xfrm>
+            <a:off x="640080" y="6199632"/>
+            <a:ext cx="10908792" cy="365760"/>
+          </a:xfrm>
+          <a:prstGeom prst="rect">
+            <a:avLst/>
+          </a:prstGeom>
+          <a:noFill/>
+        </p:spPr>
+        <p:txBody>
+          <a:bodyPr wrap="square" anchor="t" lIns="0" rIns="0" tIns="0" bIns="0">
+            <a:spAutoFit/>
+          </a:bodyPr>
+          <a:lstStyle/>
+          <a:p>
+            <a:pPr algn="l">
+              <a:lnSpc>
+                <a:spcPct val="105000"/>
+              </a:lnSpc>
+              <a:spcBef>
+                <a:spcPts val="0"/>
+              </a:spcBef>
+              <a:spcAft>
+                <a:spcPts val="0"/>
+              </a:spcAft>
+            </a:pPr>
+            <a:r>
+              <a:rPr sz="1050" b="1" i="0">
+                <a:solidFill>
+                  <a:srgbClr val="F59E0B"/>
+                </a:solidFill>
+                <a:latin typeface="Arial"/>
+              </a:rPr>
+              <a:t>Flow: </a:t>
+            </a:r>
+            <a:r>
+              <a:rPr sz="1050" b="0" i="0">
+                <a:solidFill>
+                  <a:srgbClr val="94A3B8"/>
+                </a:solidFill>
+                <a:latin typeface="Arial"/>
+              </a:rPr>
+              <a:t>browser &amp; jjf CLI → Forgejo; jj CLI → sidecar (native jj sync, no git-compat layer). Forgejo's JjBackend calls the sidecar's HTTP API for all repo content — git hosting is present but disabled. Both forks are vendored as git subtrees.</a:t>
+            </a:r>
+          </a:p>
+        </p:txBody>
+      </p:sp>
+      <p:sp>
+        <p:nvSpPr>
+          <p:cNvPr id="44" name="TextBox 43"/>
+          <p:cNvSpPr txBox="1"/>
+          <p:nvPr/>
+        </p:nvSpPr>
+        <p:spPr>
+          <a:xfrm>
+            <a:off x="640080" y="6528816"/>
+            <a:ext cx="7315200" cy="274320"/>
+          </a:xfrm>
+          <a:prstGeom prst="rect">
+            <a:avLst/>
+          </a:prstGeom>
+          <a:noFill/>
+        </p:spPr>
+        <p:txBody>
+          <a:bodyPr wrap="square" anchor="t" lIns="0" rIns="0" tIns="0" bIns="0">
+            <a:spAutoFit/>
+          </a:bodyPr>
+          <a:lstStyle/>
+          <a:p>
+            <a:pPr algn="l">
+              <a:lnSpc>
+                <a:spcPct val="105000"/>
+              </a:lnSpc>
+              <a:spcBef>
+                <a:spcPts val="0"/>
+              </a:spcBef>
+              <a:spcAft>
+                <a:spcPts val="0"/>
+              </a:spcAft>
+            </a:pPr>
+            <a:r>
+              <a:rPr sz="1000" b="0" i="0">
+                <a:solidFill>
+                  <a:srgbClr val="94A3B8"/>
+                </a:solidFill>
+                <a:latin typeface="Consolas"/>
+              </a:rPr>
+              <a:t>sandcastle-tdd  ·  appendix</a:t>
             </a:r>
           </a:p>
         </p:txBody>

</xml_diff>

<commit_message>
docs(deck): add status dashboard slide and a build timeline
Insert two slides after Campaign mode (now 20 slides):
- 'A live status dashboard' — the status command, wave/issue chips,
  inline parked answers, and mobile/tailnet use, as three feature cards.
- 'What we built, and when' — a four-milestone timeline (Aug 16 -> 19)
  from the orchestrator through campaign mode, the deck, and the dashboard.

Both carry speaker notes; footer page numbers renumbered across the deck.

Co-Authored-By: Claude Opus 4.8 (1M context) <noreply@anthropic.com>
</commit_message>
<xml_diff>
--- a/sandcastle-tdd-deck.pptx
+++ b/sandcastle-tdd-deck.pptx
@@ -15,6 +15,8 @@
     <p:sldId id="263" r:id="rId14"/>
     <p:sldId id="264" r:id="rId15"/>
     <p:sldId id="265" r:id="rId16"/>
+    <p:sldId id="274" r:id="rId26"/>
+    <p:sldId id="275" r:id="rId27"/>
     <p:sldId id="266" r:id="rId17"/>
     <p:sldId id="267" r:id="rId18"/>
     <p:sldId id="268" r:id="rId19"/>
@@ -1224,6 +1226,76 @@
 </p:notes>
 </file>
 
+<file path=ppt/notesSlides/notesSlide19.xml><?xml version="1.0" encoding="utf-8"?>
+<p:notes xmlns:a="http://schemas.openxmlformats.org/drawingml/2006/main" xmlns:p="http://schemas.openxmlformats.org/presentationml/2006/main" xmlns:r="http://schemas.openxmlformats.org/officeDocument/2006/relationships">
+  <p:cSld>
+    <p:spTree>
+      <p:nvGrpSpPr>
+        <p:cNvPr id="1" name=""/>
+        <p:cNvGrpSpPr/>
+        <p:nvPr/>
+      </p:nvGrpSpPr>
+      <p:grpSpPr>
+        <a:xfrm>
+          <a:off x="0" y="0"/>
+          <a:ext cx="0" cy="0"/>
+          <a:chOff x="0" y="0"/>
+          <a:chExt cx="0" cy="0"/>
+        </a:xfrm>
+      </p:grpSpPr>
+      <p:sp>
+        <p:nvSpPr>
+          <p:cNvPr id="2" name="Slide Image Placeholder 1"/>
+          <p:cNvSpPr>
+            <a:spLocks noGrp="1"/>
+          </p:cNvSpPr>
+          <p:nvPr>
+            <p:ph type="sldImg" idx="2"/>
+          </p:nvPr>
+        </p:nvSpPr>
+        <p:spPr/>
+      </p:sp>
+      <p:sp>
+        <p:nvSpPr>
+          <p:cNvPr id="3" name="Notes Placeholder 2"/>
+          <p:cNvSpPr>
+            <a:spLocks noGrp="1"/>
+          </p:cNvSpPr>
+          <p:nvPr>
+            <p:ph type="body" idx="3" sz="quarter"/>
+          </p:nvPr>
+        </p:nvSpPr>
+        <p:spPr/>
+        <p:txBody>
+          <a:bodyPr/>
+          <a:lstStyle/>
+          <a:p>
+            <a:r>
+              <a:t>This is the newest addition: a status command that serves a local dashboard for a running campaign. It's deliberately thin — it reads the orchestrator's JSONL event log and the parked/ records, and the only thing it writes is your answer to a parked task, which it hands to the same 'answer' path the CLI uses. Left card: every wave and issue is a chip color-coded by state; closed waves collapse to a green check so the active work is what you see. Middle card: parked issues — the only thing that needs a human — float to the top with a count badge; you answer inline and the dispatcher resumes that agent. Right card: it's usable from a phone on the tailnet, auto-refresh is a checkbox, and the refresh won't fire while you're mid-reply. The point: it's a read-only lens plus one write, not a second system to keep alive.</a:t>
+            </a:r>
+          </a:p>
+        </p:txBody>
+      </p:sp>
+      <p:sp>
+        <p:nvSpPr>
+          <p:cNvPr id="4" name="Slide Number Placeholder 3"/>
+          <p:cNvSpPr>
+            <a:spLocks noGrp="1"/>
+          </p:cNvSpPr>
+          <p:nvPr>
+            <p:ph type="sldNum" idx="5" sz="quarter"/>
+          </p:nvPr>
+        </p:nvSpPr>
+        <p:spPr/>
+      </p:sp>
+    </p:spTree>
+  </p:cSld>
+  <p:clrMapOvr>
+    <a:masterClrMapping/>
+  </p:clrMapOvr>
+</p:notes>
+</file>
+
 <file path=ppt/notesSlides/notesSlide2.xml><?xml version="1.0" encoding="utf-8"?>
 <p:notes xmlns:a="http://schemas.openxmlformats.org/drawingml/2006/main" xmlns:p="http://schemas.openxmlformats.org/presentationml/2006/main" xmlns:r="http://schemas.openxmlformats.org/officeDocument/2006/relationships">
   <p:cSld>
@@ -1275,6 +1347,76 @@
           <a:p>
             <a:r>
               <a:t>Line to land: the bottleneck moved from 'can I build it' to 'do I know what I want.' Everything after this hangs on one of these two hooks.</a:t>
+            </a:r>
+          </a:p>
+        </p:txBody>
+      </p:sp>
+      <p:sp>
+        <p:nvSpPr>
+          <p:cNvPr id="4" name="Slide Number Placeholder 3"/>
+          <p:cNvSpPr>
+            <a:spLocks noGrp="1"/>
+          </p:cNvSpPr>
+          <p:nvPr>
+            <p:ph type="sldNum" idx="5" sz="quarter"/>
+          </p:nvPr>
+        </p:nvSpPr>
+        <p:spPr/>
+      </p:sp>
+    </p:spTree>
+  </p:cSld>
+  <p:clrMapOvr>
+    <a:masterClrMapping/>
+  </p:clrMapOvr>
+</p:notes>
+</file>
+
+<file path=ppt/notesSlides/notesSlide20.xml><?xml version="1.0" encoding="utf-8"?>
+<p:notes xmlns:a="http://schemas.openxmlformats.org/drawingml/2006/main" xmlns:p="http://schemas.openxmlformats.org/presentationml/2006/main" xmlns:r="http://schemas.openxmlformats.org/officeDocument/2006/relationships">
+  <p:cSld>
+    <p:spTree>
+      <p:nvGrpSpPr>
+        <p:cNvPr id="1" name=""/>
+        <p:cNvGrpSpPr/>
+        <p:nvPr/>
+      </p:nvGrpSpPr>
+      <p:grpSpPr>
+        <a:xfrm>
+          <a:off x="0" y="0"/>
+          <a:ext cx="0" cy="0"/>
+          <a:chOff x="0" y="0"/>
+          <a:chExt cx="0" cy="0"/>
+        </a:xfrm>
+      </p:grpSpPr>
+      <p:sp>
+        <p:nvSpPr>
+          <p:cNvPr id="2" name="Slide Image Placeholder 1"/>
+          <p:cNvSpPr>
+            <a:spLocks noGrp="1"/>
+          </p:cNvSpPr>
+          <p:nvPr>
+            <p:ph type="sldImg" idx="2"/>
+          </p:nvPr>
+        </p:nvSpPr>
+        <p:spPr/>
+      </p:sp>
+      <p:sp>
+        <p:nvSpPr>
+          <p:cNvPr id="3" name="Notes Placeholder 2"/>
+          <p:cNvSpPr>
+            <a:spLocks noGrp="1"/>
+          </p:cNvSpPr>
+          <p:nvPr>
+            <p:ph type="body" idx="3" sz="quarter"/>
+          </p:nvPr>
+        </p:nvSpPr>
+        <p:spPr/>
+        <p:txBody>
+          <a:bodyPr/>
+          <a:lstStyle/>
+          <a:p>
+            <a:r>
+              <a:t>A quick recap of the arc so it's clear how much of this is recent. Aug 16: the core orchestrator — the loop that owns 'done', parks on blocks, and resumes on red — in about 950 lines of TypeScript. Aug 16 to 18: campaign mode, which merges a whole backlog wave by wave and runs the gate on the merged base, plus baking the mattpocock skills into the image so every agent has them. Aug 18: this deck. Aug 19: the status dashboard we just walked through, plus housekeeping — a CHANGELOG and the v0.1.0 tag. The takeaway mirrors slide two: the leverage isn't volume of code, it's the loop plus borrowed tools.</a:t>
             </a:r>
           </a:p>
         </p:txBody>
@@ -7750,7 +7892,7 @@
                 </a:solidFill>
                 <a:latin typeface="Arial"/>
               </a:rPr>
-              <a:t>10</a:t>
+              <a:t>12</a:t>
             </a:r>
           </a:p>
         </p:txBody>
@@ -10085,7 +10227,7 @@
                 </a:solidFill>
                 <a:latin typeface="Arial"/>
               </a:rPr>
-              <a:t>11</a:t>
+              <a:t>13</a:t>
             </a:r>
           </a:p>
         </p:txBody>
@@ -11313,7 +11455,7 @@
                 </a:solidFill>
                 <a:latin typeface="Arial"/>
               </a:rPr>
-              <a:t>12</a:t>
+              <a:t>14</a:t>
             </a:r>
           </a:p>
         </p:txBody>
@@ -12369,7 +12511,7 @@
                 </a:solidFill>
                 <a:latin typeface="Arial"/>
               </a:rPr>
-              <a:t>13</a:t>
+              <a:t>15</a:t>
             </a:r>
           </a:p>
         </p:txBody>
@@ -13516,7 +13658,7 @@
                 </a:solidFill>
                 <a:latin typeface="Arial"/>
               </a:rPr>
-              <a:t>14</a:t>
+              <a:t>16</a:t>
             </a:r>
           </a:p>
         </p:txBody>
@@ -14786,7 +14928,7 @@
                 </a:solidFill>
                 <a:latin typeface="Arial"/>
               </a:rPr>
-              <a:t>15</a:t>
+              <a:t>17</a:t>
             </a:r>
           </a:p>
         </p:txBody>
@@ -17475,6 +17617,825 @@
 </p:sld>
 </file>
 
+<file path=ppt/slides/slide19.xml><?xml version="1.0" encoding="utf-8"?>
+<p:sld xmlns:a="http://schemas.openxmlformats.org/drawingml/2006/main" xmlns:p="http://schemas.openxmlformats.org/presentationml/2006/main" xmlns:r="http://schemas.openxmlformats.org/officeDocument/2006/relationships">
+  <p:cSld>
+    <p:spTree>
+      <p:nvGrpSpPr>
+        <p:cNvPr id="1" name=""/>
+        <p:cNvGrpSpPr/>
+        <p:nvPr/>
+      </p:nvGrpSpPr>
+      <p:grpSpPr/>
+      <p:sp>
+        <p:nvSpPr>
+          <p:cNvPr id="2" name="Rectangle 1"/>
+          <p:cNvSpPr/>
+          <p:nvPr/>
+        </p:nvSpPr>
+        <p:spPr>
+          <a:xfrm>
+            <a:off x="0" y="0"/>
+            <a:ext cx="12191695" cy="6858000"/>
+          </a:xfrm>
+          <a:prstGeom prst="rect">
+            <a:avLst/>
+          </a:prstGeom>
+          <a:solidFill>
+            <a:srgbClr val="0F172A"/>
+          </a:solidFill>
+          <a:ln>
+            <a:noFill/>
+          </a:ln>
+          <a:effectLst/>
+        </p:spPr>
+        <p:style>
+          <a:lnRef idx="1">
+            <a:schemeClr val="accent1"/>
+          </a:lnRef>
+          <a:fillRef idx="3">
+            <a:schemeClr val="accent1"/>
+          </a:fillRef>
+          <a:effectRef idx="2">
+            <a:schemeClr val="accent1"/>
+          </a:effectRef>
+          <a:fontRef idx="minor">
+            <a:schemeClr val="lt1"/>
+          </a:fontRef>
+        </p:style>
+        <p:txBody>
+          <a:bodyPr rtlCol="0" anchor="ctr"/>
+          <a:lstStyle/>
+          <a:p>
+            <a:pPr algn="ctr"/>
+          </a:p>
+        </p:txBody>
+      </p:sp>
+      <p:sp>
+        <p:nvSpPr>
+          <p:cNvPr id="3" name="TextBox 2"/>
+          <p:cNvSpPr txBox="1"/>
+          <p:nvPr/>
+        </p:nvSpPr>
+        <p:spPr>
+          <a:xfrm>
+            <a:off x="640080" y="566928"/>
+            <a:ext cx="10881360" cy="457200"/>
+          </a:xfrm>
+          <a:prstGeom prst="rect">
+            <a:avLst/>
+          </a:prstGeom>
+          <a:noFill/>
+        </p:spPr>
+        <p:txBody>
+          <a:bodyPr wrap="square" anchor="t" lIns="0" rIns="0" tIns="0" bIns="0">
+            <a:spAutoFit/>
+          </a:bodyPr>
+          <a:lstStyle/>
+          <a:p>
+            <a:pPr algn="l"/>
+            <a:r>
+              <a:rPr sz="1400" b="1">
+                <a:solidFill>
+                  <a:srgbClr val="F59E0B"/>
+                </a:solidFill>
+                <a:latin typeface="Arial"/>
+              </a:rPr>
+              <a:t>SEE THE WHOLE CAMPAIGN</a:t>
+            </a:r>
+          </a:p>
+        </p:txBody>
+      </p:sp>
+      <p:sp>
+        <p:nvSpPr>
+          <p:cNvPr id="4" name="TextBox 3"/>
+          <p:cNvSpPr txBox="1"/>
+          <p:nvPr/>
+        </p:nvSpPr>
+        <p:spPr>
+          <a:xfrm>
+            <a:off x="640080" y="868680"/>
+            <a:ext cx="10881360" cy="914400"/>
+          </a:xfrm>
+          <a:prstGeom prst="rect">
+            <a:avLst/>
+          </a:prstGeom>
+          <a:noFill/>
+        </p:spPr>
+        <p:txBody>
+          <a:bodyPr wrap="square" anchor="t" lIns="0" rIns="0" tIns="0" bIns="0">
+            <a:spAutoFit/>
+          </a:bodyPr>
+          <a:lstStyle/>
+          <a:p>
+            <a:pPr algn="l"/>
+            <a:r>
+              <a:rPr sz="3400" b="1">
+                <a:solidFill>
+                  <a:srgbClr val="F8FAFC"/>
+                </a:solidFill>
+                <a:latin typeface="Arial"/>
+              </a:rPr>
+              <a:t>A live status dashboard</a:t>
+            </a:r>
+          </a:p>
+        </p:txBody>
+      </p:sp>
+      <p:sp>
+        <p:nvSpPr>
+          <p:cNvPr id="5" name="Rectangle 4"/>
+          <p:cNvSpPr/>
+          <p:nvPr/>
+        </p:nvSpPr>
+        <p:spPr>
+          <a:xfrm>
+            <a:off x="640080" y="1481328"/>
+            <a:ext cx="1371600" cy="54864"/>
+          </a:xfrm>
+          <a:prstGeom prst="rect">
+            <a:avLst/>
+          </a:prstGeom>
+          <a:solidFill>
+            <a:srgbClr val="F59E0B"/>
+          </a:solidFill>
+          <a:ln>
+            <a:noFill/>
+          </a:ln>
+          <a:effectLst/>
+        </p:spPr>
+        <p:style>
+          <a:lnRef idx="1">
+            <a:schemeClr val="accent1"/>
+          </a:lnRef>
+          <a:fillRef idx="3">
+            <a:schemeClr val="accent1"/>
+          </a:fillRef>
+          <a:effectRef idx="2">
+            <a:schemeClr val="accent1"/>
+          </a:effectRef>
+          <a:fontRef idx="minor">
+            <a:schemeClr val="lt1"/>
+          </a:fontRef>
+        </p:style>
+        <p:txBody>
+          <a:bodyPr rtlCol="0" anchor="ctr"/>
+          <a:lstStyle/>
+          <a:p>
+            <a:pPr algn="ctr"/>
+          </a:p>
+        </p:txBody>
+      </p:sp>
+      <p:sp>
+        <p:nvSpPr>
+          <p:cNvPr id="6" name="TextBox 5"/>
+          <p:cNvSpPr txBox="1"/>
+          <p:nvPr/>
+        </p:nvSpPr>
+        <p:spPr>
+          <a:xfrm>
+            <a:off x="640080" y="1783080"/>
+            <a:ext cx="10881360" cy="914400"/>
+          </a:xfrm>
+          <a:prstGeom prst="rect">
+            <a:avLst/>
+          </a:prstGeom>
+          <a:noFill/>
+        </p:spPr>
+        <p:txBody>
+          <a:bodyPr wrap="square" anchor="t" lIns="0" rIns="0" tIns="0" bIns="0">
+            <a:spAutoFit/>
+          </a:bodyPr>
+          <a:lstStyle/>
+          <a:p>
+            <a:pPr algn="l">
+              <a:spcAft>
+                <a:spcPts val="400"/>
+              </a:spcAft>
+            </a:pPr>
+            <a:r>
+              <a:rPr sz="1700" b="1">
+                <a:solidFill>
+                  <a:srgbClr val="E2E8F0"/>
+                </a:solidFill>
+                <a:latin typeface="Consolas"/>
+              </a:rPr>
+              <a:t>npx sandcastle-tdd status</a:t>
+            </a:r>
+            <a:r>
+              <a:rPr sz="1700" b="0">
+                <a:solidFill>
+                  <a:srgbClr val="E2E8F0"/>
+                </a:solidFill>
+                <a:latin typeface="Arial"/>
+              </a:rPr>
+              <a:t>  — a local web page for the whole run.</a:t>
+            </a:r>
+          </a:p>
+          <a:p>
+            <a:pPr algn="l">
+              <a:spcAft>
+                <a:spcPts val="400"/>
+              </a:spcAft>
+            </a:pPr>
+            <a:r>
+              <a:rPr sz="1500" b="0">
+                <a:solidFill>
+                  <a:srgbClr val="94A3B8"/>
+                </a:solidFill>
+                <a:latin typeface="Arial"/>
+              </a:rPr>
+              <a:t>No new services: it reads the same JSONL the orchestrator already writes.</a:t>
+            </a:r>
+          </a:p>
+        </p:txBody>
+      </p:sp>
+      <p:sp>
+        <p:nvSpPr>
+          <p:cNvPr id="7" name="Rounded Rectangle 6"/>
+          <p:cNvSpPr/>
+          <p:nvPr/>
+        </p:nvSpPr>
+        <p:spPr>
+          <a:xfrm>
+            <a:off x="640080" y="2880360"/>
+            <a:ext cx="3566160" cy="2788920"/>
+          </a:xfrm>
+          <a:prstGeom prst="roundRect">
+            <a:avLst/>
+          </a:prstGeom>
+          <a:solidFill>
+            <a:srgbClr val="1E293B"/>
+          </a:solidFill>
+          <a:ln>
+            <a:noFill/>
+          </a:ln>
+          <a:effectLst/>
+        </p:spPr>
+        <p:style>
+          <a:lnRef idx="1">
+            <a:schemeClr val="accent1"/>
+          </a:lnRef>
+          <a:fillRef idx="3">
+            <a:schemeClr val="accent1"/>
+          </a:fillRef>
+          <a:effectRef idx="2">
+            <a:schemeClr val="accent1"/>
+          </a:effectRef>
+          <a:fontRef idx="minor">
+            <a:schemeClr val="lt1"/>
+          </a:fontRef>
+        </p:style>
+        <p:txBody>
+          <a:bodyPr rtlCol="0" anchor="ctr"/>
+          <a:lstStyle/>
+          <a:p>
+            <a:pPr algn="ctr"/>
+          </a:p>
+        </p:txBody>
+      </p:sp>
+      <p:sp>
+        <p:nvSpPr>
+          <p:cNvPr id="8" name="Rectangle 7"/>
+          <p:cNvSpPr/>
+          <p:nvPr/>
+        </p:nvSpPr>
+        <p:spPr>
+          <a:xfrm>
+            <a:off x="640080" y="2880360"/>
+            <a:ext cx="3566160" cy="109728"/>
+          </a:xfrm>
+          <a:prstGeom prst="rect">
+            <a:avLst/>
+          </a:prstGeom>
+          <a:solidFill>
+            <a:srgbClr val="F59E0B"/>
+          </a:solidFill>
+          <a:ln>
+            <a:noFill/>
+          </a:ln>
+          <a:effectLst/>
+        </p:spPr>
+        <p:style>
+          <a:lnRef idx="1">
+            <a:schemeClr val="accent1"/>
+          </a:lnRef>
+          <a:fillRef idx="3">
+            <a:schemeClr val="accent1"/>
+          </a:fillRef>
+          <a:effectRef idx="2">
+            <a:schemeClr val="accent1"/>
+          </a:effectRef>
+          <a:fontRef idx="minor">
+            <a:schemeClr val="lt1"/>
+          </a:fontRef>
+        </p:style>
+        <p:txBody>
+          <a:bodyPr rtlCol="0" anchor="ctr"/>
+          <a:lstStyle/>
+          <a:p>
+            <a:pPr algn="ctr"/>
+          </a:p>
+        </p:txBody>
+      </p:sp>
+      <p:sp>
+        <p:nvSpPr>
+          <p:cNvPr id="9" name="TextBox 8"/>
+          <p:cNvSpPr txBox="1"/>
+          <p:nvPr/>
+        </p:nvSpPr>
+        <p:spPr>
+          <a:xfrm>
+            <a:off x="914400" y="3264408"/>
+            <a:ext cx="3017520" cy="640080"/>
+          </a:xfrm>
+          <a:prstGeom prst="rect">
+            <a:avLst/>
+          </a:prstGeom>
+          <a:noFill/>
+        </p:spPr>
+        <p:txBody>
+          <a:bodyPr wrap="square" anchor="t" lIns="0" rIns="0" tIns="0" bIns="0">
+            <a:spAutoFit/>
+          </a:bodyPr>
+          <a:lstStyle/>
+          <a:p>
+            <a:pPr algn="l"/>
+            <a:r>
+              <a:rPr sz="1900" b="1">
+                <a:solidFill>
+                  <a:srgbClr val="F8FAFC"/>
+                </a:solidFill>
+                <a:latin typeface="Arial"/>
+              </a:rPr>
+              <a:t>Waves at a glance</a:t>
+            </a:r>
+          </a:p>
+        </p:txBody>
+      </p:sp>
+      <p:sp>
+        <p:nvSpPr>
+          <p:cNvPr id="10" name="TextBox 9"/>
+          <p:cNvSpPr txBox="1"/>
+          <p:nvPr/>
+        </p:nvSpPr>
+        <p:spPr>
+          <a:xfrm>
+            <a:off x="914400" y="4069080"/>
+            <a:ext cx="3017520" cy="1463040"/>
+          </a:xfrm>
+          <a:prstGeom prst="rect">
+            <a:avLst/>
+          </a:prstGeom>
+          <a:noFill/>
+        </p:spPr>
+        <p:txBody>
+          <a:bodyPr wrap="square" anchor="t" lIns="0" rIns="0" tIns="0" bIns="0">
+            <a:spAutoFit/>
+          </a:bodyPr>
+          <a:lstStyle/>
+          <a:p>
+            <a:pPr algn="l"/>
+            <a:r>
+              <a:rPr sz="1350" b="0">
+                <a:solidFill>
+                  <a:srgbClr val="E2E8F0"/>
+                </a:solidFill>
+                <a:latin typeface="Arial"/>
+              </a:rPr>
+              <a:t>Every wave with its issue chips — green completed, yellow parked, blue running. Finished waves collapse behind a green check.</a:t>
+            </a:r>
+          </a:p>
+        </p:txBody>
+      </p:sp>
+      <p:sp>
+        <p:nvSpPr>
+          <p:cNvPr id="11" name="Rounded Rectangle 10"/>
+          <p:cNvSpPr/>
+          <p:nvPr/>
+        </p:nvSpPr>
+        <p:spPr>
+          <a:xfrm>
+            <a:off x="4498848" y="2880360"/>
+            <a:ext cx="3566160" cy="2788920"/>
+          </a:xfrm>
+          <a:prstGeom prst="roundRect">
+            <a:avLst/>
+          </a:prstGeom>
+          <a:solidFill>
+            <a:srgbClr val="1E293B"/>
+          </a:solidFill>
+          <a:ln>
+            <a:noFill/>
+          </a:ln>
+          <a:effectLst/>
+        </p:spPr>
+        <p:style>
+          <a:lnRef idx="1">
+            <a:schemeClr val="accent1"/>
+          </a:lnRef>
+          <a:fillRef idx="3">
+            <a:schemeClr val="accent1"/>
+          </a:fillRef>
+          <a:effectRef idx="2">
+            <a:schemeClr val="accent1"/>
+          </a:effectRef>
+          <a:fontRef idx="minor">
+            <a:schemeClr val="lt1"/>
+          </a:fontRef>
+        </p:style>
+        <p:txBody>
+          <a:bodyPr rtlCol="0" anchor="ctr"/>
+          <a:lstStyle/>
+          <a:p>
+            <a:pPr algn="ctr"/>
+          </a:p>
+        </p:txBody>
+      </p:sp>
+      <p:sp>
+        <p:nvSpPr>
+          <p:cNvPr id="12" name="Rectangle 11"/>
+          <p:cNvSpPr/>
+          <p:nvPr/>
+        </p:nvSpPr>
+        <p:spPr>
+          <a:xfrm>
+            <a:off x="4498848" y="2880360"/>
+            <a:ext cx="3566160" cy="109728"/>
+          </a:xfrm>
+          <a:prstGeom prst="rect">
+            <a:avLst/>
+          </a:prstGeom>
+          <a:solidFill>
+            <a:srgbClr val="38BDF8"/>
+          </a:solidFill>
+          <a:ln>
+            <a:noFill/>
+          </a:ln>
+          <a:effectLst/>
+        </p:spPr>
+        <p:style>
+          <a:lnRef idx="1">
+            <a:schemeClr val="accent1"/>
+          </a:lnRef>
+          <a:fillRef idx="3">
+            <a:schemeClr val="accent1"/>
+          </a:fillRef>
+          <a:effectRef idx="2">
+            <a:schemeClr val="accent1"/>
+          </a:effectRef>
+          <a:fontRef idx="minor">
+            <a:schemeClr val="lt1"/>
+          </a:fontRef>
+        </p:style>
+        <p:txBody>
+          <a:bodyPr rtlCol="0" anchor="ctr"/>
+          <a:lstStyle/>
+          <a:p>
+            <a:pPr algn="ctr"/>
+          </a:p>
+        </p:txBody>
+      </p:sp>
+      <p:sp>
+        <p:nvSpPr>
+          <p:cNvPr id="13" name="TextBox 12"/>
+          <p:cNvSpPr txBox="1"/>
+          <p:nvPr/>
+        </p:nvSpPr>
+        <p:spPr>
+          <a:xfrm>
+            <a:off x="4773168" y="3264408"/>
+            <a:ext cx="3017520" cy="640080"/>
+          </a:xfrm>
+          <a:prstGeom prst="rect">
+            <a:avLst/>
+          </a:prstGeom>
+          <a:noFill/>
+        </p:spPr>
+        <p:txBody>
+          <a:bodyPr wrap="square" anchor="t" lIns="0" rIns="0" tIns="0" bIns="0">
+            <a:spAutoFit/>
+          </a:bodyPr>
+          <a:lstStyle/>
+          <a:p>
+            <a:pPr algn="l"/>
+            <a:r>
+              <a:rPr sz="1900" b="1">
+                <a:solidFill>
+                  <a:srgbClr val="F8FAFC"/>
+                </a:solidFill>
+                <a:latin typeface="Arial"/>
+              </a:rPr>
+              <a:t>Answer parked issues inline</a:t>
+            </a:r>
+          </a:p>
+        </p:txBody>
+      </p:sp>
+      <p:sp>
+        <p:nvSpPr>
+          <p:cNvPr id="14" name="TextBox 13"/>
+          <p:cNvSpPr txBox="1"/>
+          <p:nvPr/>
+        </p:nvSpPr>
+        <p:spPr>
+          <a:xfrm>
+            <a:off x="4773168" y="4069080"/>
+            <a:ext cx="3017520" cy="1463040"/>
+          </a:xfrm>
+          <a:prstGeom prst="rect">
+            <a:avLst/>
+          </a:prstGeom>
+          <a:noFill/>
+        </p:spPr>
+        <p:txBody>
+          <a:bodyPr wrap="square" anchor="t" lIns="0" rIns="0" tIns="0" bIns="0">
+            <a:spAutoFit/>
+          </a:bodyPr>
+          <a:lstStyle/>
+          <a:p>
+            <a:pPr algn="l"/>
+            <a:r>
+              <a:rPr sz="1350" b="0">
+                <a:solidFill>
+                  <a:srgbClr val="E2E8F0"/>
+                </a:solidFill>
+                <a:latin typeface="Arial"/>
+              </a:rPr>
+              <a:t>Blocked tasks jump to the top with an “N awaiting you” badge. Type a reply and the dispatcher resumes that exact agent.</a:t>
+            </a:r>
+          </a:p>
+        </p:txBody>
+      </p:sp>
+      <p:sp>
+        <p:nvSpPr>
+          <p:cNvPr id="15" name="Rounded Rectangle 14"/>
+          <p:cNvSpPr/>
+          <p:nvPr/>
+        </p:nvSpPr>
+        <p:spPr>
+          <a:xfrm>
+            <a:off x="8357615" y="2880360"/>
+            <a:ext cx="3566160" cy="2788920"/>
+          </a:xfrm>
+          <a:prstGeom prst="roundRect">
+            <a:avLst/>
+          </a:prstGeom>
+          <a:solidFill>
+            <a:srgbClr val="1E293B"/>
+          </a:solidFill>
+          <a:ln>
+            <a:noFill/>
+          </a:ln>
+          <a:effectLst/>
+        </p:spPr>
+        <p:style>
+          <a:lnRef idx="1">
+            <a:schemeClr val="accent1"/>
+          </a:lnRef>
+          <a:fillRef idx="3">
+            <a:schemeClr val="accent1"/>
+          </a:fillRef>
+          <a:effectRef idx="2">
+            <a:schemeClr val="accent1"/>
+          </a:effectRef>
+          <a:fontRef idx="minor">
+            <a:schemeClr val="lt1"/>
+          </a:fontRef>
+        </p:style>
+        <p:txBody>
+          <a:bodyPr rtlCol="0" anchor="ctr"/>
+          <a:lstStyle/>
+          <a:p>
+            <a:pPr algn="ctr"/>
+          </a:p>
+        </p:txBody>
+      </p:sp>
+      <p:sp>
+        <p:nvSpPr>
+          <p:cNvPr id="16" name="Rectangle 15"/>
+          <p:cNvSpPr/>
+          <p:nvPr/>
+        </p:nvSpPr>
+        <p:spPr>
+          <a:xfrm>
+            <a:off x="8357615" y="2880360"/>
+            <a:ext cx="3566160" cy="109728"/>
+          </a:xfrm>
+          <a:prstGeom prst="rect">
+            <a:avLst/>
+          </a:prstGeom>
+          <a:solidFill>
+            <a:srgbClr val="F59E0B"/>
+          </a:solidFill>
+          <a:ln>
+            <a:noFill/>
+          </a:ln>
+          <a:effectLst/>
+        </p:spPr>
+        <p:style>
+          <a:lnRef idx="1">
+            <a:schemeClr val="accent1"/>
+          </a:lnRef>
+          <a:fillRef idx="3">
+            <a:schemeClr val="accent1"/>
+          </a:fillRef>
+          <a:effectRef idx="2">
+            <a:schemeClr val="accent1"/>
+          </a:effectRef>
+          <a:fontRef idx="minor">
+            <a:schemeClr val="lt1"/>
+          </a:fontRef>
+        </p:style>
+        <p:txBody>
+          <a:bodyPr rtlCol="0" anchor="ctr"/>
+          <a:lstStyle/>
+          <a:p>
+            <a:pPr algn="ctr"/>
+          </a:p>
+        </p:txBody>
+      </p:sp>
+      <p:sp>
+        <p:nvSpPr>
+          <p:cNvPr id="17" name="TextBox 16"/>
+          <p:cNvSpPr txBox="1"/>
+          <p:nvPr/>
+        </p:nvSpPr>
+        <p:spPr>
+          <a:xfrm>
+            <a:off x="8631936" y="3264408"/>
+            <a:ext cx="3017520" cy="640080"/>
+          </a:xfrm>
+          <a:prstGeom prst="rect">
+            <a:avLst/>
+          </a:prstGeom>
+          <a:noFill/>
+        </p:spPr>
+        <p:txBody>
+          <a:bodyPr wrap="square" anchor="t" lIns="0" rIns="0" tIns="0" bIns="0">
+            <a:spAutoFit/>
+          </a:bodyPr>
+          <a:lstStyle/>
+          <a:p>
+            <a:pPr algn="l"/>
+            <a:r>
+              <a:rPr sz="1900" b="1">
+                <a:solidFill>
+                  <a:srgbClr val="F8FAFC"/>
+                </a:solidFill>
+                <a:latin typeface="Arial"/>
+              </a:rPr>
+              <a:t>Made for your phone</a:t>
+            </a:r>
+          </a:p>
+        </p:txBody>
+      </p:sp>
+      <p:sp>
+        <p:nvSpPr>
+          <p:cNvPr id="18" name="TextBox 17"/>
+          <p:cNvSpPr txBox="1"/>
+          <p:nvPr/>
+        </p:nvSpPr>
+        <p:spPr>
+          <a:xfrm>
+            <a:off x="8631936" y="4069080"/>
+            <a:ext cx="3017520" cy="1463040"/>
+          </a:xfrm>
+          <a:prstGeom prst="rect">
+            <a:avLst/>
+          </a:prstGeom>
+          <a:noFill/>
+        </p:spPr>
+        <p:txBody>
+          <a:bodyPr wrap="square" anchor="t" lIns="0" rIns="0" tIns="0" bIns="0">
+            <a:spAutoFit/>
+          </a:bodyPr>
+          <a:lstStyle/>
+          <a:p>
+            <a:pPr algn="l"/>
+            <a:r>
+              <a:rPr sz="1350" b="0">
+                <a:solidFill>
+                  <a:srgbClr val="E2E8F0"/>
+                </a:solidFill>
+                <a:latin typeface="Arial"/>
+              </a:rPr>
+              <a:t>Toggleable auto-refresh, a dismissible detail bar, tailnet access via --host 0.0.0.0 — and it never clobbers a reply you’re typing.</a:t>
+            </a:r>
+          </a:p>
+        </p:txBody>
+      </p:sp>
+      <p:sp>
+        <p:nvSpPr>
+          <p:cNvPr id="19" name="TextBox 18"/>
+          <p:cNvSpPr txBox="1"/>
+          <p:nvPr/>
+        </p:nvSpPr>
+        <p:spPr>
+          <a:xfrm>
+            <a:off x="640080" y="5897880"/>
+            <a:ext cx="10881360" cy="365760"/>
+          </a:xfrm>
+          <a:prstGeom prst="rect">
+            <a:avLst/>
+          </a:prstGeom>
+          <a:noFill/>
+        </p:spPr>
+        <p:txBody>
+          <a:bodyPr wrap="square" anchor="t" lIns="0" rIns="0" tIns="0" bIns="0">
+            <a:spAutoFit/>
+          </a:bodyPr>
+          <a:lstStyle/>
+          <a:p>
+            <a:pPr algn="l"/>
+            <a:r>
+              <a:rPr sz="1300" b="0">
+                <a:solidFill>
+                  <a:srgbClr val="F59E0B"/>
+                </a:solidFill>
+                <a:latin typeface="Arial"/>
+              </a:rPr>
+              <a:t>Reads state, writes answers — the dashboard is a lens on the loop, not another moving part.</a:t>
+            </a:r>
+          </a:p>
+        </p:txBody>
+      </p:sp>
+      <p:sp>
+        <p:nvSpPr>
+          <p:cNvPr id="20" name="TextBox 19"/>
+          <p:cNvSpPr txBox="1"/>
+          <p:nvPr/>
+        </p:nvSpPr>
+        <p:spPr>
+          <a:xfrm>
+            <a:off x="640080" y="6419088"/>
+            <a:ext cx="7315200" cy="274320"/>
+          </a:xfrm>
+          <a:prstGeom prst="rect">
+            <a:avLst/>
+          </a:prstGeom>
+          <a:noFill/>
+        </p:spPr>
+        <p:txBody>
+          <a:bodyPr wrap="square" anchor="t" lIns="0" rIns="0" tIns="0" bIns="0">
+            <a:spAutoFit/>
+          </a:bodyPr>
+          <a:lstStyle/>
+          <a:p>
+            <a:pPr algn="l"/>
+            <a:r>
+              <a:rPr sz="1000" b="0">
+                <a:solidFill>
+                  <a:srgbClr val="94A3B8"/>
+                </a:solidFill>
+                <a:latin typeface="Consolas"/>
+              </a:rPr>
+              <a:t>sandcastle-tdd</a:t>
+            </a:r>
+          </a:p>
+        </p:txBody>
+      </p:sp>
+      <p:sp>
+        <p:nvSpPr>
+          <p:cNvPr id="21" name="TextBox 20"/>
+          <p:cNvSpPr txBox="1"/>
+          <p:nvPr/>
+        </p:nvSpPr>
+        <p:spPr>
+          <a:xfrm>
+            <a:off x="10881360" y="6419088"/>
+            <a:ext cx="822960" cy="274320"/>
+          </a:xfrm>
+          <a:prstGeom prst="rect">
+            <a:avLst/>
+          </a:prstGeom>
+          <a:noFill/>
+        </p:spPr>
+        <p:txBody>
+          <a:bodyPr wrap="square" anchor="t" lIns="0" rIns="0" tIns="0" bIns="0">
+            <a:spAutoFit/>
+          </a:bodyPr>
+          <a:lstStyle/>
+          <a:p>
+            <a:pPr algn="r"/>
+            <a:r>
+              <a:rPr sz="1000" b="0">
+                <a:solidFill>
+                  <a:srgbClr val="94A3B8"/>
+                </a:solidFill>
+                <a:latin typeface="Arial"/>
+              </a:rPr>
+              <a:t>10</a:t>
+            </a:r>
+          </a:p>
+        </p:txBody>
+      </p:sp>
+    </p:spTree>
+  </p:cSld>
+  <p:clrMapOvr>
+    <a:masterClrMapping/>
+  </p:clrMapOvr>
+</p:sld>
+</file>
+
 <file path=ppt/slides/slide2.xml><?xml version="1.0" encoding="utf-8"?>
 <p:sld xmlns:a="http://schemas.openxmlformats.org/drawingml/2006/main" xmlns:p="http://schemas.openxmlformats.org/presentationml/2006/main" xmlns:r="http://schemas.openxmlformats.org/officeDocument/2006/relationships">
   <p:cSld>
@@ -18289,6 +19250,1103 @@
                 <a:latin typeface="Arial"/>
               </a:rPr>
               <a:t>1</a:t>
+            </a:r>
+          </a:p>
+        </p:txBody>
+      </p:sp>
+    </p:spTree>
+  </p:cSld>
+  <p:clrMapOvr>
+    <a:masterClrMapping/>
+  </p:clrMapOvr>
+</p:sld>
+</file>
+
+<file path=ppt/slides/slide20.xml><?xml version="1.0" encoding="utf-8"?>
+<p:sld xmlns:a="http://schemas.openxmlformats.org/drawingml/2006/main" xmlns:p="http://schemas.openxmlformats.org/presentationml/2006/main" xmlns:r="http://schemas.openxmlformats.org/officeDocument/2006/relationships">
+  <p:cSld>
+    <p:spTree>
+      <p:nvGrpSpPr>
+        <p:cNvPr id="1" name=""/>
+        <p:cNvGrpSpPr/>
+        <p:nvPr/>
+      </p:nvGrpSpPr>
+      <p:grpSpPr/>
+      <p:sp>
+        <p:nvSpPr>
+          <p:cNvPr id="2" name="Rectangle 1"/>
+          <p:cNvSpPr/>
+          <p:nvPr/>
+        </p:nvSpPr>
+        <p:spPr>
+          <a:xfrm>
+            <a:off x="0" y="0"/>
+            <a:ext cx="12191695" cy="6858000"/>
+          </a:xfrm>
+          <a:prstGeom prst="rect">
+            <a:avLst/>
+          </a:prstGeom>
+          <a:solidFill>
+            <a:srgbClr val="0F172A"/>
+          </a:solidFill>
+          <a:ln>
+            <a:noFill/>
+          </a:ln>
+          <a:effectLst/>
+        </p:spPr>
+        <p:style>
+          <a:lnRef idx="1">
+            <a:schemeClr val="accent1"/>
+          </a:lnRef>
+          <a:fillRef idx="3">
+            <a:schemeClr val="accent1"/>
+          </a:fillRef>
+          <a:effectRef idx="2">
+            <a:schemeClr val="accent1"/>
+          </a:effectRef>
+          <a:fontRef idx="minor">
+            <a:schemeClr val="lt1"/>
+          </a:fontRef>
+        </p:style>
+        <p:txBody>
+          <a:bodyPr rtlCol="0" anchor="ctr"/>
+          <a:lstStyle/>
+          <a:p>
+            <a:pPr algn="ctr"/>
+          </a:p>
+        </p:txBody>
+      </p:sp>
+      <p:sp>
+        <p:nvSpPr>
+          <p:cNvPr id="3" name="TextBox 2"/>
+          <p:cNvSpPr txBox="1"/>
+          <p:nvPr/>
+        </p:nvSpPr>
+        <p:spPr>
+          <a:xfrm>
+            <a:off x="640080" y="566928"/>
+            <a:ext cx="10881360" cy="457200"/>
+          </a:xfrm>
+          <a:prstGeom prst="rect">
+            <a:avLst/>
+          </a:prstGeom>
+          <a:noFill/>
+        </p:spPr>
+        <p:txBody>
+          <a:bodyPr wrap="square" anchor="t" lIns="0" rIns="0" tIns="0" bIns="0">
+            <a:spAutoFit/>
+          </a:bodyPr>
+          <a:lstStyle/>
+          <a:p>
+            <a:pPr algn="l"/>
+            <a:r>
+              <a:rPr sz="1400" b="1">
+                <a:solidFill>
+                  <a:srgbClr val="F59E0B"/>
+                </a:solidFill>
+                <a:latin typeface="Arial"/>
+              </a:rPr>
+              <a:t>FROM ZERO TO SHIPPED</a:t>
+            </a:r>
+          </a:p>
+        </p:txBody>
+      </p:sp>
+      <p:sp>
+        <p:nvSpPr>
+          <p:cNvPr id="4" name="TextBox 3"/>
+          <p:cNvSpPr txBox="1"/>
+          <p:nvPr/>
+        </p:nvSpPr>
+        <p:spPr>
+          <a:xfrm>
+            <a:off x="640080" y="868680"/>
+            <a:ext cx="10881360" cy="914400"/>
+          </a:xfrm>
+          <a:prstGeom prst="rect">
+            <a:avLst/>
+          </a:prstGeom>
+          <a:noFill/>
+        </p:spPr>
+        <p:txBody>
+          <a:bodyPr wrap="square" anchor="t" lIns="0" rIns="0" tIns="0" bIns="0">
+            <a:spAutoFit/>
+          </a:bodyPr>
+          <a:lstStyle/>
+          <a:p>
+            <a:pPr algn="l"/>
+            <a:r>
+              <a:rPr sz="3400" b="1">
+                <a:solidFill>
+                  <a:srgbClr val="F8FAFC"/>
+                </a:solidFill>
+                <a:latin typeface="Arial"/>
+              </a:rPr>
+              <a:t>What we built, and when</a:t>
+            </a:r>
+          </a:p>
+        </p:txBody>
+      </p:sp>
+      <p:sp>
+        <p:nvSpPr>
+          <p:cNvPr id="5" name="Rectangle 4"/>
+          <p:cNvSpPr/>
+          <p:nvPr/>
+        </p:nvSpPr>
+        <p:spPr>
+          <a:xfrm>
+            <a:off x="640080" y="1481328"/>
+            <a:ext cx="1371600" cy="54864"/>
+          </a:xfrm>
+          <a:prstGeom prst="rect">
+            <a:avLst/>
+          </a:prstGeom>
+          <a:solidFill>
+            <a:srgbClr val="F59E0B"/>
+          </a:solidFill>
+          <a:ln>
+            <a:noFill/>
+          </a:ln>
+          <a:effectLst/>
+        </p:spPr>
+        <p:style>
+          <a:lnRef idx="1">
+            <a:schemeClr val="accent1"/>
+          </a:lnRef>
+          <a:fillRef idx="3">
+            <a:schemeClr val="accent1"/>
+          </a:fillRef>
+          <a:effectRef idx="2">
+            <a:schemeClr val="accent1"/>
+          </a:effectRef>
+          <a:fontRef idx="minor">
+            <a:schemeClr val="lt1"/>
+          </a:fontRef>
+        </p:style>
+        <p:txBody>
+          <a:bodyPr rtlCol="0" anchor="ctr"/>
+          <a:lstStyle/>
+          <a:p>
+            <a:pPr algn="ctr"/>
+          </a:p>
+        </p:txBody>
+      </p:sp>
+      <p:sp>
+        <p:nvSpPr>
+          <p:cNvPr id="6" name="TextBox 5"/>
+          <p:cNvSpPr txBox="1"/>
+          <p:nvPr/>
+        </p:nvSpPr>
+        <p:spPr>
+          <a:xfrm>
+            <a:off x="640080" y="1783080"/>
+            <a:ext cx="10881360" cy="548640"/>
+          </a:xfrm>
+          <a:prstGeom prst="rect">
+            <a:avLst/>
+          </a:prstGeom>
+          <a:noFill/>
+        </p:spPr>
+        <p:txBody>
+          <a:bodyPr wrap="square" anchor="t" lIns="0" rIns="0" tIns="0" bIns="0">
+            <a:spAutoFit/>
+          </a:bodyPr>
+          <a:lstStyle/>
+          <a:p>
+            <a:pPr algn="l"/>
+            <a:r>
+              <a:rPr sz="1600" b="0">
+                <a:solidFill>
+                  <a:srgbClr val="E2E8F0"/>
+                </a:solidFill>
+                <a:latin typeface="Arial"/>
+              </a:rPr>
+              <a:t>Four days, one small repo. Most of it is the loop; the rest is leverage.</a:t>
+            </a:r>
+          </a:p>
+        </p:txBody>
+      </p:sp>
+      <p:sp>
+        <p:nvSpPr>
+          <p:cNvPr id="7" name="Rectangle 6"/>
+          <p:cNvSpPr/>
+          <p:nvPr/>
+        </p:nvSpPr>
+        <p:spPr>
+          <a:xfrm>
+            <a:off x="1965960" y="3364992"/>
+            <a:ext cx="8229600" cy="45720"/>
+          </a:xfrm>
+          <a:prstGeom prst="rect">
+            <a:avLst/>
+          </a:prstGeom>
+          <a:solidFill>
+            <a:srgbClr val="334155"/>
+          </a:solidFill>
+          <a:ln>
+            <a:noFill/>
+          </a:ln>
+          <a:effectLst/>
+        </p:spPr>
+        <p:style>
+          <a:lnRef idx="1">
+            <a:schemeClr val="accent1"/>
+          </a:lnRef>
+          <a:fillRef idx="3">
+            <a:schemeClr val="accent1"/>
+          </a:fillRef>
+          <a:effectRef idx="2">
+            <a:schemeClr val="accent1"/>
+          </a:effectRef>
+          <a:fontRef idx="minor">
+            <a:schemeClr val="lt1"/>
+          </a:fontRef>
+        </p:style>
+        <p:txBody>
+          <a:bodyPr rtlCol="0" anchor="ctr"/>
+          <a:lstStyle/>
+          <a:p>
+            <a:pPr algn="ctr"/>
+          </a:p>
+        </p:txBody>
+      </p:sp>
+      <p:sp>
+        <p:nvSpPr>
+          <p:cNvPr id="8" name="TextBox 7"/>
+          <p:cNvSpPr txBox="1"/>
+          <p:nvPr/>
+        </p:nvSpPr>
+        <p:spPr>
+          <a:xfrm>
+            <a:off x="708659" y="2450592"/>
+            <a:ext cx="2514600" cy="365760"/>
+          </a:xfrm>
+          <a:prstGeom prst="rect">
+            <a:avLst/>
+          </a:prstGeom>
+          <a:noFill/>
+        </p:spPr>
+        <p:txBody>
+          <a:bodyPr wrap="square" anchor="t" lIns="0" rIns="0" tIns="0" bIns="0">
+            <a:spAutoFit/>
+          </a:bodyPr>
+          <a:lstStyle/>
+          <a:p>
+            <a:pPr algn="ctr"/>
+            <a:r>
+              <a:rPr sz="1400" b="1">
+                <a:solidFill>
+                  <a:srgbClr val="F59E0B"/>
+                </a:solidFill>
+                <a:latin typeface="Arial"/>
+              </a:rPr>
+              <a:t>Aug 16</a:t>
+            </a:r>
+          </a:p>
+        </p:txBody>
+      </p:sp>
+      <p:sp>
+        <p:nvSpPr>
+          <p:cNvPr id="9" name="Oval 8"/>
+          <p:cNvSpPr/>
+          <p:nvPr/>
+        </p:nvSpPr>
+        <p:spPr>
+          <a:xfrm>
+            <a:off x="1810512" y="3227832"/>
+            <a:ext cx="310896" cy="310896"/>
+          </a:xfrm>
+          <a:prstGeom prst="ellipse">
+            <a:avLst/>
+          </a:prstGeom>
+          <a:solidFill>
+            <a:srgbClr val="F59E0B"/>
+          </a:solidFill>
+          <a:ln>
+            <a:noFill/>
+          </a:ln>
+          <a:effectLst/>
+        </p:spPr>
+        <p:style>
+          <a:lnRef idx="1">
+            <a:schemeClr val="accent1"/>
+          </a:lnRef>
+          <a:fillRef idx="3">
+            <a:schemeClr val="accent1"/>
+          </a:fillRef>
+          <a:effectRef idx="2">
+            <a:schemeClr val="accent1"/>
+          </a:effectRef>
+          <a:fontRef idx="minor">
+            <a:schemeClr val="lt1"/>
+          </a:fontRef>
+        </p:style>
+        <p:txBody>
+          <a:bodyPr rtlCol="0" anchor="ctr"/>
+          <a:lstStyle/>
+          <a:p>
+            <a:pPr algn="ctr"/>
+          </a:p>
+        </p:txBody>
+      </p:sp>
+      <p:sp>
+        <p:nvSpPr>
+          <p:cNvPr id="10" name="Oval 9"/>
+          <p:cNvSpPr/>
+          <p:nvPr/>
+        </p:nvSpPr>
+        <p:spPr>
+          <a:xfrm>
+            <a:off x="1920240" y="3337560"/>
+            <a:ext cx="91440" cy="91440"/>
+          </a:xfrm>
+          <a:prstGeom prst="ellipse">
+            <a:avLst/>
+          </a:prstGeom>
+          <a:solidFill>
+            <a:srgbClr val="0F172A"/>
+          </a:solidFill>
+          <a:ln>
+            <a:noFill/>
+          </a:ln>
+          <a:effectLst/>
+        </p:spPr>
+        <p:style>
+          <a:lnRef idx="1">
+            <a:schemeClr val="accent1"/>
+          </a:lnRef>
+          <a:fillRef idx="3">
+            <a:schemeClr val="accent1"/>
+          </a:fillRef>
+          <a:effectRef idx="2">
+            <a:schemeClr val="accent1"/>
+          </a:effectRef>
+          <a:fontRef idx="minor">
+            <a:schemeClr val="lt1"/>
+          </a:fontRef>
+        </p:style>
+        <p:txBody>
+          <a:bodyPr rtlCol="0" anchor="ctr"/>
+          <a:lstStyle/>
+          <a:p>
+            <a:pPr algn="ctr"/>
+          </a:p>
+        </p:txBody>
+      </p:sp>
+      <p:sp>
+        <p:nvSpPr>
+          <p:cNvPr id="11" name="TextBox 10"/>
+          <p:cNvSpPr txBox="1"/>
+          <p:nvPr/>
+        </p:nvSpPr>
+        <p:spPr>
+          <a:xfrm>
+            <a:off x="708659" y="3767328"/>
+            <a:ext cx="2514600" cy="502920"/>
+          </a:xfrm>
+          <a:prstGeom prst="rect">
+            <a:avLst/>
+          </a:prstGeom>
+          <a:noFill/>
+        </p:spPr>
+        <p:txBody>
+          <a:bodyPr wrap="square" anchor="t" lIns="0" rIns="0" tIns="0" bIns="0">
+            <a:spAutoFit/>
+          </a:bodyPr>
+          <a:lstStyle/>
+          <a:p>
+            <a:pPr algn="ctr"/>
+            <a:r>
+              <a:rPr sz="1600" b="1">
+                <a:solidFill>
+                  <a:srgbClr val="F8FAFC"/>
+                </a:solidFill>
+                <a:latin typeface="Arial"/>
+              </a:rPr>
+              <a:t>Orchestrator</a:t>
+            </a:r>
+          </a:p>
+        </p:txBody>
+      </p:sp>
+      <p:sp>
+        <p:nvSpPr>
+          <p:cNvPr id="12" name="TextBox 11"/>
+          <p:cNvSpPr txBox="1"/>
+          <p:nvPr/>
+        </p:nvSpPr>
+        <p:spPr>
+          <a:xfrm>
+            <a:off x="708659" y="4343400"/>
+            <a:ext cx="2514600" cy="1463040"/>
+          </a:xfrm>
+          <a:prstGeom prst="rect">
+            <a:avLst/>
+          </a:prstGeom>
+          <a:noFill/>
+        </p:spPr>
+        <p:txBody>
+          <a:bodyPr wrap="square" anchor="t" lIns="0" rIns="0" tIns="0" bIns="0">
+            <a:spAutoFit/>
+          </a:bodyPr>
+          <a:lstStyle/>
+          <a:p>
+            <a:pPr algn="ctr"/>
+            <a:r>
+              <a:rPr sz="1250" b="0">
+                <a:solidFill>
+                  <a:srgbClr val="94A3B8"/>
+                </a:solidFill>
+                <a:latin typeface="Arial"/>
+              </a:rPr>
+              <a:t>Parallel TDD agents that can’t self-approve and park instead of guessing. ~950 lines.</a:t>
+            </a:r>
+          </a:p>
+        </p:txBody>
+      </p:sp>
+      <p:sp>
+        <p:nvSpPr>
+          <p:cNvPr id="13" name="TextBox 12"/>
+          <p:cNvSpPr txBox="1"/>
+          <p:nvPr/>
+        </p:nvSpPr>
+        <p:spPr>
+          <a:xfrm>
+            <a:off x="3451860" y="2450592"/>
+            <a:ext cx="2514600" cy="365760"/>
+          </a:xfrm>
+          <a:prstGeom prst="rect">
+            <a:avLst/>
+          </a:prstGeom>
+          <a:noFill/>
+        </p:spPr>
+        <p:txBody>
+          <a:bodyPr wrap="square" anchor="t" lIns="0" rIns="0" tIns="0" bIns="0">
+            <a:spAutoFit/>
+          </a:bodyPr>
+          <a:lstStyle/>
+          <a:p>
+            <a:pPr algn="ctr"/>
+            <a:r>
+              <a:rPr sz="1400" b="1">
+                <a:solidFill>
+                  <a:srgbClr val="38BDF8"/>
+                </a:solidFill>
+                <a:latin typeface="Arial"/>
+              </a:rPr>
+              <a:t>Aug 16–18</a:t>
+            </a:r>
+          </a:p>
+        </p:txBody>
+      </p:sp>
+      <p:sp>
+        <p:nvSpPr>
+          <p:cNvPr id="14" name="Oval 13"/>
+          <p:cNvSpPr/>
+          <p:nvPr/>
+        </p:nvSpPr>
+        <p:spPr>
+          <a:xfrm>
+            <a:off x="4553712" y="3227832"/>
+            <a:ext cx="310896" cy="310896"/>
+          </a:xfrm>
+          <a:prstGeom prst="ellipse">
+            <a:avLst/>
+          </a:prstGeom>
+          <a:solidFill>
+            <a:srgbClr val="38BDF8"/>
+          </a:solidFill>
+          <a:ln>
+            <a:noFill/>
+          </a:ln>
+          <a:effectLst/>
+        </p:spPr>
+        <p:style>
+          <a:lnRef idx="1">
+            <a:schemeClr val="accent1"/>
+          </a:lnRef>
+          <a:fillRef idx="3">
+            <a:schemeClr val="accent1"/>
+          </a:fillRef>
+          <a:effectRef idx="2">
+            <a:schemeClr val="accent1"/>
+          </a:effectRef>
+          <a:fontRef idx="minor">
+            <a:schemeClr val="lt1"/>
+          </a:fontRef>
+        </p:style>
+        <p:txBody>
+          <a:bodyPr rtlCol="0" anchor="ctr"/>
+          <a:lstStyle/>
+          <a:p>
+            <a:pPr algn="ctr"/>
+          </a:p>
+        </p:txBody>
+      </p:sp>
+      <p:sp>
+        <p:nvSpPr>
+          <p:cNvPr id="15" name="Oval 14"/>
+          <p:cNvSpPr/>
+          <p:nvPr/>
+        </p:nvSpPr>
+        <p:spPr>
+          <a:xfrm>
+            <a:off x="4663440" y="3337560"/>
+            <a:ext cx="91440" cy="91440"/>
+          </a:xfrm>
+          <a:prstGeom prst="ellipse">
+            <a:avLst/>
+          </a:prstGeom>
+          <a:solidFill>
+            <a:srgbClr val="0F172A"/>
+          </a:solidFill>
+          <a:ln>
+            <a:noFill/>
+          </a:ln>
+          <a:effectLst/>
+        </p:spPr>
+        <p:style>
+          <a:lnRef idx="1">
+            <a:schemeClr val="accent1"/>
+          </a:lnRef>
+          <a:fillRef idx="3">
+            <a:schemeClr val="accent1"/>
+          </a:fillRef>
+          <a:effectRef idx="2">
+            <a:schemeClr val="accent1"/>
+          </a:effectRef>
+          <a:fontRef idx="minor">
+            <a:schemeClr val="lt1"/>
+          </a:fontRef>
+        </p:style>
+        <p:txBody>
+          <a:bodyPr rtlCol="0" anchor="ctr"/>
+          <a:lstStyle/>
+          <a:p>
+            <a:pPr algn="ctr"/>
+          </a:p>
+        </p:txBody>
+      </p:sp>
+      <p:sp>
+        <p:nvSpPr>
+          <p:cNvPr id="16" name="TextBox 15"/>
+          <p:cNvSpPr txBox="1"/>
+          <p:nvPr/>
+        </p:nvSpPr>
+        <p:spPr>
+          <a:xfrm>
+            <a:off x="3451860" y="3767328"/>
+            <a:ext cx="2514600" cy="502920"/>
+          </a:xfrm>
+          <a:prstGeom prst="rect">
+            <a:avLst/>
+          </a:prstGeom>
+          <a:noFill/>
+        </p:spPr>
+        <p:txBody>
+          <a:bodyPr wrap="square" anchor="t" lIns="0" rIns="0" tIns="0" bIns="0">
+            <a:spAutoFit/>
+          </a:bodyPr>
+          <a:lstStyle/>
+          <a:p>
+            <a:pPr algn="ctr"/>
+            <a:r>
+              <a:rPr sz="1600" b="1">
+                <a:solidFill>
+                  <a:srgbClr val="F8FAFC"/>
+                </a:solidFill>
+                <a:latin typeface="Arial"/>
+              </a:rPr>
+              <a:t>Campaign mode + skills</a:t>
+            </a:r>
+          </a:p>
+        </p:txBody>
+      </p:sp>
+      <p:sp>
+        <p:nvSpPr>
+          <p:cNvPr id="17" name="TextBox 16"/>
+          <p:cNvSpPr txBox="1"/>
+          <p:nvPr/>
+        </p:nvSpPr>
+        <p:spPr>
+          <a:xfrm>
+            <a:off x="3451860" y="4343400"/>
+            <a:ext cx="2514600" cy="1463040"/>
+          </a:xfrm>
+          <a:prstGeom prst="rect">
+            <a:avLst/>
+          </a:prstGeom>
+          <a:noFill/>
+        </p:spPr>
+        <p:txBody>
+          <a:bodyPr wrap="square" anchor="t" lIns="0" rIns="0" tIns="0" bIns="0">
+            <a:spAutoFit/>
+          </a:bodyPr>
+          <a:lstStyle/>
+          <a:p>
+            <a:pPr algn="ctr"/>
+            <a:r>
+              <a:rPr sz="1250" b="0">
+                <a:solidFill>
+                  <a:srgbClr val="94A3B8"/>
+                </a:solidFill>
+                <a:latin typeface="Arial"/>
+              </a:rPr>
+              <a:t>Merge the whole backlog wave-by-wave; mattpocock skills baked into the agent image.</a:t>
+            </a:r>
+          </a:p>
+        </p:txBody>
+      </p:sp>
+      <p:sp>
+        <p:nvSpPr>
+          <p:cNvPr id="18" name="TextBox 17"/>
+          <p:cNvSpPr txBox="1"/>
+          <p:nvPr/>
+        </p:nvSpPr>
+        <p:spPr>
+          <a:xfrm>
+            <a:off x="6195060" y="2450592"/>
+            <a:ext cx="2514600" cy="365760"/>
+          </a:xfrm>
+          <a:prstGeom prst="rect">
+            <a:avLst/>
+          </a:prstGeom>
+          <a:noFill/>
+        </p:spPr>
+        <p:txBody>
+          <a:bodyPr wrap="square" anchor="t" lIns="0" rIns="0" tIns="0" bIns="0">
+            <a:spAutoFit/>
+          </a:bodyPr>
+          <a:lstStyle/>
+          <a:p>
+            <a:pPr algn="ctr"/>
+            <a:r>
+              <a:rPr sz="1400" b="1">
+                <a:solidFill>
+                  <a:srgbClr val="F59E0B"/>
+                </a:solidFill>
+                <a:latin typeface="Arial"/>
+              </a:rPr>
+              <a:t>Aug 18</a:t>
+            </a:r>
+          </a:p>
+        </p:txBody>
+      </p:sp>
+      <p:sp>
+        <p:nvSpPr>
+          <p:cNvPr id="19" name="Oval 18"/>
+          <p:cNvSpPr/>
+          <p:nvPr/>
+        </p:nvSpPr>
+        <p:spPr>
+          <a:xfrm>
+            <a:off x="7296912" y="3227832"/>
+            <a:ext cx="310896" cy="310896"/>
+          </a:xfrm>
+          <a:prstGeom prst="ellipse">
+            <a:avLst/>
+          </a:prstGeom>
+          <a:solidFill>
+            <a:srgbClr val="F59E0B"/>
+          </a:solidFill>
+          <a:ln>
+            <a:noFill/>
+          </a:ln>
+          <a:effectLst/>
+        </p:spPr>
+        <p:style>
+          <a:lnRef idx="1">
+            <a:schemeClr val="accent1"/>
+          </a:lnRef>
+          <a:fillRef idx="3">
+            <a:schemeClr val="accent1"/>
+          </a:fillRef>
+          <a:effectRef idx="2">
+            <a:schemeClr val="accent1"/>
+          </a:effectRef>
+          <a:fontRef idx="minor">
+            <a:schemeClr val="lt1"/>
+          </a:fontRef>
+        </p:style>
+        <p:txBody>
+          <a:bodyPr rtlCol="0" anchor="ctr"/>
+          <a:lstStyle/>
+          <a:p>
+            <a:pPr algn="ctr"/>
+          </a:p>
+        </p:txBody>
+      </p:sp>
+      <p:sp>
+        <p:nvSpPr>
+          <p:cNvPr id="20" name="Oval 19"/>
+          <p:cNvSpPr/>
+          <p:nvPr/>
+        </p:nvSpPr>
+        <p:spPr>
+          <a:xfrm>
+            <a:off x="7406640" y="3337560"/>
+            <a:ext cx="91440" cy="91440"/>
+          </a:xfrm>
+          <a:prstGeom prst="ellipse">
+            <a:avLst/>
+          </a:prstGeom>
+          <a:solidFill>
+            <a:srgbClr val="0F172A"/>
+          </a:solidFill>
+          <a:ln>
+            <a:noFill/>
+          </a:ln>
+          <a:effectLst/>
+        </p:spPr>
+        <p:style>
+          <a:lnRef idx="1">
+            <a:schemeClr val="accent1"/>
+          </a:lnRef>
+          <a:fillRef idx="3">
+            <a:schemeClr val="accent1"/>
+          </a:fillRef>
+          <a:effectRef idx="2">
+            <a:schemeClr val="accent1"/>
+          </a:effectRef>
+          <a:fontRef idx="minor">
+            <a:schemeClr val="lt1"/>
+          </a:fontRef>
+        </p:style>
+        <p:txBody>
+          <a:bodyPr rtlCol="0" anchor="ctr"/>
+          <a:lstStyle/>
+          <a:p>
+            <a:pPr algn="ctr"/>
+          </a:p>
+        </p:txBody>
+      </p:sp>
+      <p:sp>
+        <p:nvSpPr>
+          <p:cNvPr id="21" name="TextBox 20"/>
+          <p:cNvSpPr txBox="1"/>
+          <p:nvPr/>
+        </p:nvSpPr>
+        <p:spPr>
+          <a:xfrm>
+            <a:off x="6195060" y="3767328"/>
+            <a:ext cx="2514600" cy="502920"/>
+          </a:xfrm>
+          <a:prstGeom prst="rect">
+            <a:avLst/>
+          </a:prstGeom>
+          <a:noFill/>
+        </p:spPr>
+        <p:txBody>
+          <a:bodyPr wrap="square" anchor="t" lIns="0" rIns="0" tIns="0" bIns="0">
+            <a:spAutoFit/>
+          </a:bodyPr>
+          <a:lstStyle/>
+          <a:p>
+            <a:pPr algn="ctr"/>
+            <a:r>
+              <a:rPr sz="1600" b="1">
+                <a:solidFill>
+                  <a:srgbClr val="F8FAFC"/>
+                </a:solidFill>
+                <a:latin typeface="Arial"/>
+              </a:rPr>
+              <a:t>Team deck</a:t>
+            </a:r>
+          </a:p>
+        </p:txBody>
+      </p:sp>
+      <p:sp>
+        <p:nvSpPr>
+          <p:cNvPr id="22" name="TextBox 21"/>
+          <p:cNvSpPr txBox="1"/>
+          <p:nvPr/>
+        </p:nvSpPr>
+        <p:spPr>
+          <a:xfrm>
+            <a:off x="6195060" y="4343400"/>
+            <a:ext cx="2514600" cy="1463040"/>
+          </a:xfrm>
+          <a:prstGeom prst="rect">
+            <a:avLst/>
+          </a:prstGeom>
+          <a:noFill/>
+        </p:spPr>
+        <p:txBody>
+          <a:bodyPr wrap="square" anchor="t" lIns="0" rIns="0" tIns="0" bIns="0">
+            <a:spAutoFit/>
+          </a:bodyPr>
+          <a:lstStyle/>
+          <a:p>
+            <a:pPr algn="ctr"/>
+            <a:r>
+              <a:rPr sz="1250" b="0">
+                <a:solidFill>
+                  <a:srgbClr val="94A3B8"/>
+                </a:solidFill>
+                <a:latin typeface="Arial"/>
+              </a:rPr>
+              <a:t>This walkthrough — the design principles and a real-velocity proof slide.</a:t>
+            </a:r>
+          </a:p>
+        </p:txBody>
+      </p:sp>
+      <p:sp>
+        <p:nvSpPr>
+          <p:cNvPr id="23" name="TextBox 22"/>
+          <p:cNvSpPr txBox="1"/>
+          <p:nvPr/>
+        </p:nvSpPr>
+        <p:spPr>
+          <a:xfrm>
+            <a:off x="8938260" y="2450592"/>
+            <a:ext cx="2514600" cy="365760"/>
+          </a:xfrm>
+          <a:prstGeom prst="rect">
+            <a:avLst/>
+          </a:prstGeom>
+          <a:noFill/>
+        </p:spPr>
+        <p:txBody>
+          <a:bodyPr wrap="square" anchor="t" lIns="0" rIns="0" tIns="0" bIns="0">
+            <a:spAutoFit/>
+          </a:bodyPr>
+          <a:lstStyle/>
+          <a:p>
+            <a:pPr algn="ctr"/>
+            <a:r>
+              <a:rPr sz="1400" b="1">
+                <a:solidFill>
+                  <a:srgbClr val="38BDF8"/>
+                </a:solidFill>
+                <a:latin typeface="Arial"/>
+              </a:rPr>
+              <a:t>Aug 19</a:t>
+            </a:r>
+          </a:p>
+        </p:txBody>
+      </p:sp>
+      <p:sp>
+        <p:nvSpPr>
+          <p:cNvPr id="24" name="Oval 23"/>
+          <p:cNvSpPr/>
+          <p:nvPr/>
+        </p:nvSpPr>
+        <p:spPr>
+          <a:xfrm>
+            <a:off x="10040112" y="3227832"/>
+            <a:ext cx="310896" cy="310896"/>
+          </a:xfrm>
+          <a:prstGeom prst="ellipse">
+            <a:avLst/>
+          </a:prstGeom>
+          <a:solidFill>
+            <a:srgbClr val="38BDF8"/>
+          </a:solidFill>
+          <a:ln>
+            <a:noFill/>
+          </a:ln>
+          <a:effectLst/>
+        </p:spPr>
+        <p:style>
+          <a:lnRef idx="1">
+            <a:schemeClr val="accent1"/>
+          </a:lnRef>
+          <a:fillRef idx="3">
+            <a:schemeClr val="accent1"/>
+          </a:fillRef>
+          <a:effectRef idx="2">
+            <a:schemeClr val="accent1"/>
+          </a:effectRef>
+          <a:fontRef idx="minor">
+            <a:schemeClr val="lt1"/>
+          </a:fontRef>
+        </p:style>
+        <p:txBody>
+          <a:bodyPr rtlCol="0" anchor="ctr"/>
+          <a:lstStyle/>
+          <a:p>
+            <a:pPr algn="ctr"/>
+          </a:p>
+        </p:txBody>
+      </p:sp>
+      <p:sp>
+        <p:nvSpPr>
+          <p:cNvPr id="25" name="Oval 24"/>
+          <p:cNvSpPr/>
+          <p:nvPr/>
+        </p:nvSpPr>
+        <p:spPr>
+          <a:xfrm>
+            <a:off x="10149840" y="3337560"/>
+            <a:ext cx="91440" cy="91440"/>
+          </a:xfrm>
+          <a:prstGeom prst="ellipse">
+            <a:avLst/>
+          </a:prstGeom>
+          <a:solidFill>
+            <a:srgbClr val="0F172A"/>
+          </a:solidFill>
+          <a:ln>
+            <a:noFill/>
+          </a:ln>
+          <a:effectLst/>
+        </p:spPr>
+        <p:style>
+          <a:lnRef idx="1">
+            <a:schemeClr val="accent1"/>
+          </a:lnRef>
+          <a:fillRef idx="3">
+            <a:schemeClr val="accent1"/>
+          </a:fillRef>
+          <a:effectRef idx="2">
+            <a:schemeClr val="accent1"/>
+          </a:effectRef>
+          <a:fontRef idx="minor">
+            <a:schemeClr val="lt1"/>
+          </a:fontRef>
+        </p:style>
+        <p:txBody>
+          <a:bodyPr rtlCol="0" anchor="ctr"/>
+          <a:lstStyle/>
+          <a:p>
+            <a:pPr algn="ctr"/>
+          </a:p>
+        </p:txBody>
+      </p:sp>
+      <p:sp>
+        <p:nvSpPr>
+          <p:cNvPr id="26" name="TextBox 25"/>
+          <p:cNvSpPr txBox="1"/>
+          <p:nvPr/>
+        </p:nvSpPr>
+        <p:spPr>
+          <a:xfrm>
+            <a:off x="8938260" y="3767328"/>
+            <a:ext cx="2514600" cy="502920"/>
+          </a:xfrm>
+          <a:prstGeom prst="rect">
+            <a:avLst/>
+          </a:prstGeom>
+          <a:noFill/>
+        </p:spPr>
+        <p:txBody>
+          <a:bodyPr wrap="square" anchor="t" lIns="0" rIns="0" tIns="0" bIns="0">
+            <a:spAutoFit/>
+          </a:bodyPr>
+          <a:lstStyle/>
+          <a:p>
+            <a:pPr algn="ctr"/>
+            <a:r>
+              <a:rPr sz="1600" b="1">
+                <a:solidFill>
+                  <a:srgbClr val="F8FAFC"/>
+                </a:solidFill>
+                <a:latin typeface="Arial"/>
+              </a:rPr>
+              <a:t>Status dashboard</a:t>
+            </a:r>
+          </a:p>
+        </p:txBody>
+      </p:sp>
+      <p:sp>
+        <p:nvSpPr>
+          <p:cNvPr id="27" name="TextBox 26"/>
+          <p:cNvSpPr txBox="1"/>
+          <p:nvPr/>
+        </p:nvSpPr>
+        <p:spPr>
+          <a:xfrm>
+            <a:off x="8938260" y="4343400"/>
+            <a:ext cx="2514600" cy="1463040"/>
+          </a:xfrm>
+          <a:prstGeom prst="rect">
+            <a:avLst/>
+          </a:prstGeom>
+          <a:noFill/>
+        </p:spPr>
+        <p:txBody>
+          <a:bodyPr wrap="square" anchor="t" lIns="0" rIns="0" tIns="0" bIns="0">
+            <a:spAutoFit/>
+          </a:bodyPr>
+          <a:lstStyle/>
+          <a:p>
+            <a:pPr algn="ctr"/>
+            <a:r>
+              <a:rPr sz="1250" b="0">
+                <a:solidFill>
+                  <a:srgbClr val="94A3B8"/>
+                </a:solidFill>
+                <a:latin typeface="Arial"/>
+              </a:rPr>
+              <a:t>Live campaign view, parked answers inline, mobile-ready. CHANGELOG + v0.1.0 tag.</a:t>
+            </a:r>
+          </a:p>
+        </p:txBody>
+      </p:sp>
+      <p:sp>
+        <p:nvSpPr>
+          <p:cNvPr id="28" name="TextBox 27"/>
+          <p:cNvSpPr txBox="1"/>
+          <p:nvPr/>
+        </p:nvSpPr>
+        <p:spPr>
+          <a:xfrm>
+            <a:off x="640080" y="6419088"/>
+            <a:ext cx="7315200" cy="274320"/>
+          </a:xfrm>
+          <a:prstGeom prst="rect">
+            <a:avLst/>
+          </a:prstGeom>
+          <a:noFill/>
+        </p:spPr>
+        <p:txBody>
+          <a:bodyPr wrap="square" anchor="t" lIns="0" rIns="0" tIns="0" bIns="0">
+            <a:spAutoFit/>
+          </a:bodyPr>
+          <a:lstStyle/>
+          <a:p>
+            <a:pPr algn="l"/>
+            <a:r>
+              <a:rPr sz="1000" b="0">
+                <a:solidFill>
+                  <a:srgbClr val="94A3B8"/>
+                </a:solidFill>
+                <a:latin typeface="Consolas"/>
+              </a:rPr>
+              <a:t>sandcastle-tdd</a:t>
+            </a:r>
+          </a:p>
+        </p:txBody>
+      </p:sp>
+      <p:sp>
+        <p:nvSpPr>
+          <p:cNvPr id="29" name="TextBox 28"/>
+          <p:cNvSpPr txBox="1"/>
+          <p:nvPr/>
+        </p:nvSpPr>
+        <p:spPr>
+          <a:xfrm>
+            <a:off x="10881360" y="6419088"/>
+            <a:ext cx="822960" cy="274320"/>
+          </a:xfrm>
+          <a:prstGeom prst="rect">
+            <a:avLst/>
+          </a:prstGeom>
+          <a:noFill/>
+        </p:spPr>
+        <p:txBody>
+          <a:bodyPr wrap="square" anchor="t" lIns="0" rIns="0" tIns="0" bIns="0">
+            <a:spAutoFit/>
+          </a:bodyPr>
+          <a:lstStyle/>
+          <a:p>
+            <a:pPr algn="r"/>
+            <a:r>
+              <a:rPr sz="1000" b="0">
+                <a:solidFill>
+                  <a:srgbClr val="94A3B8"/>
+                </a:solidFill>
+                <a:latin typeface="Arial"/>
+              </a:rPr>
+              <a:t>11</a:t>
             </a:r>
           </a:p>
         </p:txBody>

</xml_diff>